<commit_message>
feat(restitution): TED-style CXO deck with hero/stat/quote/persona layouts
Extend Restitution01 with an impactful TED-talk-style rework:

- New Pillow-based asset generator (Restitution01/build/gen_assets.py) producing 19 procedural PNGs (hero gradients, persona tiles, EU map, stat cards, EU lock) under Restitution01/assets/.

- Build script supports 6 render modes via a 'Render:' directive: hero, stat, quote, image, persona, cards (default). Adds full-bleed image backdrops, monumental typography, and persona portrait strips.

- Slides 01, 03, 04, 05, 06, 07, 21 rewritten as hero / stat / quote / persona to anchor the narrative; appendices stay as dense cards.

- 38 slides rebuilt (2.49 MB).

Co-authored-by: Copilot <223556219+Copilot@users.noreply.github.com>
</commit_message>
<xml_diff>
--- a/Restitution01/build/LearnEU-CXO-Restitution.pptx
+++ b/Restitution01/build/LearnEU-CXO-Restitution.pptx
@@ -898,7 +898,7 @@
           <a:lstStyle/>
           <a:p>
             <a:r>
-              <a:t>Bonjour. Vingt slides, sept minutes de démo, et une banque d'annexes pour vos questions. Mon objectif : vous prouver en trente minutes que les quatre engagements du board — réduire l'écart de résultats de 26 %, libérer 45 % du temps administratif enseignant, passer la localisation de 12 mois à 6 semaines, et maintenir 100 % de conformité GDPR Article 8 — sont **simultanément** tenables. Pas une maquette : une slice réellement déployée sur Azure West Europe.</a:t>
+              <a:t>Bonjour. 4,1 millions d'enfants nous regardent — c'est le seul chiffre qui compte. En vingt slides et sept minutes de démo, je vous montre comment on tient *trois* promesses qu'on entend toujours opposer : personnaliser, protéger la vie privée des mineurs, et rester européen de bout en bout. Pas un slideware : une slice réellement déployée sur Azure West Europe.</a:t>
             </a:r>
           </a:p>
           <a:p/>
@@ -914,7 +914,7 @@
           </a:p>
           <a:p>
             <a:r>
-              <a:t>Visual: LearnEU mark on dark navy; subtle EU stars; "Personalised. Private. European." tagline.</a:t>
+              <a:t>Visual: Full-bleed navy gradient with soft orange/teal orbs. Single huge headline, italic sub.</a:t>
             </a:r>
           </a:p>
           <a:p>
@@ -2101,7 +2101,7 @@
           <a:lstStyle/>
           <a:p>
             <a:r>
-              <a:t>Pour terminer : trois décisions à prendre aujourd'hui. Un — mandater les DPIA dans les cinq pays, ça débloque la Phase 0. Deux — libérer 3,5 millions pour la Phase 0 (landing zone Azure, DPIA, squelette Annex IV) ; le reste du budget sera ré-engagé au gate suivant, pas avant. Trois — nommer le président du Conseil RAI au prochain comité de pilotage, c'est une décision RH qui ne peut pas attendre. Et deux endossements implicites : le contrat de KPI tel qu'écrit, et la séquence NL puis DE, les trois marchés suivants étant tranchés au gate du mois 10 en fonction de la traction ministérielle. Merci.</a:t>
+              <a:t>Trois décisions. Un — mandater les DPIA dans les cinq pays, ça débloque la Phase 0. Deux — libérer 3,5 millions pour la Phase 0. Trois — nommer le président du Conseil RAI au prochain comité. Le reste du budget sera ré-engagé au gate suivant, pas avant. Merci.</a:t>
             </a:r>
           </a:p>
           <a:p/>
@@ -2117,7 +2117,7 @@
           </a:p>
           <a:p>
             <a:r>
-              <a:t>Visual: Three large numbered chips: "1 — Mandate", "2 — Budget", "3 — Chair". LearnEU logo bottom-right with tagline "Personalised. Private. European."</a:t>
+              <a:t>Visual: Hero orange. Single line, monumental: "Three decisions. Today." Tagline: "Personalised. Private. European."</a:t>
             </a:r>
           </a:p>
           <a:p>
@@ -2920,7 +2920,7 @@
           <a:lstStyle/>
           <a:p>
             <a:r>
-              <a:t>Trois manières de regarder le problème. Côté apprenant : 40 % d'écart de résultats pour exactement le même contenu — c'est un échec de personnalisation, pas de pédagogie. Côté enseignant : un tiers du temps perdu sur de la correction qui n'apporte rien à la relation. Côté marché : 8 à 12 mois pour entrer dans un pays, c'est-à-dire qu'on arrive après les compétiteurs qui ont commencé leurs pilotes IA. Et ce problème ne se règle pas par "plus d'IA générique" : GDPR Article 8 et l'EU AI Act haut-risque imposent un cadre que la plupart des solutions du marché ne respectent pas. C'est notre fenêtre.</a:t>
+              <a:t>Quarante points d'écart entre nos meilleures et nos moins bonnes écoles — sur exactement le même contenu. Ce n'est pas un problème de qualité du contenu. C'est un problème de livraison : la même phrase rencontre un enfant prêt à l'entendre dans une école, et un enfant pas prêt dans l'autre. La personnalisation, c'est précisément refuser cette fatalité.</a:t>
             </a:r>
           </a:p>
           <a:p/>
@@ -2932,11 +2932,6 @@
           <a:p>
             <a:r>
               <a:t>CXO focus: CEO · COO · CMO</a:t>
-            </a:r>
-          </a:p>
-          <a:p>
-            <a:r>
-              <a:t>Visual: Left: 4 stat tiles. Right: trend arrow showing widening outcome gap + competitor heat-map of EU pilots.</a:t>
             </a:r>
           </a:p>
           <a:p>
@@ -3830,7 +3825,7 @@
           <a:lstStyle/>
           <a:p>
             <a:r>
-              <a:t>Notre thèse stratégique tient en une phrase : à partir de 2027, les ministères de l'Éducation des Vingt-Sept n'achèteront plus que de l'IA pédagogique conforme à l'AI Act et résidente en UE. Aujourd'hui, personne ne coche les deux cases. Les incumbents américains ont la profondeur de personnalisation mais pas la posture européenne ; les éditeurs européens historiques ont la confiance mais pas l'IA. La fenêtre est de 18 à 24 mois. Cela explique pourquoi on investit lourdement dès la Phase 0 sur la conformité — pas par prudence, mais par stratégie commerciale. Le dossier Annex IV est un asset de vente.</a:t>
+              <a:t>Notre thèse en une phrase. À partir de 2027, les ministères européens n'achèteront que de l'IA éducative résidente UE et conforme à l'AI Act. Aujourd'hui, personne ne coche les deux cases. La conformité n'est pas un coût : c'est l'asset de vente. Fenêtre : 18 à 24 mois.</a:t>
             </a:r>
           </a:p>
           <a:p/>
@@ -3842,11 +3837,6 @@
           <a:p>
             <a:r>
               <a:t>CXO focus: CEO · CSO · CAIO</a:t>
-            </a:r>
-          </a:p>
-          <a:p>
-            <a:r>
-              <a:t>Visual: 2×2 strategic positioning matrix: axes = "EU-compliance posture" × "Personalisation depth". LearnEU isolated top-right; US/UK incumbents bottom-right; legacy EU publishers top-left.</a:t>
             </a:r>
           </a:p>
           <a:p>
@@ -3921,7 +3911,7 @@
           <a:lstStyle/>
           <a:p>
             <a:r>
-              <a:t>On a refusé d'inventer nos propres KPI. Les cinq cibles sont tirées mot pour mot du case study. Ce qui change, c'est qu'on s'engage à prouver la trajectoire **chaque mois**, pas à la fin du programme. Chaque KPI a un *leading indicator* instrumenté en production : la disparité de fairness par cohorte sort dans Application Insights, le temps gagné par enseignant est mesuré côté Assessment AI, la cadence de localisation est un compteur dans le pipeline Fabric. Voir plan/05-kpis-outcomes.md pour le détail par workstream.</a:t>
+              <a:t>Quatre chiffres tirés mot pour mot du case study. Moins 26 % d'écart de résultats. Moins 45 % de temps administratif enseignant. Localisation passée de 12 mois à 6 semaines. Et 100 % de conformité GDPR Article 8, en permanence. Pas de chiffre inventé pour le board. Et chaque mois, je rapporte la trajectoire — pas seulement en fin de programme.</a:t>
             </a:r>
           </a:p>
           <a:p/>
@@ -3933,11 +3923,6 @@
           <a:p>
             <a:r>
               <a:t>CXO focus: CEO · CFO · COO</a:t>
-            </a:r>
-          </a:p>
-          <a:p>
-            <a:r>
-              <a:t>Visual: Left: 5 KPI tiles, target deltas in orange. Right: monthly review cadence wheel.</a:t>
             </a:r>
           </a:p>
           <a:p>
@@ -4012,7 +3997,7 @@
           <a:lstStyle/>
           <a:p>
             <a:r>
-              <a:t>Sizing conservateur. Le plus gros pool de valeur, c'est la productivité enseignante : 45 % de moins sur l'administratif, sur environ 120 000 enseignants, valorisé à 15 € de l'heure, ça fait grossièrement 28 millions par an. Ajoutez 18 millions d'ARR incrémentale liée à l'entrée plus rapide dans trois marchés, et 9 millions de rétention liée à la baisse de l'écart de résultats. Total : 55 millions par an au régime de croisière. Face à un investissement de 18 à 22 millions, le payback est sous 24 mois sur trois marchés. Point clé pour le CFO : la part conformité est de toute façon obligatoire à partir de 2026, donc la faire dans le programme évite un re-work multi-million plus tard.</a:t>
+              <a:t>Cinquante-cinq millions d'euros de valeur annuelle au régime de croisière, sur trois marchés. Décomposition : 28 millions de productivité enseignante (−45 % d'admin × 120 000 enseignants × 15 € de l'heure), 18 millions d'ARR incrémentale liée à l'entrée plus rapide dans les marchés, 9 millions de rétention liée à la baisse de l'écart de résultats. Face à un investissement de 18 à 22 millions, payback sous 24 mois. Détail dans l'annexe A11.</a:t>
             </a:r>
           </a:p>
           <a:p/>
@@ -4024,11 +4009,6 @@
           <a:p>
             <a:r>
               <a:t>CXO focus: CFO · CEO</a:t>
-            </a:r>
-          </a:p>
-          <a:p>
-            <a:r>
-              <a:t>Visual: Waterfall: investment → value pools → run-rate. Payback arrow at month 22.</a:t>
             </a:r>
           </a:p>
           <a:p>
@@ -4103,7 +4083,7 @@
           <a:lstStyle/>
           <a:p>
             <a:r>
-              <a:t>On résume l'expérience produit en trois personas. L'apprenant gagne un contenu calibré (probabilité de réussite visée environ 0,7, c'est la zone de progression maximale d'après les sciences de l'apprentissage). L'enseignant récupère 45 % de son temps administratif, mais surtout garde la main : chaque suggestion IA est explicable et révocable en un clic. Le parent obtient un portail dans sa langue, des contrôles GDPR Article 8 explicites, et la garantie écrite qu'un humain reste le décideur. On verra les trois en démo dans dix minutes.</a:t>
+              <a:t>Trois personas, trois gains chiffrés. Lucas — un élève de 12 ans en Allemagne — reçoit du contenu calibré sur sa zone de progression maximale. Mr Klein récupère 45 % de son temps administratif et garde la main : chaque suggestion IA est explicable et révocable. Sophie, sa mère, a un portail dans sa langue avec les contrôles GDPR Article 8 en hero. On verra les trois en démo dans dix minutes.</a:t>
             </a:r>
           </a:p>
           <a:p/>
@@ -4119,12 +4099,7 @@
           </a:p>
           <a:p>
             <a:r>
-              <a:t>Visual: 3 persona cards (Learner / Teacher / Parent), each with a "before → after" arrow and one quantified win.</a:t>
-            </a:r>
-          </a:p>
-          <a:p>
-            <a:r>
-              <a:t>Source refs: demo/DEMO-STORYTELLING.md · plan/02-workstreams.md</a:t>
+              <a:t>Source refs: demo/DEMO-STORYTELLING.md</a:t>
             </a:r>
           </a:p>
         </p:txBody>
@@ -20445,28 +20420,43 @@
         <p:txBody>
           <a:bodyPr/>
           <a:lstStyle/>
-          <a:p>
-            <a:r>
-              <a:rPr>
-                <a:solidFill>
-                  <a:srgbClr val="FFFFFF"/>
-                </a:solidFill>
-              </a:rPr>
-              <a:t>LearnEU — Personalised learning, on contract</a:t>
-            </a:r>
-          </a:p>
+          <a:p/>
         </p:txBody>
       </p:sp>
-      <p:sp>
-        <p:nvSpPr>
-          <p:cNvPr id="3" name="TextBox 2"/>
+      <p:pic>
+        <p:nvPicPr>
+          <p:cNvPr id="3" name="Picture 2" descr="bg-hero-navy.png"/>
+          <p:cNvPicPr>
+            <a:picLocks noChangeAspect="1"/>
+          </p:cNvPicPr>
+          <p:nvPr/>
+        </p:nvPicPr>
+        <p:blipFill>
+          <a:blip r:embed="rId2"/>
+          <a:stretch>
+            <a:fillRect/>
+          </a:stretch>
+        </p:blipFill>
+        <p:spPr>
+          <a:xfrm>
+            <a:off x="0" y="0"/>
+            <a:ext cx="12192000" cy="6858000"/>
+          </a:xfrm>
+          <a:prstGeom prst="rect">
+            <a:avLst/>
+          </a:prstGeom>
+        </p:spPr>
+      </p:pic>
+      <p:sp>
+        <p:nvSpPr>
+          <p:cNvPr id="4" name="TextBox 3"/>
           <p:cNvSpPr txBox="1"/>
           <p:nvPr/>
         </p:nvSpPr>
         <p:spPr>
           <a:xfrm>
-            <a:off x="640000" y="2900000"/>
-            <a:ext cx="10912000" cy="1400000"/>
+            <a:off x="600000" y="2300000"/>
+            <a:ext cx="10992000" cy="2100000"/>
           </a:xfrm>
           <a:prstGeom prst="rect">
             <a:avLst/>
@@ -20474,52 +20464,53 @@
           <a:noFill/>
         </p:spPr>
         <p:txBody>
-          <a:bodyPr wrap="square" lIns="120000" rIns="120000" tIns="80000" bIns="80000">
+          <a:bodyPr wrap="square">
             <a:spAutoFit/>
           </a:bodyPr>
           <a:lstStyle/>
           <a:p>
-            <a:pPr/>
-            <a:r>
-              <a:rPr sz="2200" b="0">
+            <a:pPr algn="ctr"/>
+            <a:r>
+              <a:rPr sz="7200" b="1" i="0">
+                <a:solidFill>
+                  <a:srgbClr val="FFFFFF"/>
+                </a:solidFill>
+              </a:rPr>
+              <a:t>4.1 million kids. One promise.</a:t>
+            </a:r>
+          </a:p>
+        </p:txBody>
+      </p:sp>
+      <p:sp>
+        <p:nvSpPr>
+          <p:cNvPr id="5" name="TextBox 4"/>
+          <p:cNvSpPr txBox="1"/>
+          <p:nvPr/>
+        </p:nvSpPr>
+        <p:spPr>
+          <a:xfrm>
+            <a:off x="600000" y="4400000"/>
+            <a:ext cx="10992000" cy="700000"/>
+          </a:xfrm>
+          <a:prstGeom prst="rect">
+            <a:avLst/>
+          </a:prstGeom>
+          <a:noFill/>
+        </p:spPr>
+        <p:txBody>
+          <a:bodyPr wrap="square">
+            <a:spAutoFit/>
+          </a:bodyPr>
+          <a:lstStyle/>
+          <a:p>
+            <a:pPr algn="ctr"/>
+            <a:r>
+              <a:rPr sz="2600" b="0" i="1">
                 <a:solidFill>
                   <a:srgbClr val="C8D4E6"/>
                 </a:solidFill>
               </a:rPr>
-              <a:t>AMA Case Study 33 · 4.1M learners · 5 EU markets · CXO restitution</a:t>
-            </a:r>
-          </a:p>
-          <a:p>
-            <a:pPr/>
-            <a:r>
-              <a:rPr sz="1600" b="0">
-                <a:solidFill>
-                  <a:srgbClr val="FFFFFF"/>
-                </a:solidFill>
-              </a:rPr>
-              <a:t>Azure Master Architect — board-level restitution</a:t>
-            </a:r>
-          </a:p>
-          <a:p>
-            <a:pPr/>
-            <a:r>
-              <a:rPr sz="1600" b="0">
-                <a:solidFill>
-                  <a:srgbClr val="FFFFFF"/>
-                </a:solidFill>
-              </a:rPr>
-              <a:t>Outcome contract: −26% gap · −45% admin · 12mo → 6wk · 100% GDPR Art. 8</a:t>
-            </a:r>
-          </a:p>
-          <a:p>
-            <a:pPr/>
-            <a:r>
-              <a:rPr sz="1600" b="0">
-                <a:solidFill>
-                  <a:srgbClr val="FFFFFF"/>
-                </a:solidFill>
-              </a:rPr>
-              <a:t>Live demo at slide 17 on rg-learneu-demo (West Europe)</a:t>
+              <a:t>Personalised. Private. European.</a:t>
             </a:r>
           </a:p>
         </p:txBody>
@@ -23777,14 +23768,55 @@
       <p:grpSpPr/>
       <p:sp>
         <p:nvSpPr>
-          <p:cNvPr id="2" name="TextBox 1"/>
+          <p:cNvPr id="2" name="Title 1"/>
+          <p:cNvSpPr>
+            <a:spLocks noGrp="1"/>
+          </p:cNvSpPr>
+          <p:nvPr>
+            <p:ph type="title"/>
+          </p:nvPr>
+        </p:nvSpPr>
+        <p:spPr/>
+        <p:txBody>
+          <a:bodyPr/>
+          <a:lstStyle/>
+          <a:p/>
+        </p:txBody>
+      </p:sp>
+      <p:pic>
+        <p:nvPicPr>
+          <p:cNvPr id="3" name="Picture 2" descr="bg-hero-orange.png"/>
+          <p:cNvPicPr>
+            <a:picLocks noChangeAspect="1"/>
+          </p:cNvPicPr>
+          <p:nvPr/>
+        </p:nvPicPr>
+        <p:blipFill>
+          <a:blip r:embed="rId2"/>
+          <a:stretch>
+            <a:fillRect/>
+          </a:stretch>
+        </p:blipFill>
+        <p:spPr>
+          <a:xfrm>
+            <a:off x="0" y="0"/>
+            <a:ext cx="12192000" cy="6858000"/>
+          </a:xfrm>
+          <a:prstGeom prst="rect">
+            <a:avLst/>
+          </a:prstGeom>
+        </p:spPr>
+      </p:pic>
+      <p:sp>
+        <p:nvSpPr>
+          <p:cNvPr id="4" name="TextBox 3"/>
           <p:cNvSpPr txBox="1"/>
           <p:nvPr/>
         </p:nvSpPr>
         <p:spPr>
           <a:xfrm>
-            <a:off x="640000" y="900000"/>
-            <a:ext cx="10912000" cy="900000"/>
+            <a:off x="600000" y="2300000"/>
+            <a:ext cx="10992000" cy="2100000"/>
           </a:xfrm>
           <a:prstGeom prst="rect">
             <a:avLst/>
@@ -23797,27 +23829,28 @@
           </a:bodyPr>
           <a:lstStyle/>
           <a:p>
-            <a:r>
-              <a:rPr sz="4000" b="1">
+            <a:pPr algn="ctr"/>
+            <a:r>
+              <a:rPr sz="7200" b="1" i="0">
                 <a:solidFill>
                   <a:srgbClr val="FFFFFF"/>
                 </a:solidFill>
               </a:rPr>
-              <a:t>Three decisions, today</a:t>
+              <a:t>Three decisions. Today.</a:t>
             </a:r>
           </a:p>
         </p:txBody>
       </p:sp>
       <p:sp>
         <p:nvSpPr>
-          <p:cNvPr id="3" name="TextBox 2"/>
+          <p:cNvPr id="5" name="TextBox 4"/>
           <p:cNvSpPr txBox="1"/>
           <p:nvPr/>
         </p:nvSpPr>
         <p:spPr>
           <a:xfrm>
-            <a:off x="640000" y="1900000"/>
-            <a:ext cx="10912000" cy="500000"/>
+            <a:off x="600000" y="4400000"/>
+            <a:ext cx="10992000" cy="700000"/>
           </a:xfrm>
           <a:prstGeom prst="rect">
             <a:avLst/>
@@ -23825,127 +23858,19 @@
           <a:noFill/>
         </p:spPr>
         <p:txBody>
-          <a:bodyPr wrap="none">
+          <a:bodyPr wrap="square">
             <a:spAutoFit/>
           </a:bodyPr>
           <a:lstStyle/>
           <a:p>
-            <a:r>
-              <a:rPr sz="2000" i="1">
+            <a:pPr algn="ctr"/>
+            <a:r>
+              <a:rPr sz="2600" b="0" i="1">
                 <a:solidFill>
                   <a:srgbClr val="C8D4E6"/>
                 </a:solidFill>
               </a:rPr>
-              <a:t>DPIA mandate · P0 budget · RAI Council chair</a:t>
-            </a:r>
-          </a:p>
-        </p:txBody>
-      </p:sp>
-      <p:sp>
-        <p:nvSpPr>
-          <p:cNvPr id="4" name="Rounded Rectangle 3"/>
-          <p:cNvSpPr/>
-          <p:nvPr/>
-        </p:nvSpPr>
-        <p:spPr>
-          <a:xfrm>
-            <a:off x="900000" y="2600000"/>
-            <a:ext cx="10392000" cy="3558000"/>
-          </a:xfrm>
-          <a:prstGeom prst="roundRect">
-            <a:avLst/>
-          </a:prstGeom>
-          <a:solidFill>
-            <a:srgbClr val="122A4A"/>
-          </a:solidFill>
-          <a:ln w="12700">
-            <a:solidFill>
-              <a:srgbClr val="2A4A78"/>
-            </a:solidFill>
-          </a:ln>
-          <a:effectLst/>
-        </p:spPr>
-        <p:style>
-          <a:lnRef idx="1">
-            <a:schemeClr val="accent1"/>
-          </a:lnRef>
-          <a:fillRef idx="3">
-            <a:schemeClr val="accent1"/>
-          </a:fillRef>
-          <a:effectRef idx="2">
-            <a:schemeClr val="accent1"/>
-          </a:effectRef>
-          <a:fontRef idx="minor">
-            <a:schemeClr val="lt1"/>
-          </a:fontRef>
-        </p:style>
-        <p:txBody>
-          <a:bodyPr rtlCol="0" anchor="t" wrap="square" lIns="120000" rIns="120000" tIns="80000" bIns="80000"/>
-          <a:lstStyle/>
-          <a:p>
-            <a:pPr algn="ctr"/>
-            <a:r>
-              <a:rPr sz="1600" b="1">
-                <a:solidFill>
-                  <a:srgbClr val="F28C00"/>
-                </a:solidFill>
-              </a:rPr>
-              <a:t>WHAT WE ASK OF THE BOARD</a:t>
-            </a:r>
-          </a:p>
-          <a:p>
-            <a:pPr/>
-            <a:r>
-              <a:rPr sz="1800" b="0">
-                <a:solidFill>
-                  <a:srgbClr val="FFFFFF"/>
-                </a:solidFill>
-              </a:rPr>
-              <a:t>• 1 · Approve the DPIA mandate across NL/BE/DE/PL/RO — enables Phase 0</a:t>
-            </a:r>
-          </a:p>
-          <a:p>
-            <a:pPr/>
-            <a:r>
-              <a:rPr sz="1800" b="0">
-                <a:solidFill>
-                  <a:srgbClr val="FFFFFF"/>
-                </a:solidFill>
-              </a:rPr>
-              <a:t>• 2 · Release €3.5M for Phase 0 (M0–M2) — landing zone + DPIAs + Annex IV skeleton</a:t>
-            </a:r>
-          </a:p>
-          <a:p>
-            <a:pPr/>
-            <a:r>
-              <a:rPr sz="1800" b="0">
-                <a:solidFill>
-                  <a:srgbClr val="FFFFFF"/>
-                </a:solidFill>
-              </a:rPr>
-              <a:t>• 3 · Name the Responsible AI Council chair — by next steering committee</a:t>
-            </a:r>
-          </a:p>
-          <a:p>
-            <a:pPr/>
-            <a:r>
-              <a:rPr sz="1800" b="0">
-                <a:solidFill>
-                  <a:srgbClr val="FFFFFF"/>
-                </a:solidFill>
-              </a:rPr>
-              <a:t>• 4 · Endorse the outcome contract as KPI-bound (board scorecard, monthly)</a:t>
-            </a:r>
-          </a:p>
-          <a:p>
-            <a:pPr/>
-            <a:r>
-              <a:rPr sz="1800" b="0">
-                <a:solidFill>
-                  <a:srgbClr val="FFFFFF"/>
-                </a:solidFill>
-              </a:rPr>
-              <a:t>• 5 · Confirm NL → DE sequencing; defer markets 3–5 to month 10 gate</a:t>
+              <a:t>Mandate · Budget · Chair</a:t>
             </a:r>
           </a:p>
         </p:txBody>
@@ -26199,6 +26124,133 @@
         <p:txBody>
           <a:bodyPr/>
           <a:lstStyle/>
+          <a:p/>
+        </p:txBody>
+      </p:sp>
+      <p:pic>
+        <p:nvPicPr>
+          <p:cNvPr id="3" name="Picture 2" descr="stat-gap.png"/>
+          <p:cNvPicPr>
+            <a:picLocks noChangeAspect="1"/>
+          </p:cNvPicPr>
+          <p:nvPr/>
+        </p:nvPicPr>
+        <p:blipFill>
+          <a:blip r:embed="rId2"/>
+          <a:stretch>
+            <a:fillRect/>
+          </a:stretch>
+        </p:blipFill>
+        <p:spPr>
+          <a:xfrm>
+            <a:off x="0" y="0"/>
+            <a:ext cx="12192000" cy="6858000"/>
+          </a:xfrm>
+          <a:prstGeom prst="rect">
+            <a:avLst/>
+          </a:prstGeom>
+        </p:spPr>
+      </p:pic>
+      <p:sp>
+        <p:nvSpPr>
+          <p:cNvPr id="4" name="TextBox 3"/>
+          <p:cNvSpPr txBox="1"/>
+          <p:nvPr/>
+        </p:nvSpPr>
+        <p:spPr>
+          <a:xfrm>
+            <a:off x="600000" y="360000"/>
+            <a:ext cx="10992000" cy="540000"/>
+          </a:xfrm>
+          <a:prstGeom prst="rect">
+            <a:avLst/>
+          </a:prstGeom>
+          <a:noFill/>
+        </p:spPr>
+        <p:txBody>
+          <a:bodyPr wrap="square">
+            <a:spAutoFit/>
+          </a:bodyPr>
+          <a:lstStyle/>
+          <a:p>
+            <a:pPr algn="ctr"/>
+            <a:r>
+              <a:rPr sz="3000" b="1" i="0">
+                <a:solidFill>
+                  <a:srgbClr val="FFFFFF"/>
+                </a:solidFill>
+              </a:rPr>
+              <a:t>Same content. Different kids. 40-point gap.</a:t>
+            </a:r>
+          </a:p>
+        </p:txBody>
+      </p:sp>
+      <p:sp>
+        <p:nvSpPr>
+          <p:cNvPr id="5" name="TextBox 4"/>
+          <p:cNvSpPr txBox="1"/>
+          <p:nvPr/>
+        </p:nvSpPr>
+        <p:spPr>
+          <a:xfrm>
+            <a:off x="600000" y="5900000"/>
+            <a:ext cx="10992000" cy="540000"/>
+          </a:xfrm>
+          <a:prstGeom prst="rect">
+            <a:avLst/>
+          </a:prstGeom>
+          <a:noFill/>
+        </p:spPr>
+        <p:txBody>
+          <a:bodyPr wrap="square">
+            <a:spAutoFit/>
+          </a:bodyPr>
+          <a:lstStyle/>
+          <a:p>
+            <a:pPr algn="ctr"/>
+            <a:r>
+              <a:rPr sz="2200" b="0" i="1">
+                <a:solidFill>
+                  <a:srgbClr val="C8D4E6"/>
+                </a:solidFill>
+              </a:rPr>
+              <a:t>That gap is not a content problem. It's a delivery problem.</a:t>
+            </a:r>
+          </a:p>
+        </p:txBody>
+      </p:sp>
+    </p:spTree>
+  </p:cSld>
+  <p:clrMapOvr>
+    <a:masterClrMapping/>
+  </p:clrMapOvr>
+</p:sld>
+</file>
+
+<file path=ppt/slides/slide30.xml><?xml version="1.0" encoding="utf-8"?>
+<p:sld xmlns:a="http://schemas.openxmlformats.org/drawingml/2006/main" xmlns:p="http://schemas.openxmlformats.org/presentationml/2006/main" xmlns:r="http://schemas.openxmlformats.org/officeDocument/2006/relationships">
+  <p:cSld>
+    <p:spTree>
+      <p:nvGrpSpPr>
+        <p:cNvPr id="1" name=""/>
+        <p:cNvGrpSpPr/>
+        <p:nvPr/>
+      </p:nvGrpSpPr>
+      <p:grpSpPr/>
+      <p:sp>
+        <p:nvSpPr>
+          <p:cNvPr id="2" name="Title 1"/>
+          <p:cNvSpPr>
+            <a:spLocks noGrp="1"/>
+          </p:cNvSpPr>
+          <p:nvPr>
+            <p:ph type="title"/>
+          </p:nvPr>
+        </p:nvSpPr>
+        <p:spPr/>
+        <p:txBody>
+          <a:bodyPr/>
+          <a:lstStyle/>
           <a:p>
             <a:r>
               <a:rPr>
@@ -26206,7 +26258,7 @@
                   <a:srgbClr val="FFFFFF"/>
                 </a:solidFill>
               </a:rPr>
-              <a:t>The cost of doing nothing is bigger than the cost of doing it right</a:t>
+              <a:t>A9 · App Insights + immutable audit = AI Act Art. 12 ready</a:t>
             </a:r>
           </a:p>
         </p:txBody>
@@ -26239,7 +26291,7 @@
                   <a:srgbClr val="C8D4E6"/>
                 </a:solidFill>
               </a:rPr>
-              <a:t>4 facts, 5 markets, 1 widening gap</a:t>
+              <a:t>Every AI decision logged, queryable, defensible</a:t>
             </a:r>
           </a:p>
         </p:txBody>
@@ -26293,7 +26345,7 @@
                   <a:srgbClr val="F28C00"/>
                 </a:solidFill>
               </a:rPr>
-              <a:t>THE FACTS TODAY</a:t>
+              <a:t>TELEMETRY</a:t>
             </a:r>
           </a:p>
           <a:p>
@@ -26304,7 +26356,7 @@
                   <a:srgbClr val="FFFFFF"/>
                 </a:solidFill>
               </a:rPr>
-              <a:t>• 4.1M learners across NL · BE · DE · PL · RO on identical content</a:t>
+              <a:t>• Application Insights per surface (Teacher · Learner · Parent · Admin)</a:t>
             </a:r>
           </a:p>
           <a:p>
@@ -26315,7 +26367,7 @@
                   <a:srgbClr val="FFFFFF"/>
                 </a:solidFill>
               </a:rPr>
-              <a:t>• Outcome gap between top and bottom schools: up to 40%</a:t>
+              <a:t>• Custom events: ai_decision, override, content_safety_block, erasure_request</a:t>
             </a:r>
           </a:p>
           <a:p>
@@ -26326,7 +26378,7 @@
                   <a:srgbClr val="FFFFFF"/>
                 </a:solidFill>
               </a:rPr>
-              <a:t>• 35% of teacher hours lost to administrative grading</a:t>
+              <a:t>• Per-cohort fairness metrics aggregated continuously</a:t>
             </a:r>
           </a:p>
           <a:p>
@@ -26337,7 +26389,7 @@
                   <a:srgbClr val="FFFFFF"/>
                 </a:solidFill>
               </a:rPr>
-              <a:t>• Each market entry costs 8–12 months of localisation cycle</a:t>
+              <a:t>• KQL workbooks for AI Act Art. 12 evidence on demand</a:t>
             </a:r>
           </a:p>
         </p:txBody>
@@ -26391,7 +26443,7 @@
                   <a:srgbClr val="F28C00"/>
                 </a:solidFill>
               </a:rPr>
-              <a:t>WHY IT GETS WORSE</a:t>
+              <a:t>IMMUTABLE AUDIT</a:t>
             </a:r>
           </a:p>
           <a:p>
@@ -26402,7 +26454,7 @@
                   <a:srgbClr val="FFFFFF"/>
                 </a:solidFill>
               </a:rPr>
-              <a:t>• GDPR Art. 8 caps what we can personalise without parental consent</a:t>
+              <a:t>• Azure Blob WORM storage, EU regions, 6-month minimum retention</a:t>
             </a:r>
           </a:p>
           <a:p>
@@ -26413,7 +26465,7 @@
                   <a:srgbClr val="FFFFFF"/>
                 </a:solidFill>
               </a:rPr>
-              <a:t>• EU AI Act now classifies our category as high-risk (Annex III §3)</a:t>
+              <a:t>• Append-only stream of every AI decision + override</a:t>
             </a:r>
           </a:p>
           <a:p>
@@ -26424,7 +26476,7 @@
                   <a:srgbClr val="FFFFFF"/>
                 </a:solidFill>
               </a:rPr>
-              <a:t>• Competitors are already running pilots — first-mover wins ministries</a:t>
+              <a:t>• Tamper-evident hashes; quarterly integrity check</a:t>
             </a:r>
           </a:p>
           <a:p>
@@ -26435,7 +26487,7 @@
                   <a:srgbClr val="FFFFFF"/>
                 </a:solidFill>
               </a:rPr>
-              <a:t>• Teacher attrition rising; admin burden is the #1 cited cause</a:t>
+              <a:t>• Surfaced to RAI Council dashboard + Steering Committee monthly</a:t>
             </a:r>
           </a:p>
         </p:txBody>
@@ -26448,7 +26500,7 @@
 </p:sld>
 </file>
 
-<file path=ppt/slides/slide30.xml><?xml version="1.0" encoding="utf-8"?>
+<file path=ppt/slides/slide31.xml><?xml version="1.0" encoding="utf-8"?>
 <p:sld xmlns:a="http://schemas.openxmlformats.org/drawingml/2006/main" xmlns:p="http://schemas.openxmlformats.org/presentationml/2006/main" xmlns:r="http://schemas.openxmlformats.org/officeDocument/2006/relationships">
   <p:cSld>
     <p:spTree>
@@ -26479,7 +26531,7 @@
                   <a:srgbClr val="FFFFFF"/>
                 </a:solidFill>
               </a:rPr>
-              <a:t>A9 · App Insights + immutable audit = AI Act Art. 12 ready</a:t>
+              <a:t>A10 · SLOs designed for school-day peaks</a:t>
             </a:r>
           </a:p>
         </p:txBody>
@@ -26512,7 +26564,7 @@
                   <a:srgbClr val="C8D4E6"/>
                 </a:solidFill>
               </a:rPr>
-              <a:t>Every AI decision logged, queryable, defensible</a:t>
+              <a:t>Latency, availability, scale — all measured on the wire</a:t>
             </a:r>
           </a:p>
         </p:txBody>
@@ -26566,7 +26618,7 @@
                   <a:srgbClr val="F28C00"/>
                 </a:solidFill>
               </a:rPr>
-              <a:t>TELEMETRY</a:t>
+              <a:t>SLOS</a:t>
             </a:r>
           </a:p>
           <a:p>
@@ -26577,7 +26629,7 @@
                   <a:srgbClr val="FFFFFF"/>
                 </a:solidFill>
               </a:rPr>
-              <a:t>• Application Insights per surface (Teacher · Learner · Parent · Admin)</a:t>
+              <a:t>• API availability: 99.9% (excl. planned maintenance windows out of school hours)</a:t>
             </a:r>
           </a:p>
           <a:p>
@@ -26588,7 +26640,7 @@
                   <a:srgbClr val="FFFFFF"/>
                 </a:solidFill>
               </a:rPr>
-              <a:t>• Custom events: ai_decision, override, content_safety_block, erasure_request</a:t>
+              <a:t>• Adaptive picker p95 latency: ≤ 200 ms (on-device); ≤ 800 ms (fallback)</a:t>
             </a:r>
           </a:p>
           <a:p>
@@ -26599,7 +26651,7 @@
                   <a:srgbClr val="FFFFFF"/>
                 </a:solidFill>
               </a:rPr>
-              <a:t>• Per-cohort fairness metrics aggregated continuously</a:t>
+              <a:t>• Assessment grading p95: ≤ 3 s</a:t>
             </a:r>
           </a:p>
           <a:p>
@@ -26610,7 +26662,7 @@
                   <a:srgbClr val="FFFFFF"/>
                 </a:solidFill>
               </a:rPr>
-              <a:t>• KQL workbooks for AI Act Art. 12 evidence on demand</a:t>
+              <a:t>• Localisation batch: 6-week SLA per market</a:t>
             </a:r>
           </a:p>
         </p:txBody>
@@ -26664,7 +26716,7 @@
                   <a:srgbClr val="F28C00"/>
                 </a:solidFill>
               </a:rPr>
-              <a:t>IMMUTABLE AUDIT</a:t>
+              <a:t>RESILIENCE</a:t>
             </a:r>
           </a:p>
           <a:p>
@@ -26675,7 +26727,7 @@
                   <a:srgbClr val="FFFFFF"/>
                 </a:solidFill>
               </a:rPr>
-              <a:t>• Azure Blob WORM storage, EU regions, 6-month minimum retention</a:t>
+              <a:t>• Multi-region within EU (West Europe ↔ North Europe; DE primary in Germany)</a:t>
             </a:r>
           </a:p>
           <a:p>
@@ -26686,7 +26738,7 @@
                   <a:srgbClr val="FFFFFF"/>
                 </a:solidFill>
               </a:rPr>
-              <a:t>• Append-only stream of every AI decision + override</a:t>
+              <a:t>• DR drill quarterly; RPO ≤ 15 min, RTO ≤ 2 h</a:t>
             </a:r>
           </a:p>
           <a:p>
@@ -26697,7 +26749,7 @@
                   <a:srgbClr val="FFFFFF"/>
                 </a:solidFill>
               </a:rPr>
-              <a:t>• Tamper-evident hashes; quarterly integrity check</a:t>
+              <a:t>• APIM rate-limit per school to prevent noisy-neighbour</a:t>
             </a:r>
           </a:p>
           <a:p>
@@ -26708,7 +26760,7 @@
                   <a:srgbClr val="FFFFFF"/>
                 </a:solidFill>
               </a:rPr>
-              <a:t>• Surfaced to RAI Council dashboard + Steering Committee monthly</a:t>
+              <a:t>• Kill-switch wired per AI feature (sub-5-minute disable)</a:t>
             </a:r>
           </a:p>
         </p:txBody>
@@ -26721,7 +26773,7 @@
 </p:sld>
 </file>
 
-<file path=ppt/slides/slide31.xml><?xml version="1.0" encoding="utf-8"?>
+<file path=ppt/slides/slide32.xml><?xml version="1.0" encoding="utf-8"?>
 <p:sld xmlns:a="http://schemas.openxmlformats.org/drawingml/2006/main" xmlns:p="http://schemas.openxmlformats.org/presentationml/2006/main" xmlns:r="http://schemas.openxmlformats.org/officeDocument/2006/relationships">
   <p:cSld>
     <p:spTree>
@@ -26752,7 +26804,7 @@
                   <a:srgbClr val="FFFFFF"/>
                 </a:solidFill>
               </a:rPr>
-              <a:t>A10 · SLOs designed for school-day peaks</a:t>
+              <a:t>A11 · Cost / learner / month is the FinOps north star</a:t>
             </a:r>
           </a:p>
         </p:txBody>
@@ -26785,7 +26837,7 @@
                   <a:srgbClr val="C8D4E6"/>
                 </a:solidFill>
               </a:rPr>
-              <a:t>Latency, availability, scale — all measured on the wire</a:t>
+              <a:t>Target ≤ €0.45 / learner / month at 3-market scale</a:t>
             </a:r>
           </a:p>
         </p:txBody>
@@ -26839,7 +26891,7 @@
                   <a:srgbClr val="F28C00"/>
                 </a:solidFill>
               </a:rPr>
-              <a:t>SLOS</a:t>
+              <a:t>COST BREAKDOWN</a:t>
             </a:r>
           </a:p>
           <a:p>
@@ -26850,7 +26902,7 @@
                   <a:srgbClr val="FFFFFF"/>
                 </a:solidFill>
               </a:rPr>
-              <a:t>• API availability: 99.9% (excl. planned maintenance windows out of school hours)</a:t>
+              <a:t>• Azure compute &amp; storage: ~35% of run cost</a:t>
             </a:r>
           </a:p>
           <a:p>
@@ -26861,7 +26913,7 @@
                   <a:srgbClr val="FFFFFF"/>
                 </a:solidFill>
               </a:rPr>
-              <a:t>• Adaptive picker p95 latency: ≤ 200 ms (on-device); ≤ 800 ms (fallback)</a:t>
+              <a:t>• Azure OpenAI (localisation + grading): ~20% — biggest variable</a:t>
             </a:r>
           </a:p>
           <a:p>
@@ -26872,7 +26924,7 @@
                   <a:srgbClr val="FFFFFF"/>
                 </a:solidFill>
               </a:rPr>
-              <a:t>• Assessment grading p95: ≤ 3 s</a:t>
+              <a:t>• People (RAI, editorial, CSM, ops): ~35%</a:t>
             </a:r>
           </a:p>
           <a:p>
@@ -26883,7 +26935,7 @@
                   <a:srgbClr val="FFFFFF"/>
                 </a:solidFill>
               </a:rPr>
-              <a:t>• Localisation batch: 6-week SLA per market</a:t>
+              <a:t>• Sub-processors + licences: ~10%</a:t>
             </a:r>
           </a:p>
         </p:txBody>
@@ -26937,7 +26989,7 @@
                   <a:srgbClr val="F28C00"/>
                 </a:solidFill>
               </a:rPr>
-              <a:t>RESILIENCE</a:t>
+              <a:t>OPTIMISATION LEVERS</a:t>
             </a:r>
           </a:p>
           <a:p>
@@ -26948,7 +27000,7 @@
                   <a:srgbClr val="FFFFFF"/>
                 </a:solidFill>
               </a:rPr>
-              <a:t>• Multi-region within EU (West Europe ↔ North Europe; DE primary in Germany)</a:t>
+              <a:t>• Provisioned Throughput Units (PTU) on OpenAI for predictable load</a:t>
             </a:r>
           </a:p>
           <a:p>
@@ -26959,7 +27011,7 @@
                   <a:srgbClr val="FFFFFF"/>
                 </a:solidFill>
               </a:rPr>
-              <a:t>• DR drill quarterly; RPO ≤ 15 min, RTO ≤ 2 h</a:t>
+              <a:t>• Caching of repeated localisations (~30% cost avoidance modelled)</a:t>
             </a:r>
           </a:p>
           <a:p>
@@ -26970,7 +27022,7 @@
                   <a:srgbClr val="FFFFFF"/>
                 </a:solidFill>
               </a:rPr>
-              <a:t>• APIM rate-limit per school to prevent noisy-neighbour</a:t>
+              <a:t>• Fine-tuned small models for routine tasks; frontier on edge cases</a:t>
             </a:r>
           </a:p>
           <a:p>
@@ -26981,7 +27033,7 @@
                   <a:srgbClr val="FFFFFF"/>
                 </a:solidFill>
               </a:rPr>
-              <a:t>• Kill-switch wired per AI feature (sub-5-minute disable)</a:t>
+              <a:t>• Region pinning + reserved instances for Fabric capacity</a:t>
             </a:r>
           </a:p>
         </p:txBody>
@@ -26994,7 +27046,7 @@
 </p:sld>
 </file>
 
-<file path=ppt/slides/slide32.xml><?xml version="1.0" encoding="utf-8"?>
+<file path=ppt/slides/slide33.xml><?xml version="1.0" encoding="utf-8"?>
 <p:sld xmlns:a="http://schemas.openxmlformats.org/drawingml/2006/main" xmlns:p="http://schemas.openxmlformats.org/presentationml/2006/main" xmlns:r="http://schemas.openxmlformats.org/officeDocument/2006/relationships">
   <p:cSld>
     <p:spTree>
@@ -27025,7 +27077,7 @@
                   <a:srgbClr val="FFFFFF"/>
                 </a:solidFill>
               </a:rPr>
-              <a:t>A11 · Cost / learner / month is the FinOps north star</a:t>
+              <a:t>A12 · 12 risks tracked, monthly Steering review</a:t>
             </a:r>
           </a:p>
         </p:txBody>
@@ -27058,7 +27110,259 @@
                   <a:srgbClr val="C8D4E6"/>
                 </a:solidFill>
               </a:rPr>
-              <a:t>Target ≤ €0.45 / learner / month at 3-market scale</a:t>
+              <a:t>Severity = Likelihood × Impact (1–5 each)</a:t>
+            </a:r>
+          </a:p>
+        </p:txBody>
+      </p:sp>
+      <p:sp>
+        <p:nvSpPr>
+          <p:cNvPr id="4" name="Rounded Rectangle 3"/>
+          <p:cNvSpPr/>
+          <p:nvPr/>
+        </p:nvSpPr>
+        <p:spPr>
+          <a:xfrm>
+            <a:off x="600000" y="1400000"/>
+            <a:ext cx="10992000" cy="5098000"/>
+          </a:xfrm>
+          <a:prstGeom prst="roundRect">
+            <a:avLst/>
+          </a:prstGeom>
+          <a:solidFill>
+            <a:srgbClr val="122A4A"/>
+          </a:solidFill>
+          <a:ln w="12700">
+            <a:solidFill>
+              <a:srgbClr val="2A4A78"/>
+            </a:solidFill>
+          </a:ln>
+          <a:effectLst/>
+        </p:spPr>
+        <p:style>
+          <a:lnRef idx="1">
+            <a:schemeClr val="accent1"/>
+          </a:lnRef>
+          <a:fillRef idx="3">
+            <a:schemeClr val="accent1"/>
+          </a:fillRef>
+          <a:effectRef idx="2">
+            <a:schemeClr val="accent1"/>
+          </a:effectRef>
+          <a:fontRef idx="minor">
+            <a:schemeClr val="lt1"/>
+          </a:fontRef>
+        </p:style>
+        <p:txBody>
+          <a:bodyPr rtlCol="0" anchor="t" wrap="square" lIns="120000" rIns="120000" tIns="80000" bIns="80000"/>
+          <a:lstStyle/>
+          <a:p>
+            <a:pPr algn="ctr"/>
+            <a:r>
+              <a:rPr sz="1400" b="0">
+                <a:solidFill>
+                  <a:srgbClr val="FFFFFF"/>
+                </a:solidFill>
+              </a:rPr>
+              <a:t>• R1 · DPA blocks DPIA · sev 15 · DPO · engage early · delay that market</a:t>
+            </a:r>
+          </a:p>
+          <a:p>
+            <a:pPr/>
+            <a:r>
+              <a:rPr sz="1400" b="0">
+                <a:solidFill>
+                  <a:srgbClr val="FFFFFF"/>
+                </a:solidFill>
+              </a:rPr>
+              <a:t>• R2 · AI Act conformity fails · sev 10 · AI Act CO · Annex IV from M0</a:t>
+            </a:r>
+          </a:p>
+          <a:p>
+            <a:pPr/>
+            <a:r>
+              <a:rPr sz="1400" b="0">
+                <a:solidFill>
+                  <a:srgbClr val="FFFFFF"/>
+                </a:solidFill>
+              </a:rPr>
+              <a:t>• R3 · Federated runtime non-convergence · sev 12 · ML Lead · DP central fallback</a:t>
+            </a:r>
+          </a:p>
+          <a:p>
+            <a:pPr/>
+            <a:r>
+              <a:rPr sz="1400" b="0">
+                <a:solidFill>
+                  <a:srgbClr val="FFFFFF"/>
+                </a:solidFill>
+              </a:rPr>
+              <a:t>• R4 · Localisation quality drift · sev 16 · Editorial · reviewer non-optional</a:t>
+            </a:r>
+          </a:p>
+          <a:p>
+            <a:pPr/>
+            <a:r>
+              <a:rPr sz="1400" b="0">
+                <a:solidFill>
+                  <a:srgbClr val="FFFFFF"/>
+                </a:solidFill>
+              </a:rPr>
+              <a:t>• R5 · Teacher override explosion · sev 12 · UX/RAI · co-design + CPD</a:t>
+            </a:r>
+          </a:p>
+          <a:p>
+            <a:pPr/>
+            <a:r>
+              <a:rPr sz="1400" b="0">
+                <a:solidFill>
+                  <a:srgbClr val="FFFFFF"/>
+                </a:solidFill>
+              </a:rPr>
+              <a:t>• R6 · Bias disparity &gt; 5pp · sev 15 · RAI · gate + same-day rollback</a:t>
+            </a:r>
+          </a:p>
+          <a:p>
+            <a:pPr/>
+            <a:r>
+              <a:rPr sz="1400" b="0">
+                <a:solidFill>
+                  <a:srgbClr val="FFFFFF"/>
+                </a:solidFill>
+              </a:rPr>
+              <a:t>• R7 · Sub-processor change · sev 10 · DPO/Arch · quarterly review</a:t>
+            </a:r>
+          </a:p>
+          <a:p>
+            <a:pPr/>
+            <a:r>
+              <a:rPr sz="1400" b="0">
+                <a:solidFill>
+                  <a:srgbClr val="FFFFFF"/>
+                </a:solidFill>
+              </a:rPr>
+              <a:t>• R8 · OpenAI cost runaway · sev 12 · FinOps · PTU + cache</a:t>
+            </a:r>
+          </a:p>
+          <a:p>
+            <a:pPr/>
+            <a:r>
+              <a:rPr sz="1400" b="0">
+                <a:solidFill>
+                  <a:srgbClr val="FFFFFF"/>
+                </a:solidFill>
+              </a:rPr>
+              <a:t>• R9 · School onboarding lag · sev 12 · Country Mgrs · CSM per market</a:t>
+            </a:r>
+          </a:p>
+          <a:p>
+            <a:pPr/>
+            <a:r>
+              <a:rPr sz="1400" b="0">
+                <a:solidFill>
+                  <a:srgbClr val="FFFFFF"/>
+                </a:solidFill>
+              </a:rPr>
+              <a:t>• R10 · Art. 73 serious incident · sev 5 · RAI/DPO · drilled IR</a:t>
+            </a:r>
+          </a:p>
+          <a:p>
+            <a:pPr/>
+            <a:r>
+              <a:rPr sz="1400" b="0">
+                <a:solidFill>
+                  <a:srgbClr val="FFFFFF"/>
+                </a:solidFill>
+              </a:rPr>
+              <a:t>• R11 · SIS vulnerability exposes minors · sev 10 · Security · pen-test + Defender</a:t>
+            </a:r>
+          </a:p>
+          <a:p>
+            <a:pPr/>
+            <a:r>
+              <a:rPr sz="1400" b="0">
+                <a:solidFill>
+                  <a:srgbClr val="FFFFFF"/>
+                </a:solidFill>
+              </a:rPr>
+              <a:t>• R12 · Content Safety false negative · sev 10 · RAI/Editorial · takedown &lt; 2h</a:t>
+            </a:r>
+          </a:p>
+        </p:txBody>
+      </p:sp>
+    </p:spTree>
+  </p:cSld>
+  <p:clrMapOvr>
+    <a:masterClrMapping/>
+  </p:clrMapOvr>
+</p:sld>
+</file>
+
+<file path=ppt/slides/slide34.xml><?xml version="1.0" encoding="utf-8"?>
+<p:sld xmlns:a="http://schemas.openxmlformats.org/drawingml/2006/main" xmlns:p="http://schemas.openxmlformats.org/presentationml/2006/main" xmlns:r="http://schemas.openxmlformats.org/officeDocument/2006/relationships">
+  <p:cSld>
+    <p:spTree>
+      <p:nvGrpSpPr>
+        <p:cNvPr id="1" name=""/>
+        <p:cNvGrpSpPr/>
+        <p:nvPr/>
+      </p:nvGrpSpPr>
+      <p:grpSpPr/>
+      <p:sp>
+        <p:nvSpPr>
+          <p:cNvPr id="2" name="Title 1"/>
+          <p:cNvSpPr>
+            <a:spLocks noGrp="1"/>
+          </p:cNvSpPr>
+          <p:nvPr>
+            <p:ph type="title"/>
+          </p:nvPr>
+        </p:nvSpPr>
+        <p:spPr/>
+        <p:txBody>
+          <a:bodyPr/>
+          <a:lstStyle/>
+          <a:p>
+            <a:r>
+              <a:rPr>
+                <a:solidFill>
+                  <a:srgbClr val="FFFFFF"/>
+                </a:solidFill>
+              </a:rPr>
+              <a:t>A13 · Leading indicators per workstream</a:t>
+            </a:r>
+          </a:p>
+        </p:txBody>
+      </p:sp>
+      <p:sp>
+        <p:nvSpPr>
+          <p:cNvPr id="3" name="TextBox 2"/>
+          <p:cNvSpPr txBox="1"/>
+          <p:nvPr/>
+        </p:nvSpPr>
+        <p:spPr>
+          <a:xfrm>
+            <a:off x="640000" y="950000"/>
+            <a:ext cx="10912000" cy="360000"/>
+          </a:xfrm>
+          <a:prstGeom prst="rect">
+            <a:avLst/>
+          </a:prstGeom>
+          <a:noFill/>
+        </p:spPr>
+        <p:txBody>
+          <a:bodyPr wrap="square">
+            <a:spAutoFit/>
+          </a:bodyPr>
+          <a:lstStyle/>
+          <a:p>
+            <a:r>
+              <a:rPr sz="1800" i="1">
+                <a:solidFill>
+                  <a:srgbClr val="C8D4E6"/>
+                </a:solidFill>
+              </a:rPr>
+              <a:t>What we watch weekly to know KPIs will land</a:t>
             </a:r>
           </a:p>
         </p:txBody>
@@ -27112,7 +27416,7 @@
                   <a:srgbClr val="F28C00"/>
                 </a:solidFill>
               </a:rPr>
-              <a:t>COST BREAKDOWN</a:t>
+              <a:t>LEARNER &amp; TEACHER</a:t>
             </a:r>
           </a:p>
           <a:p>
@@ -27123,7 +27427,7 @@
                   <a:srgbClr val="FFFFFF"/>
                 </a:solidFill>
               </a:rPr>
-              <a:t>• Azure compute &amp; storage: ~35% of run cost</a:t>
+              <a:t>• Adaptive: mastery improvement, curriculum coverage breadth, time-on-task</a:t>
             </a:r>
           </a:p>
           <a:p>
@@ -27134,7 +27438,7 @@
                   <a:srgbClr val="FFFFFF"/>
                 </a:solidFill>
               </a:rPr>
-              <a:t>• Azure OpenAI (localisation + grading): ~20% — biggest variable</a:t>
+              <a:t>• Adaptive: per-cohort fairness disparity (gating)</a:t>
             </a:r>
           </a:p>
           <a:p>
@@ -27145,7 +27449,7 @@
                   <a:srgbClr val="FFFFFF"/>
                 </a:solidFill>
               </a:rPr>
-              <a:t>• People (RAI, editorial, CSM, ops): ~35%</a:t>
+              <a:t>• Assessment: teacher minutes saved / assignment</a:t>
             </a:r>
           </a:p>
           <a:p>
@@ -27156,7 +27460,7 @@
                   <a:srgbClr val="FFFFFF"/>
                 </a:solidFill>
               </a:rPr>
-              <a:t>• Sub-processors + licences: ~10%</a:t>
+              <a:t>• Assessment: override rate ≤ 10% target, ECE ≤ 0.05</a:t>
             </a:r>
           </a:p>
         </p:txBody>
@@ -27210,7 +27514,7 @@
                   <a:srgbClr val="F28C00"/>
                 </a:solidFill>
               </a:rPr>
-              <a:t>OPTIMISATION LEVERS</a:t>
+              <a:t>LOCALISATION &amp; COMPLIANCE</a:t>
             </a:r>
           </a:p>
           <a:p>
@@ -27221,7 +27525,7 @@
                   <a:srgbClr val="FFFFFF"/>
                 </a:solidFill>
               </a:rPr>
-              <a:t>• Provisioned Throughput Units (PTU) on OpenAI for predictable load</a:t>
+              <a:t>• Localisation: units / week / market, first-pass acceptance, reviewer cycle</a:t>
             </a:r>
           </a:p>
           <a:p>
@@ -27232,7 +27536,7 @@
                   <a:srgbClr val="FFFFFF"/>
                 </a:solidFill>
               </a:rPr>
-              <a:t>• Caching of repeated localisations (~30% cost avoidance modelled)</a:t>
+              <a:t>• Localisation: glossary coverage % per subject</a:t>
             </a:r>
           </a:p>
           <a:p>
@@ -27243,7 +27547,7 @@
                   <a:srgbClr val="FFFFFF"/>
                 </a:solidFill>
               </a:rPr>
-              <a:t>• Fine-tuned small models for routine tasks; frontier on edge cases</a:t>
+              <a:t>• Compliance: % features with current Annex IV, DPIA freshness &lt; 12mo</a:t>
             </a:r>
           </a:p>
           <a:p>
@@ -27254,7 +27558,7 @@
                   <a:srgbClr val="FFFFFF"/>
                 </a:solidFill>
               </a:rPr>
-              <a:t>• Region pinning + reserved instances for Fabric capacity</a:t>
+              <a:t>• Compliance: erasure mean cycle time, # overrides exercised</a:t>
             </a:r>
           </a:p>
         </p:txBody>
@@ -27267,7 +27571,7 @@
 </p:sld>
 </file>
 
-<file path=ppt/slides/slide33.xml><?xml version="1.0" encoding="utf-8"?>
+<file path=ppt/slides/slide35.xml><?xml version="1.0" encoding="utf-8"?>
 <p:sld xmlns:a="http://schemas.openxmlformats.org/drawingml/2006/main" xmlns:p="http://schemas.openxmlformats.org/presentationml/2006/main" xmlns:r="http://schemas.openxmlformats.org/officeDocument/2006/relationships">
   <p:cSld>
     <p:spTree>
@@ -27298,7 +27602,7 @@
                   <a:srgbClr val="FFFFFF"/>
                 </a:solidFill>
               </a:rPr>
-              <a:t>A12 · 12 risks tracked, monthly Steering review</a:t>
+              <a:t>A14 · Who decides what, when</a:t>
             </a:r>
           </a:p>
         </p:txBody>
@@ -27331,259 +27635,7 @@
                   <a:srgbClr val="C8D4E6"/>
                 </a:solidFill>
               </a:rPr>
-              <a:t>Severity = Likelihood × Impact (1–5 each)</a:t>
-            </a:r>
-          </a:p>
-        </p:txBody>
-      </p:sp>
-      <p:sp>
-        <p:nvSpPr>
-          <p:cNvPr id="4" name="Rounded Rectangle 3"/>
-          <p:cNvSpPr/>
-          <p:nvPr/>
-        </p:nvSpPr>
-        <p:spPr>
-          <a:xfrm>
-            <a:off x="600000" y="1400000"/>
-            <a:ext cx="10992000" cy="5098000"/>
-          </a:xfrm>
-          <a:prstGeom prst="roundRect">
-            <a:avLst/>
-          </a:prstGeom>
-          <a:solidFill>
-            <a:srgbClr val="122A4A"/>
-          </a:solidFill>
-          <a:ln w="12700">
-            <a:solidFill>
-              <a:srgbClr val="2A4A78"/>
-            </a:solidFill>
-          </a:ln>
-          <a:effectLst/>
-        </p:spPr>
-        <p:style>
-          <a:lnRef idx="1">
-            <a:schemeClr val="accent1"/>
-          </a:lnRef>
-          <a:fillRef idx="3">
-            <a:schemeClr val="accent1"/>
-          </a:fillRef>
-          <a:effectRef idx="2">
-            <a:schemeClr val="accent1"/>
-          </a:effectRef>
-          <a:fontRef idx="minor">
-            <a:schemeClr val="lt1"/>
-          </a:fontRef>
-        </p:style>
-        <p:txBody>
-          <a:bodyPr rtlCol="0" anchor="t" wrap="square" lIns="120000" rIns="120000" tIns="80000" bIns="80000"/>
-          <a:lstStyle/>
-          <a:p>
-            <a:pPr algn="ctr"/>
-            <a:r>
-              <a:rPr sz="1400" b="0">
-                <a:solidFill>
-                  <a:srgbClr val="FFFFFF"/>
-                </a:solidFill>
-              </a:rPr>
-              <a:t>• R1 · DPA blocks DPIA · sev 15 · DPO · engage early · delay that market</a:t>
-            </a:r>
-          </a:p>
-          <a:p>
-            <a:pPr/>
-            <a:r>
-              <a:rPr sz="1400" b="0">
-                <a:solidFill>
-                  <a:srgbClr val="FFFFFF"/>
-                </a:solidFill>
-              </a:rPr>
-              <a:t>• R2 · AI Act conformity fails · sev 10 · AI Act CO · Annex IV from M0</a:t>
-            </a:r>
-          </a:p>
-          <a:p>
-            <a:pPr/>
-            <a:r>
-              <a:rPr sz="1400" b="0">
-                <a:solidFill>
-                  <a:srgbClr val="FFFFFF"/>
-                </a:solidFill>
-              </a:rPr>
-              <a:t>• R3 · Federated runtime non-convergence · sev 12 · ML Lead · DP central fallback</a:t>
-            </a:r>
-          </a:p>
-          <a:p>
-            <a:pPr/>
-            <a:r>
-              <a:rPr sz="1400" b="0">
-                <a:solidFill>
-                  <a:srgbClr val="FFFFFF"/>
-                </a:solidFill>
-              </a:rPr>
-              <a:t>• R4 · Localisation quality drift · sev 16 · Editorial · reviewer non-optional</a:t>
-            </a:r>
-          </a:p>
-          <a:p>
-            <a:pPr/>
-            <a:r>
-              <a:rPr sz="1400" b="0">
-                <a:solidFill>
-                  <a:srgbClr val="FFFFFF"/>
-                </a:solidFill>
-              </a:rPr>
-              <a:t>• R5 · Teacher override explosion · sev 12 · UX/RAI · co-design + CPD</a:t>
-            </a:r>
-          </a:p>
-          <a:p>
-            <a:pPr/>
-            <a:r>
-              <a:rPr sz="1400" b="0">
-                <a:solidFill>
-                  <a:srgbClr val="FFFFFF"/>
-                </a:solidFill>
-              </a:rPr>
-              <a:t>• R6 · Bias disparity &gt; 5pp · sev 15 · RAI · gate + same-day rollback</a:t>
-            </a:r>
-          </a:p>
-          <a:p>
-            <a:pPr/>
-            <a:r>
-              <a:rPr sz="1400" b="0">
-                <a:solidFill>
-                  <a:srgbClr val="FFFFFF"/>
-                </a:solidFill>
-              </a:rPr>
-              <a:t>• R7 · Sub-processor change · sev 10 · DPO/Arch · quarterly review</a:t>
-            </a:r>
-          </a:p>
-          <a:p>
-            <a:pPr/>
-            <a:r>
-              <a:rPr sz="1400" b="0">
-                <a:solidFill>
-                  <a:srgbClr val="FFFFFF"/>
-                </a:solidFill>
-              </a:rPr>
-              <a:t>• R8 · OpenAI cost runaway · sev 12 · FinOps · PTU + cache</a:t>
-            </a:r>
-          </a:p>
-          <a:p>
-            <a:pPr/>
-            <a:r>
-              <a:rPr sz="1400" b="0">
-                <a:solidFill>
-                  <a:srgbClr val="FFFFFF"/>
-                </a:solidFill>
-              </a:rPr>
-              <a:t>• R9 · School onboarding lag · sev 12 · Country Mgrs · CSM per market</a:t>
-            </a:r>
-          </a:p>
-          <a:p>
-            <a:pPr/>
-            <a:r>
-              <a:rPr sz="1400" b="0">
-                <a:solidFill>
-                  <a:srgbClr val="FFFFFF"/>
-                </a:solidFill>
-              </a:rPr>
-              <a:t>• R10 · Art. 73 serious incident · sev 5 · RAI/DPO · drilled IR</a:t>
-            </a:r>
-          </a:p>
-          <a:p>
-            <a:pPr/>
-            <a:r>
-              <a:rPr sz="1400" b="0">
-                <a:solidFill>
-                  <a:srgbClr val="FFFFFF"/>
-                </a:solidFill>
-              </a:rPr>
-              <a:t>• R11 · SIS vulnerability exposes minors · sev 10 · Security · pen-test + Defender</a:t>
-            </a:r>
-          </a:p>
-          <a:p>
-            <a:pPr/>
-            <a:r>
-              <a:rPr sz="1400" b="0">
-                <a:solidFill>
-                  <a:srgbClr val="FFFFFF"/>
-                </a:solidFill>
-              </a:rPr>
-              <a:t>• R12 · Content Safety false negative · sev 10 · RAI/Editorial · takedown &lt; 2h</a:t>
-            </a:r>
-          </a:p>
-        </p:txBody>
-      </p:sp>
-    </p:spTree>
-  </p:cSld>
-  <p:clrMapOvr>
-    <a:masterClrMapping/>
-  </p:clrMapOvr>
-</p:sld>
-</file>
-
-<file path=ppt/slides/slide34.xml><?xml version="1.0" encoding="utf-8"?>
-<p:sld xmlns:a="http://schemas.openxmlformats.org/drawingml/2006/main" xmlns:p="http://schemas.openxmlformats.org/presentationml/2006/main" xmlns:r="http://schemas.openxmlformats.org/officeDocument/2006/relationships">
-  <p:cSld>
-    <p:spTree>
-      <p:nvGrpSpPr>
-        <p:cNvPr id="1" name=""/>
-        <p:cNvGrpSpPr/>
-        <p:nvPr/>
-      </p:nvGrpSpPr>
-      <p:grpSpPr/>
-      <p:sp>
-        <p:nvSpPr>
-          <p:cNvPr id="2" name="Title 1"/>
-          <p:cNvSpPr>
-            <a:spLocks noGrp="1"/>
-          </p:cNvSpPr>
-          <p:nvPr>
-            <p:ph type="title"/>
-          </p:nvPr>
-        </p:nvSpPr>
-        <p:spPr/>
-        <p:txBody>
-          <a:bodyPr/>
-          <a:lstStyle/>
-          <a:p>
-            <a:r>
-              <a:rPr>
-                <a:solidFill>
-                  <a:srgbClr val="FFFFFF"/>
-                </a:solidFill>
-              </a:rPr>
-              <a:t>A13 · Leading indicators per workstream</a:t>
-            </a:r>
-          </a:p>
-        </p:txBody>
-      </p:sp>
-      <p:sp>
-        <p:nvSpPr>
-          <p:cNvPr id="3" name="TextBox 2"/>
-          <p:cNvSpPr txBox="1"/>
-          <p:nvPr/>
-        </p:nvSpPr>
-        <p:spPr>
-          <a:xfrm>
-            <a:off x="640000" y="950000"/>
-            <a:ext cx="10912000" cy="360000"/>
-          </a:xfrm>
-          <a:prstGeom prst="rect">
-            <a:avLst/>
-          </a:prstGeom>
-          <a:noFill/>
-        </p:spPr>
-        <p:txBody>
-          <a:bodyPr wrap="square">
-            <a:spAutoFit/>
-          </a:bodyPr>
-          <a:lstStyle/>
-          <a:p>
-            <a:r>
-              <a:rPr sz="1800" i="1">
-                <a:solidFill>
-                  <a:srgbClr val="C8D4E6"/>
-                </a:solidFill>
-              </a:rPr>
-              <a:t>What we watch weekly to know KPIs will land</a:t>
+              <a:t>Four bodies, named chairs, written charter</a:t>
             </a:r>
           </a:p>
         </p:txBody>
@@ -27637,7 +27689,7 @@
                   <a:srgbClr val="F28C00"/>
                 </a:solidFill>
               </a:rPr>
-              <a:t>LEARNER &amp; TEACHER</a:t>
+              <a:t>BODIES</a:t>
             </a:r>
           </a:p>
           <a:p>
@@ -27648,7 +27700,7 @@
                   <a:srgbClr val="FFFFFF"/>
                 </a:solidFill>
               </a:rPr>
-              <a:t>• Adaptive: mastery improvement, curriculum coverage breadth, time-on-task</a:t>
+              <a:t>• Steering Committee — monthly · CEO chair · KPIs + risk + budget</a:t>
             </a:r>
           </a:p>
           <a:p>
@@ -27659,7 +27711,7 @@
                   <a:srgbClr val="FFFFFF"/>
                 </a:solidFill>
               </a:rPr>
-              <a:t>• Adaptive: per-cohort fairness disparity (gating)</a:t>
+              <a:t>• Responsible AI Council — bi-weekly · CAIO/RAI Evaluator chair · release gates</a:t>
             </a:r>
           </a:p>
           <a:p>
@@ -27670,7 +27722,7 @@
                   <a:srgbClr val="FFFFFF"/>
                 </a:solidFill>
               </a:rPr>
-              <a:t>• Assessment: teacher minutes saved / assignment</a:t>
+              <a:t>• Architecture Review Board — bi-weekly · CTO chair · technical decisions</a:t>
             </a:r>
           </a:p>
           <a:p>
@@ -27681,7 +27733,7 @@
                   <a:srgbClr val="FFFFFF"/>
                 </a:solidFill>
               </a:rPr>
-              <a:t>• Assessment: override rate ≤ 10% target, ECE ≤ 0.05</a:t>
+              <a:t>• Teacher Council — per release · Learning Sciences chair · pedagogical sign-off</a:t>
             </a:r>
           </a:p>
         </p:txBody>
@@ -27735,7 +27787,7 @@
                   <a:srgbClr val="F28C00"/>
                 </a:solidFill>
               </a:rPr>
-              <a:t>LOCALISATION &amp; COMPLIANCE</a:t>
+              <a:t>RAI COUNCIL COMPOSITION</a:t>
             </a:r>
           </a:p>
           <a:p>
@@ -27746,7 +27798,7 @@
                   <a:srgbClr val="FFFFFF"/>
                 </a:solidFill>
               </a:rPr>
-              <a:t>• Localisation: units / week / market, first-pass acceptance, reviewer cycle</a:t>
+              <a:t>• Chair: independent (proposed)</a:t>
             </a:r>
           </a:p>
           <a:p>
@@ -27757,7 +27809,7 @@
                   <a:srgbClr val="FFFFFF"/>
                 </a:solidFill>
               </a:rPr>
-              <a:t>• Localisation: glossary coverage % per subject</a:t>
+              <a:t>• Members: RAI Evaluator, AI Act CO, GDPR Specialist, Learning Sciences,</a:t>
             </a:r>
           </a:p>
           <a:p>
@@ -27768,7 +27820,7 @@
                   <a:srgbClr val="FFFFFF"/>
                 </a:solidFill>
               </a:rPr>
-              <a:t>• Compliance: % features with current Annex IV, DPIA freshness &lt; 12mo</a:t>
+              <a:t>• Authority: bind/release model versions, mandate rollback, escalate to Steering</a:t>
             </a:r>
           </a:p>
           <a:p>
@@ -27779,7 +27831,7 @@
                   <a:srgbClr val="FFFFFF"/>
                 </a:solidFill>
               </a:rPr>
-              <a:t>• Compliance: erasure mean cycle time, # overrides exercised</a:t>
+              <a:t>• Outputs: weekly RAI dashboard, quarterly re-evaluation report</a:t>
             </a:r>
           </a:p>
         </p:txBody>
@@ -27792,7 +27844,7 @@
 </p:sld>
 </file>
 
-<file path=ppt/slides/slide35.xml><?xml version="1.0" encoding="utf-8"?>
+<file path=ppt/slides/slide36.xml><?xml version="1.0" encoding="utf-8"?>
 <p:sld xmlns:a="http://schemas.openxmlformats.org/drawingml/2006/main" xmlns:p="http://schemas.openxmlformats.org/presentationml/2006/main" xmlns:r="http://schemas.openxmlformats.org/officeDocument/2006/relationships">
   <p:cSld>
     <p:spTree>
@@ -27823,7 +27875,7 @@
                   <a:srgbClr val="FFFFFF"/>
                 </a:solidFill>
               </a:rPr>
-              <a:t>A14 · Who decides what, when</a:t>
+              <a:t>A15 · IR drilled, statutory windows known</a:t>
             </a:r>
           </a:p>
         </p:txBody>
@@ -27856,7 +27908,7 @@
                   <a:srgbClr val="C8D4E6"/>
                 </a:solidFill>
               </a:rPr>
-              <a:t>Four bodies, named chairs, written charter</a:t>
+              <a:t>GDPR Art. 33/34 · AI Act Art. 73 · Content Safety takedown</a:t>
             </a:r>
           </a:p>
         </p:txBody>
@@ -27910,7 +27962,7 @@
                   <a:srgbClr val="F28C00"/>
                 </a:solidFill>
               </a:rPr>
-              <a:t>BODIES</a:t>
+              <a:t>DETECTION &amp; TRIAGE</a:t>
             </a:r>
           </a:p>
           <a:p>
@@ -27921,7 +27973,7 @@
                   <a:srgbClr val="FFFFFF"/>
                 </a:solidFill>
               </a:rPr>
-              <a:t>• Steering Committee — monthly · CEO chair · KPIs + risk + budget</a:t>
+              <a:t>• Defender for Cloud + Sentinel — 24×7 SOC</a:t>
             </a:r>
           </a:p>
           <a:p>
@@ -27932,7 +27984,7 @@
                   <a:srgbClr val="FFFFFF"/>
                 </a:solidFill>
               </a:rPr>
-              <a:t>• Responsible AI Council — bi-weekly · CAIO/RAI Evaluator chair · release gates</a:t>
+              <a:t>• App Insights anomaly detection on AI decisions + Content Safety blocks</a:t>
             </a:r>
           </a:p>
           <a:p>
@@ -27943,7 +27995,7 @@
                   <a:srgbClr val="FFFFFF"/>
                 </a:solidFill>
               </a:rPr>
-              <a:t>• Architecture Review Board — bi-weekly · CTO chair · technical decisions</a:t>
+              <a:t>• Kill switch per AI feature (sub-5-minute disable)</a:t>
             </a:r>
           </a:p>
           <a:p>
@@ -27954,7 +28006,7 @@
                   <a:srgbClr val="FFFFFF"/>
                 </a:solidFill>
               </a:rPr>
-              <a:t>• Teacher Council — per release · Learning Sciences chair · pedagogical sign-off</a:t>
+              <a:t>• Severity matrix: P1 = learner data exposure or serious AI incident</a:t>
             </a:r>
           </a:p>
         </p:txBody>
@@ -28008,7 +28060,7 @@
                   <a:srgbClr val="F28C00"/>
                 </a:solidFill>
               </a:rPr>
-              <a:t>RAI COUNCIL COMPOSITION</a:t>
+              <a:t>STATUTORY RESPONSE</a:t>
             </a:r>
           </a:p>
           <a:p>
@@ -28019,7 +28071,7 @@
                   <a:srgbClr val="FFFFFF"/>
                 </a:solidFill>
               </a:rPr>
-              <a:t>• Chair: independent (proposed)</a:t>
+              <a:t>• GDPR Art. 33: 72-hour DPA notification on breach (template ready)</a:t>
             </a:r>
           </a:p>
           <a:p>
@@ -28030,7 +28082,7 @@
                   <a:srgbClr val="FFFFFF"/>
                 </a:solidFill>
               </a:rPr>
-              <a:t>• Members: RAI Evaluator, AI Act CO, GDPR Specialist, Learning Sciences,</a:t>
+              <a:t>• GDPR Art. 34: data-subject notification when high risk</a:t>
             </a:r>
           </a:p>
           <a:p>
@@ -28041,7 +28093,7 @@
                   <a:srgbClr val="FFFFFF"/>
                 </a:solidFill>
               </a:rPr>
-              <a:t>• Authority: bind/release model versions, mandate rollback, escalate to Steering</a:t>
+              <a:t>• AI Act Art. 73: serious incident reporting to authority within statutory window</a:t>
             </a:r>
           </a:p>
           <a:p>
@@ -28052,7 +28104,7 @@
                   <a:srgbClr val="FFFFFF"/>
                 </a:solidFill>
               </a:rPr>
-              <a:t>• Outputs: weekly RAI dashboard, quarterly re-evaluation report</a:t>
+              <a:t>• Post-incident: root-cause analysis + RAI Council review within 5 working days</a:t>
             </a:r>
           </a:p>
         </p:txBody>
@@ -28065,7 +28117,7 @@
 </p:sld>
 </file>
 
-<file path=ppt/slides/slide36.xml><?xml version="1.0" encoding="utf-8"?>
+<file path=ppt/slides/slide37.xml><?xml version="1.0" encoding="utf-8"?>
 <p:sld xmlns:a="http://schemas.openxmlformats.org/drawingml/2006/main" xmlns:p="http://schemas.openxmlformats.org/presentationml/2006/main" xmlns:r="http://schemas.openxmlformats.org/officeDocument/2006/relationships">
   <p:cSld>
     <p:spTree>
@@ -28096,7 +28148,7 @@
                   <a:srgbClr val="FFFFFF"/>
                 </a:solidFill>
               </a:rPr>
-              <a:t>A15 · IR drilled, statutory windows known</a:t>
+              <a:t>A16 · gCO₂e / learner / month — measured and reduced</a:t>
             </a:r>
           </a:p>
         </p:txBody>
@@ -28129,7 +28181,7 @@
                   <a:srgbClr val="C8D4E6"/>
                 </a:solidFill>
               </a:rPr>
-              <a:t>GDPR Art. 33/34 · AI Act Art. 73 · Content Safety takedown</a:t>
+              <a:t>Aligned to group ESG report; auditable proxy</a:t>
             </a:r>
           </a:p>
         </p:txBody>
@@ -28183,7 +28235,7 @@
                   <a:srgbClr val="F28C00"/>
                 </a:solidFill>
               </a:rPr>
-              <a:t>DETECTION &amp; TRIAGE</a:t>
+              <a:t>BASELINE &amp; PROXY</a:t>
             </a:r>
           </a:p>
           <a:p>
@@ -28194,7 +28246,7 @@
                   <a:srgbClr val="FFFFFF"/>
                 </a:solidFill>
               </a:rPr>
-              <a:t>• Defender for Cloud + Sentinel — 24×7 SOC</a:t>
+              <a:t>• Carbon proxy = (Azure compute + storage emissions) / active learners</a:t>
             </a:r>
           </a:p>
           <a:p>
@@ -28205,7 +28257,7 @@
                   <a:srgbClr val="FFFFFF"/>
                 </a:solidFill>
               </a:rPr>
-              <a:t>• App Insights anomaly detection on AI decisions + Content Safety blocks</a:t>
+              <a:t>• Microsoft Emissions Impact Dashboard as primary source</a:t>
             </a:r>
           </a:p>
           <a:p>
@@ -28216,7 +28268,7 @@
                   <a:srgbClr val="FFFFFF"/>
                 </a:solidFill>
               </a:rPr>
-              <a:t>• Kill switch per AI feature (sub-5-minute disable)</a:t>
+              <a:t>• On-device inference reduces server-side carbon by design</a:t>
             </a:r>
           </a:p>
           <a:p>
@@ -28227,7 +28279,7 @@
                   <a:srgbClr val="FFFFFF"/>
                 </a:solidFill>
               </a:rPr>
-              <a:t>• Severity matrix: P1 = learner data exposure or serious AI incident</a:t>
+              <a:t>• Reported quarterly into group ESG narrative</a:t>
             </a:r>
           </a:p>
         </p:txBody>
@@ -28281,7 +28333,7 @@
                   <a:srgbClr val="F28C00"/>
                 </a:solidFill>
               </a:rPr>
-              <a:t>STATUTORY RESPONSE</a:t>
+              <a:t>REDUCTION LEVERS</a:t>
             </a:r>
           </a:p>
           <a:p>
@@ -28292,7 +28344,7 @@
                   <a:srgbClr val="FFFFFF"/>
                 </a:solidFill>
               </a:rPr>
-              <a:t>• GDPR Art. 33: 72-hour DPA notification on breach (template ready)</a:t>
+              <a:t>• Region selection prioritises EU regions with high renewable share</a:t>
             </a:r>
           </a:p>
           <a:p>
@@ -28303,7 +28355,7 @@
                   <a:srgbClr val="FFFFFF"/>
                 </a:solidFill>
               </a:rPr>
-              <a:t>• GDPR Art. 34: data-subject notification when high risk</a:t>
+              <a:t>• Small-first model routing (A07) directly reduces inference carbon</a:t>
             </a:r>
           </a:p>
           <a:p>
@@ -28314,7 +28366,7 @@
                   <a:srgbClr val="FFFFFF"/>
                 </a:solidFill>
               </a:rPr>
-              <a:t>• AI Act Art. 73: serious incident reporting to authority within statutory window</a:t>
+              <a:t>• Reserved capacity for predictable Fabric load → better PUE utilisation</a:t>
             </a:r>
           </a:p>
           <a:p>
@@ -28325,7 +28377,7 @@
                   <a:srgbClr val="FFFFFF"/>
                 </a:solidFill>
               </a:rPr>
-              <a:t>• Post-incident: root-cause analysis + RAI Council review within 5 working days</a:t>
+              <a:t>• Decommissioning of legacy on-prem grading systems</a:t>
             </a:r>
           </a:p>
         </p:txBody>
@@ -28338,7 +28390,7 @@
 </p:sld>
 </file>
 
-<file path=ppt/slides/slide37.xml><?xml version="1.0" encoding="utf-8"?>
+<file path=ppt/slides/slide38.xml><?xml version="1.0" encoding="utf-8"?>
 <p:sld xmlns:a="http://schemas.openxmlformats.org/drawingml/2006/main" xmlns:p="http://schemas.openxmlformats.org/presentationml/2006/main" xmlns:r="http://schemas.openxmlformats.org/officeDocument/2006/relationships">
   <p:cSld>
     <p:spTree>
@@ -28369,7 +28421,7 @@
                   <a:srgbClr val="FFFFFF"/>
                 </a:solidFill>
               </a:rPr>
-              <a:t>A16 · gCO₂e / learner / month — measured and reduced</a:t>
+              <a:t>A17 · Acronyms and source documents</a:t>
             </a:r>
           </a:p>
         </p:txBody>
@@ -28402,7 +28454,7 @@
                   <a:srgbClr val="C8D4E6"/>
                 </a:solidFill>
               </a:rPr>
-              <a:t>Aligned to group ESG report; auditable proxy</a:t>
+              <a:t>Everything traceable, nothing invented</a:t>
             </a:r>
           </a:p>
         </p:txBody>
@@ -28456,51 +28508,73 @@
                   <a:srgbClr val="F28C00"/>
                 </a:solidFill>
               </a:rPr>
-              <a:t>BASELINE &amp; PROXY</a:t>
+              <a:t>ACRONYMS</a:t>
             </a:r>
           </a:p>
           <a:p>
             <a:pPr/>
             <a:r>
-              <a:rPr sz="1800" b="0">
+              <a:rPr sz="1600" b="0">
                 <a:solidFill>
                   <a:srgbClr val="FFFFFF"/>
                 </a:solidFill>
               </a:rPr>
-              <a:t>• Carbon proxy = (Azure compute + storage emissions) / active learners</a:t>
+              <a:t>• DPIA · Data Protection Impact Assessment (GDPR Art. 35)</a:t>
             </a:r>
           </a:p>
           <a:p>
             <a:pPr/>
             <a:r>
-              <a:rPr sz="1800" b="0">
+              <a:rPr sz="1600" b="0">
                 <a:solidFill>
                   <a:srgbClr val="FFFFFF"/>
                 </a:solidFill>
               </a:rPr>
-              <a:t>• Microsoft Emissions Impact Dashboard as primary source</a:t>
+              <a:t>• PPML · Privacy-Preserving Machine Learning (FL + DP + CC)</a:t>
             </a:r>
           </a:p>
           <a:p>
             <a:pPr/>
             <a:r>
-              <a:rPr sz="1800" b="0">
+              <a:rPr sz="1600" b="0">
                 <a:solidFill>
                   <a:srgbClr val="FFFFFF"/>
                 </a:solidFill>
               </a:rPr>
-              <a:t>• On-device inference reduces server-side carbon by design</a:t>
+              <a:t>• RAI · Responsible AI · ECE · Expected Calibration Error</a:t>
             </a:r>
           </a:p>
           <a:p>
             <a:pPr/>
             <a:r>
-              <a:rPr sz="1800" b="0">
+              <a:rPr sz="1600" b="0">
                 <a:solidFill>
                   <a:srgbClr val="FFFFFF"/>
                 </a:solidFill>
               </a:rPr>
-              <a:t>• Reported quarterly into group ESG narrative</a:t>
+              <a:t>• APIM · Azure API Management · AML · Azure Machine Learning</a:t>
+            </a:r>
+          </a:p>
+          <a:p>
+            <a:pPr/>
+            <a:r>
+              <a:rPr sz="1600" b="0">
+                <a:solidFill>
+                  <a:srgbClr val="FFFFFF"/>
+                </a:solidFill>
+              </a:rPr>
+              <a:t>• WORM · Write Once Read Many · CMK · Customer-Managed Keys</a:t>
+            </a:r>
+          </a:p>
+          <a:p>
+            <a:pPr/>
+            <a:r>
+              <a:rPr sz="1600" b="0">
+                <a:solidFill>
+                  <a:srgbClr val="FFFFFF"/>
+                </a:solidFill>
+              </a:rPr>
+              <a:t>• PTU · Provisioned Throughput Units (Azure OpenAI)</a:t>
             </a:r>
           </a:p>
         </p:txBody>
@@ -28554,301 +28628,6 @@
                   <a:srgbClr val="F28C00"/>
                 </a:solidFill>
               </a:rPr>
-              <a:t>REDUCTION LEVERS</a:t>
-            </a:r>
-          </a:p>
-          <a:p>
-            <a:pPr/>
-            <a:r>
-              <a:rPr sz="1800" b="0">
-                <a:solidFill>
-                  <a:srgbClr val="FFFFFF"/>
-                </a:solidFill>
-              </a:rPr>
-              <a:t>• Region selection prioritises EU regions with high renewable share</a:t>
-            </a:r>
-          </a:p>
-          <a:p>
-            <a:pPr/>
-            <a:r>
-              <a:rPr sz="1800" b="0">
-                <a:solidFill>
-                  <a:srgbClr val="FFFFFF"/>
-                </a:solidFill>
-              </a:rPr>
-              <a:t>• Small-first model routing (A07) directly reduces inference carbon</a:t>
-            </a:r>
-          </a:p>
-          <a:p>
-            <a:pPr/>
-            <a:r>
-              <a:rPr sz="1800" b="0">
-                <a:solidFill>
-                  <a:srgbClr val="FFFFFF"/>
-                </a:solidFill>
-              </a:rPr>
-              <a:t>• Reserved capacity for predictable Fabric load → better PUE utilisation</a:t>
-            </a:r>
-          </a:p>
-          <a:p>
-            <a:pPr/>
-            <a:r>
-              <a:rPr sz="1800" b="0">
-                <a:solidFill>
-                  <a:srgbClr val="FFFFFF"/>
-                </a:solidFill>
-              </a:rPr>
-              <a:t>• Decommissioning of legacy on-prem grading systems</a:t>
-            </a:r>
-          </a:p>
-        </p:txBody>
-      </p:sp>
-    </p:spTree>
-  </p:cSld>
-  <p:clrMapOvr>
-    <a:masterClrMapping/>
-  </p:clrMapOvr>
-</p:sld>
-</file>
-
-<file path=ppt/slides/slide38.xml><?xml version="1.0" encoding="utf-8"?>
-<p:sld xmlns:a="http://schemas.openxmlformats.org/drawingml/2006/main" xmlns:p="http://schemas.openxmlformats.org/presentationml/2006/main" xmlns:r="http://schemas.openxmlformats.org/officeDocument/2006/relationships">
-  <p:cSld>
-    <p:spTree>
-      <p:nvGrpSpPr>
-        <p:cNvPr id="1" name=""/>
-        <p:cNvGrpSpPr/>
-        <p:nvPr/>
-      </p:nvGrpSpPr>
-      <p:grpSpPr/>
-      <p:sp>
-        <p:nvSpPr>
-          <p:cNvPr id="2" name="Title 1"/>
-          <p:cNvSpPr>
-            <a:spLocks noGrp="1"/>
-          </p:cNvSpPr>
-          <p:nvPr>
-            <p:ph type="title"/>
-          </p:nvPr>
-        </p:nvSpPr>
-        <p:spPr/>
-        <p:txBody>
-          <a:bodyPr/>
-          <a:lstStyle/>
-          <a:p>
-            <a:r>
-              <a:rPr>
-                <a:solidFill>
-                  <a:srgbClr val="FFFFFF"/>
-                </a:solidFill>
-              </a:rPr>
-              <a:t>A17 · Acronyms and source documents</a:t>
-            </a:r>
-          </a:p>
-        </p:txBody>
-      </p:sp>
-      <p:sp>
-        <p:nvSpPr>
-          <p:cNvPr id="3" name="TextBox 2"/>
-          <p:cNvSpPr txBox="1"/>
-          <p:nvPr/>
-        </p:nvSpPr>
-        <p:spPr>
-          <a:xfrm>
-            <a:off x="640000" y="950000"/>
-            <a:ext cx="10912000" cy="360000"/>
-          </a:xfrm>
-          <a:prstGeom prst="rect">
-            <a:avLst/>
-          </a:prstGeom>
-          <a:noFill/>
-        </p:spPr>
-        <p:txBody>
-          <a:bodyPr wrap="square">
-            <a:spAutoFit/>
-          </a:bodyPr>
-          <a:lstStyle/>
-          <a:p>
-            <a:r>
-              <a:rPr sz="1800" i="1">
-                <a:solidFill>
-                  <a:srgbClr val="C8D4E6"/>
-                </a:solidFill>
-              </a:rPr>
-              <a:t>Everything traceable, nothing invented</a:t>
-            </a:r>
-          </a:p>
-        </p:txBody>
-      </p:sp>
-      <p:sp>
-        <p:nvSpPr>
-          <p:cNvPr id="4" name="Rounded Rectangle 3"/>
-          <p:cNvSpPr/>
-          <p:nvPr/>
-        </p:nvSpPr>
-        <p:spPr>
-          <a:xfrm>
-            <a:off x="600000" y="1400000"/>
-            <a:ext cx="5376000" cy="5098000"/>
-          </a:xfrm>
-          <a:prstGeom prst="roundRect">
-            <a:avLst/>
-          </a:prstGeom>
-          <a:solidFill>
-            <a:srgbClr val="122A4A"/>
-          </a:solidFill>
-          <a:ln w="12700">
-            <a:solidFill>
-              <a:srgbClr val="2A4A78"/>
-            </a:solidFill>
-          </a:ln>
-          <a:effectLst/>
-        </p:spPr>
-        <p:style>
-          <a:lnRef idx="1">
-            <a:schemeClr val="accent1"/>
-          </a:lnRef>
-          <a:fillRef idx="3">
-            <a:schemeClr val="accent1"/>
-          </a:fillRef>
-          <a:effectRef idx="2">
-            <a:schemeClr val="accent1"/>
-          </a:effectRef>
-          <a:fontRef idx="minor">
-            <a:schemeClr val="lt1"/>
-          </a:fontRef>
-        </p:style>
-        <p:txBody>
-          <a:bodyPr rtlCol="0" anchor="t" wrap="square" lIns="120000" rIns="120000" tIns="80000" bIns="80000"/>
-          <a:lstStyle/>
-          <a:p>
-            <a:pPr algn="ctr"/>
-            <a:r>
-              <a:rPr sz="1600" b="1">
-                <a:solidFill>
-                  <a:srgbClr val="F28C00"/>
-                </a:solidFill>
-              </a:rPr>
-              <a:t>ACRONYMS</a:t>
-            </a:r>
-          </a:p>
-          <a:p>
-            <a:pPr/>
-            <a:r>
-              <a:rPr sz="1600" b="0">
-                <a:solidFill>
-                  <a:srgbClr val="FFFFFF"/>
-                </a:solidFill>
-              </a:rPr>
-              <a:t>• DPIA · Data Protection Impact Assessment (GDPR Art. 35)</a:t>
-            </a:r>
-          </a:p>
-          <a:p>
-            <a:pPr/>
-            <a:r>
-              <a:rPr sz="1600" b="0">
-                <a:solidFill>
-                  <a:srgbClr val="FFFFFF"/>
-                </a:solidFill>
-              </a:rPr>
-              <a:t>• PPML · Privacy-Preserving Machine Learning (FL + DP + CC)</a:t>
-            </a:r>
-          </a:p>
-          <a:p>
-            <a:pPr/>
-            <a:r>
-              <a:rPr sz="1600" b="0">
-                <a:solidFill>
-                  <a:srgbClr val="FFFFFF"/>
-                </a:solidFill>
-              </a:rPr>
-              <a:t>• RAI · Responsible AI · ECE · Expected Calibration Error</a:t>
-            </a:r>
-          </a:p>
-          <a:p>
-            <a:pPr/>
-            <a:r>
-              <a:rPr sz="1600" b="0">
-                <a:solidFill>
-                  <a:srgbClr val="FFFFFF"/>
-                </a:solidFill>
-              </a:rPr>
-              <a:t>• APIM · Azure API Management · AML · Azure Machine Learning</a:t>
-            </a:r>
-          </a:p>
-          <a:p>
-            <a:pPr/>
-            <a:r>
-              <a:rPr sz="1600" b="0">
-                <a:solidFill>
-                  <a:srgbClr val="FFFFFF"/>
-                </a:solidFill>
-              </a:rPr>
-              <a:t>• WORM · Write Once Read Many · CMK · Customer-Managed Keys</a:t>
-            </a:r>
-          </a:p>
-          <a:p>
-            <a:pPr/>
-            <a:r>
-              <a:rPr sz="1600" b="0">
-                <a:solidFill>
-                  <a:srgbClr val="FFFFFF"/>
-                </a:solidFill>
-              </a:rPr>
-              <a:t>• PTU · Provisioned Throughput Units (Azure OpenAI)</a:t>
-            </a:r>
-          </a:p>
-        </p:txBody>
-      </p:sp>
-      <p:sp>
-        <p:nvSpPr>
-          <p:cNvPr id="5" name="Rounded Rectangle 4"/>
-          <p:cNvSpPr/>
-          <p:nvPr/>
-        </p:nvSpPr>
-        <p:spPr>
-          <a:xfrm>
-            <a:off x="6216000" y="1400000"/>
-            <a:ext cx="5376000" cy="5098000"/>
-          </a:xfrm>
-          <a:prstGeom prst="roundRect">
-            <a:avLst/>
-          </a:prstGeom>
-          <a:solidFill>
-            <a:srgbClr val="122A4A"/>
-          </a:solidFill>
-          <a:ln w="12700">
-            <a:solidFill>
-              <a:srgbClr val="2A4A78"/>
-            </a:solidFill>
-          </a:ln>
-          <a:effectLst/>
-        </p:spPr>
-        <p:style>
-          <a:lnRef idx="1">
-            <a:schemeClr val="accent1"/>
-          </a:lnRef>
-          <a:fillRef idx="3">
-            <a:schemeClr val="accent1"/>
-          </a:fillRef>
-          <a:effectRef idx="2">
-            <a:schemeClr val="accent1"/>
-          </a:effectRef>
-          <a:fontRef idx="minor">
-            <a:schemeClr val="lt1"/>
-          </a:fontRef>
-        </p:style>
-        <p:txBody>
-          <a:bodyPr rtlCol="0" anchor="t" wrap="square" lIns="120000" rIns="120000" tIns="80000" bIns="80000"/>
-          <a:lstStyle/>
-          <a:p>
-            <a:pPr algn="ctr"/>
-            <a:r>
-              <a:rPr sz="1600" b="1">
-                <a:solidFill>
-                  <a:srgbClr val="F28C00"/>
-                </a:solidFill>
-              </a:rPr>
               <a:t>SOURCE DOCUMENTS</a:t>
             </a:r>
           </a:p>
@@ -28952,28 +28731,43 @@
         <p:txBody>
           <a:bodyPr/>
           <a:lstStyle/>
-          <a:p>
-            <a:r>
-              <a:rPr>
-                <a:solidFill>
-                  <a:srgbClr val="FFFFFF"/>
-                </a:solidFill>
-              </a:rPr>
-              <a:t>Compliance is the moat, not the cost</a:t>
-            </a:r>
-          </a:p>
+          <a:p/>
         </p:txBody>
       </p:sp>
-      <p:sp>
-        <p:nvSpPr>
-          <p:cNvPr id="3" name="TextBox 2"/>
+      <p:pic>
+        <p:nvPicPr>
+          <p:cNvPr id="3" name="Picture 2" descr="bg-hero-orange.png"/>
+          <p:cNvPicPr>
+            <a:picLocks noChangeAspect="1"/>
+          </p:cNvPicPr>
+          <p:nvPr/>
+        </p:nvPicPr>
+        <p:blipFill>
+          <a:blip r:embed="rId2"/>
+          <a:stretch>
+            <a:fillRect/>
+          </a:stretch>
+        </p:blipFill>
+        <p:spPr>
+          <a:xfrm>
+            <a:off x="0" y="0"/>
+            <a:ext cx="12192000" cy="6858000"/>
+          </a:xfrm>
+          <a:prstGeom prst="rect">
+            <a:avLst/>
+          </a:prstGeom>
+        </p:spPr>
+      </p:pic>
+      <p:sp>
+        <p:nvSpPr>
+          <p:cNvPr id="4" name="TextBox 3"/>
           <p:cNvSpPr txBox="1"/>
           <p:nvPr/>
         </p:nvSpPr>
         <p:spPr>
           <a:xfrm>
-            <a:off x="640000" y="950000"/>
-            <a:ext cx="10912000" cy="360000"/>
+            <a:off x="800000" y="800000"/>
+            <a:ext cx="400000" cy="800000"/>
           </a:xfrm>
           <a:prstGeom prst="rect">
             <a:avLst/>
@@ -28987,208 +28781,80 @@
           <a:lstStyle/>
           <a:p>
             <a:r>
-              <a:rPr sz="1800" i="1">
-                <a:solidFill>
-                  <a:srgbClr val="C8D4E6"/>
-                </a:solidFill>
-              </a:rPr>
-              <a:t>"European, by design" is a sellable category — we own it first</a:t>
+              <a:rPr sz="22000" b="1" i="0">
+                <a:solidFill>
+                  <a:srgbClr val="F28C00"/>
+                </a:solidFill>
+              </a:rPr>
+              <a:t>“</a:t>
             </a:r>
           </a:p>
         </p:txBody>
       </p:sp>
       <p:sp>
         <p:nvSpPr>
-          <p:cNvPr id="4" name="Rounded Rectangle 3"/>
-          <p:cNvSpPr/>
+          <p:cNvPr id="5" name="TextBox 4"/>
+          <p:cNvSpPr txBox="1"/>
           <p:nvPr/>
         </p:nvSpPr>
         <p:spPr>
           <a:xfrm>
-            <a:off x="600000" y="1400000"/>
-            <a:ext cx="5376000" cy="5098000"/>
+            <a:off x="1200000" y="1600000"/>
+            <a:ext cx="9792000" cy="3400000"/>
           </a:xfrm>
-          <a:prstGeom prst="roundRect">
+          <a:prstGeom prst="rect">
             <a:avLst/>
           </a:prstGeom>
-          <a:solidFill>
-            <a:srgbClr val="122A4A"/>
-          </a:solidFill>
-          <a:ln w="12700">
-            <a:solidFill>
-              <a:srgbClr val="2A4A78"/>
-            </a:solidFill>
-          </a:ln>
-          <a:effectLst/>
+          <a:noFill/>
         </p:spPr>
-        <p:style>
-          <a:lnRef idx="1">
-            <a:schemeClr val="accent1"/>
-          </a:lnRef>
-          <a:fillRef idx="3">
-            <a:schemeClr val="accent1"/>
-          </a:fillRef>
-          <a:effectRef idx="2">
-            <a:schemeClr val="accent1"/>
-          </a:effectRef>
-          <a:fontRef idx="minor">
-            <a:schemeClr val="lt1"/>
-          </a:fontRef>
-        </p:style>
         <p:txBody>
-          <a:bodyPr rtlCol="0" anchor="t" wrap="square" lIns="120000" rIns="120000" tIns="80000" bIns="80000"/>
+          <a:bodyPr wrap="square">
+            <a:spAutoFit/>
+          </a:bodyPr>
           <a:lstStyle/>
           <a:p>
             <a:pPr algn="ctr"/>
             <a:r>
-              <a:rPr sz="1600" b="1">
-                <a:solidFill>
-                  <a:srgbClr val="F28C00"/>
-                </a:solidFill>
-              </a:rPr>
-              <a:t>THESIS</a:t>
-            </a:r>
-          </a:p>
-          <a:p>
-            <a:pPr/>
-            <a:r>
-              <a:rPr sz="1800" b="0">
+              <a:rPr sz="4400" b="0" i="0">
                 <a:solidFill>
                   <a:srgbClr val="FFFFFF"/>
                 </a:solidFill>
               </a:rPr>
-              <a:t>• Ministries will only buy EU-resident, AI-Act-compliant edtech by 2027</a:t>
-            </a:r>
-          </a:p>
-          <a:p>
-            <a:pPr/>
-            <a:r>
-              <a:rPr sz="1800" b="0">
-                <a:solidFill>
-                  <a:srgbClr val="FFFFFF"/>
-                </a:solidFill>
-              </a:rPr>
-              <a:t>• Privacy-preserving ML (on-device + federated) is now production-grade</a:t>
-            </a:r>
-          </a:p>
-          <a:p>
-            <a:pPr/>
-            <a:r>
-              <a:rPr sz="1800" b="0">
-                <a:solidFill>
-                  <a:srgbClr val="FFFFFF"/>
-                </a:solidFill>
-              </a:rPr>
-              <a:t>• Teacher-in-the-loop becomes a *feature*, not a constraint</a:t>
-            </a:r>
-          </a:p>
-          <a:p>
-            <a:pPr/>
-            <a:r>
-              <a:rPr sz="1800" b="0">
-                <a:solidFill>
-                  <a:srgbClr val="FFFFFF"/>
-                </a:solidFill>
-              </a:rPr>
-              <a:t>• Pedagogy + AI + governance must be one product, not three procurements</a:t>
+              <a:t>Compliance is not a tax on the product. It is the product.</a:t>
             </a:r>
           </a:p>
         </p:txBody>
       </p:sp>
       <p:sp>
         <p:nvSpPr>
-          <p:cNvPr id="5" name="Rounded Rectangle 4"/>
-          <p:cNvSpPr/>
+          <p:cNvPr id="6" name="TextBox 5"/>
+          <p:cNvSpPr txBox="1"/>
           <p:nvPr/>
         </p:nvSpPr>
         <p:spPr>
           <a:xfrm>
-            <a:off x="6216000" y="1400000"/>
-            <a:ext cx="5376000" cy="5098000"/>
+            <a:off x="600000" y="5500000"/>
+            <a:ext cx="10992000" cy="500000"/>
           </a:xfrm>
-          <a:prstGeom prst="roundRect">
+          <a:prstGeom prst="rect">
             <a:avLst/>
           </a:prstGeom>
-          <a:solidFill>
-            <a:srgbClr val="122A4A"/>
-          </a:solidFill>
-          <a:ln w="12700">
-            <a:solidFill>
-              <a:srgbClr val="2A4A78"/>
-            </a:solidFill>
-          </a:ln>
-          <a:effectLst/>
+          <a:noFill/>
         </p:spPr>
-        <p:style>
-          <a:lnRef idx="1">
-            <a:schemeClr val="accent1"/>
-          </a:lnRef>
-          <a:fillRef idx="3">
-            <a:schemeClr val="accent1"/>
-          </a:fillRef>
-          <a:effectRef idx="2">
-            <a:schemeClr val="accent1"/>
-          </a:effectRef>
-          <a:fontRef idx="minor">
-            <a:schemeClr val="lt1"/>
-          </a:fontRef>
-        </p:style>
         <p:txBody>
-          <a:bodyPr rtlCol="0" anchor="t" wrap="square" lIns="120000" rIns="120000" tIns="80000" bIns="80000"/>
+          <a:bodyPr wrap="square">
+            <a:spAutoFit/>
+          </a:bodyPr>
           <a:lstStyle/>
           <a:p>
             <a:pPr algn="ctr"/>
             <a:r>
-              <a:rPr sz="1600" b="1">
-                <a:solidFill>
-                  <a:srgbClr val="F28C00"/>
-                </a:solidFill>
-              </a:rPr>
-              <a:t>HOW WE DIFFERENTIATE</a:t>
-            </a:r>
-          </a:p>
-          <a:p>
-            <a:pPr/>
-            <a:r>
-              <a:rPr sz="1800" b="0">
-                <a:solidFill>
-                  <a:srgbClr val="FFFFFF"/>
-                </a:solidFill>
-              </a:rPr>
-              <a:t>• Default = on-device inference (ONNX) — minor data never leaves the browser</a:t>
-            </a:r>
-          </a:p>
-          <a:p>
-            <a:pPr/>
-            <a:r>
-              <a:rPr sz="1800" b="0">
-                <a:solidFill>
-                  <a:srgbClr val="FFFFFF"/>
-                </a:solidFill>
-              </a:rPr>
-              <a:t>• Federated training with differential privacy across 5 markets</a:t>
-            </a:r>
-          </a:p>
-          <a:p>
-            <a:pPr/>
-            <a:r>
-              <a:rPr sz="1800" b="0">
-                <a:solidFill>
-                  <a:srgbClr val="FFFFFF"/>
-                </a:solidFill>
-              </a:rPr>
-              <a:t>• Full Annex IV technical file as a sales asset, not a paperwork drag</a:t>
-            </a:r>
-          </a:p>
-          <a:p>
-            <a:pPr/>
-            <a:r>
-              <a:rPr sz="1800" b="0">
-                <a:solidFill>
-                  <a:srgbClr val="FFFFFF"/>
-                </a:solidFill>
-              </a:rPr>
-              <a:t>• Localisation as a *pipeline*, not a project — 6-week SLA per market</a:t>
+              <a:rPr sz="2200" b="0" i="1">
+                <a:solidFill>
+                  <a:srgbClr val="C8D4E6"/>
+                </a:solidFill>
+              </a:rPr>
+              <a:t>— LearnEU programme thesis</a:t>
             </a:r>
           </a:p>
         </p:txBody>
@@ -29225,28 +28891,43 @@
         <p:txBody>
           <a:bodyPr/>
           <a:lstStyle/>
-          <a:p>
-            <a:r>
-              <a:rPr>
-                <a:solidFill>
-                  <a:srgbClr val="FFFFFF"/>
-                </a:solidFill>
-              </a:rPr>
-              <a:t>Four numbers, contractually owned, board-reviewed monthly</a:t>
-            </a:r>
-          </a:p>
+          <a:p/>
         </p:txBody>
       </p:sp>
-      <p:sp>
-        <p:nvSpPr>
-          <p:cNvPr id="3" name="TextBox 2"/>
+      <p:pic>
+        <p:nvPicPr>
+          <p:cNvPr id="3" name="Picture 2" descr="stat-reduction.png"/>
+          <p:cNvPicPr>
+            <a:picLocks noChangeAspect="1"/>
+          </p:cNvPicPr>
+          <p:nvPr/>
+        </p:nvPicPr>
+        <p:blipFill>
+          <a:blip r:embed="rId2"/>
+          <a:stretch>
+            <a:fillRect/>
+          </a:stretch>
+        </p:blipFill>
+        <p:spPr>
+          <a:xfrm>
+            <a:off x="0" y="0"/>
+            <a:ext cx="12192000" cy="6858000"/>
+          </a:xfrm>
+          <a:prstGeom prst="rect">
+            <a:avLst/>
+          </a:prstGeom>
+        </p:spPr>
+      </p:pic>
+      <p:sp>
+        <p:nvSpPr>
+          <p:cNvPr id="4" name="TextBox 3"/>
           <p:cNvSpPr txBox="1"/>
           <p:nvPr/>
         </p:nvSpPr>
         <p:spPr>
           <a:xfrm>
-            <a:off x="640000" y="950000"/>
-            <a:ext cx="10912000" cy="360000"/>
+            <a:off x="600000" y="360000"/>
+            <a:ext cx="10992000" cy="540000"/>
           </a:xfrm>
           <a:prstGeom prst="rect">
             <a:avLst/>
@@ -29259,231 +28940,48 @@
           </a:bodyPr>
           <a:lstStyle/>
           <a:p>
-            <a:r>
-              <a:rPr sz="1800" i="1">
-                <a:solidFill>
-                  <a:srgbClr val="C8D4E6"/>
-                </a:solidFill>
-              </a:rPr>
-              <a:t>Targets are case-study verbatim — no padding, no softening</a:t>
+            <a:pPr algn="ctr"/>
+            <a:r>
+              <a:rPr sz="3000" b="1" i="0">
+                <a:solidFill>
+                  <a:srgbClr val="FFFFFF"/>
+                </a:solidFill>
+              </a:rPr>
+              <a:t>What we sign for</a:t>
             </a:r>
           </a:p>
         </p:txBody>
       </p:sp>
       <p:sp>
         <p:nvSpPr>
-          <p:cNvPr id="4" name="Rounded Rectangle 3"/>
-          <p:cNvSpPr/>
+          <p:cNvPr id="5" name="TextBox 4"/>
+          <p:cNvSpPr txBox="1"/>
           <p:nvPr/>
         </p:nvSpPr>
         <p:spPr>
           <a:xfrm>
-            <a:off x="600000" y="1400000"/>
-            <a:ext cx="5376000" cy="5098000"/>
+            <a:off x="600000" y="5900000"/>
+            <a:ext cx="10992000" cy="540000"/>
           </a:xfrm>
-          <a:prstGeom prst="roundRect">
+          <a:prstGeom prst="rect">
             <a:avLst/>
           </a:prstGeom>
-          <a:solidFill>
-            <a:srgbClr val="122A4A"/>
-          </a:solidFill>
-          <a:ln w="12700">
-            <a:solidFill>
-              <a:srgbClr val="2A4A78"/>
-            </a:solidFill>
-          </a:ln>
-          <a:effectLst/>
+          <a:noFill/>
         </p:spPr>
-        <p:style>
-          <a:lnRef idx="1">
-            <a:schemeClr val="accent1"/>
-          </a:lnRef>
-          <a:fillRef idx="3">
-            <a:schemeClr val="accent1"/>
-          </a:fillRef>
-          <a:effectRef idx="2">
-            <a:schemeClr val="accent1"/>
-          </a:effectRef>
-          <a:fontRef idx="minor">
-            <a:schemeClr val="lt1"/>
-          </a:fontRef>
-        </p:style>
         <p:txBody>
-          <a:bodyPr rtlCol="0" anchor="t" wrap="square" lIns="120000" rIns="120000" tIns="80000" bIns="80000"/>
+          <a:bodyPr wrap="square">
+            <a:spAutoFit/>
+          </a:bodyPr>
           <a:lstStyle/>
           <a:p>
             <a:pPr algn="ctr"/>
             <a:r>
-              <a:rPr sz="1600" b="1">
-                <a:solidFill>
-                  <a:srgbClr val="F28C00"/>
-                </a:solidFill>
-              </a:rPr>
-              <a:t>OUTCOME TARGETS</a:t>
-            </a:r>
-          </a:p>
-          <a:p>
-            <a:pPr/>
-            <a:r>
-              <a:rPr sz="1800" b="0">
-                <a:solidFill>
-                  <a:srgbClr val="FFFFFF"/>
-                </a:solidFill>
-              </a:rPr>
-              <a:t>• K1 · Outcome gap (high vs low schools): 40% → −26 pp reduction</a:t>
-            </a:r>
-          </a:p>
-          <a:p>
-            <a:pPr/>
-            <a:r>
-              <a:rPr sz="1800" b="0">
-                <a:solidFill>
-                  <a:srgbClr val="FFFFFF"/>
-                </a:solidFill>
-              </a:rPr>
-              <a:t>• K2 · Teacher administrative time: −45%</a:t>
-            </a:r>
-          </a:p>
-          <a:p>
-            <a:pPr/>
-            <a:r>
-              <a:rPr sz="1800" b="0">
-                <a:solidFill>
-                  <a:srgbClr val="FFFFFF"/>
-                </a:solidFill>
-              </a:rPr>
-              <a:t>• K3 · Localisation cycle: 12 months → 6 weeks (≈ 87% faster)</a:t>
-            </a:r>
-          </a:p>
-          <a:p>
-            <a:pPr/>
-            <a:r>
-              <a:rPr sz="1800" b="0">
-                <a:solidFill>
-                  <a:srgbClr val="FFFFFF"/>
-                </a:solidFill>
-              </a:rPr>
-              <a:t>• K4 · GDPR Art. 8 compliance: 100% maintained, 0 breaches</a:t>
-            </a:r>
-          </a:p>
-          <a:p>
-            <a:pPr/>
-            <a:r>
-              <a:rPr sz="1800" b="0">
-                <a:solidFill>
-                  <a:srgbClr val="FFFFFF"/>
-                </a:solidFill>
-              </a:rPr>
-              <a:t>• K5 · EU AI Act conformity: CE-marked before phase-3 exit (month 10)</a:t>
-            </a:r>
-          </a:p>
-        </p:txBody>
-      </p:sp>
-      <p:sp>
-        <p:nvSpPr>
-          <p:cNvPr id="5" name="Rounded Rectangle 4"/>
-          <p:cNvSpPr/>
-          <p:nvPr/>
-        </p:nvSpPr>
-        <p:spPr>
-          <a:xfrm>
-            <a:off x="6216000" y="1400000"/>
-            <a:ext cx="5376000" cy="5098000"/>
-          </a:xfrm>
-          <a:prstGeom prst="roundRect">
-            <a:avLst/>
-          </a:prstGeom>
-          <a:solidFill>
-            <a:srgbClr val="122A4A"/>
-          </a:solidFill>
-          <a:ln w="12700">
-            <a:solidFill>
-              <a:srgbClr val="2A4A78"/>
-            </a:solidFill>
-          </a:ln>
-          <a:effectLst/>
-        </p:spPr>
-        <p:style>
-          <a:lnRef idx="1">
-            <a:schemeClr val="accent1"/>
-          </a:lnRef>
-          <a:fillRef idx="3">
-            <a:schemeClr val="accent1"/>
-          </a:fillRef>
-          <a:effectRef idx="2">
-            <a:schemeClr val="accent1"/>
-          </a:effectRef>
-          <a:fontRef idx="minor">
-            <a:schemeClr val="lt1"/>
-          </a:fontRef>
-        </p:style>
-        <p:txBody>
-          <a:bodyPr rtlCol="0" anchor="t" wrap="square" lIns="120000" rIns="120000" tIns="80000" bIns="80000"/>
-          <a:lstStyle/>
-          <a:p>
-            <a:pPr algn="ctr"/>
-            <a:r>
-              <a:rPr sz="1600" b="1">
-                <a:solidFill>
-                  <a:srgbClr val="F28C00"/>
-                </a:solidFill>
-              </a:rPr>
-              <a:t>HOW WE PROVE IT MONTHLY</a:t>
-            </a:r>
-          </a:p>
-          <a:p>
-            <a:pPr/>
-            <a:r>
-              <a:rPr sz="1800" b="0">
-                <a:solidFill>
-                  <a:srgbClr val="FFFFFF"/>
-                </a:solidFill>
-              </a:rPr>
-              <a:t>• Per-cohort fairness disparity tracked in App Insights</a:t>
-            </a:r>
-          </a:p>
-          <a:p>
-            <a:pPr/>
-            <a:r>
-              <a:rPr sz="1800" b="0">
-                <a:solidFill>
-                  <a:srgbClr val="FFFFFF"/>
-                </a:solidFill>
-              </a:rPr>
-              <a:t>• Teacher minutes saved per assignment — telemetry + quarterly NPS</a:t>
-            </a:r>
-          </a:p>
-          <a:p>
-            <a:pPr/>
-            <a:r>
-              <a:rPr sz="1800" b="0">
-                <a:solidFill>
-                  <a:srgbClr val="FFFFFF"/>
-                </a:solidFill>
-              </a:rPr>
-              <a:t>• Units localised / week / market — Fabric pipeline counter</a:t>
-            </a:r>
-          </a:p>
-          <a:p>
-            <a:pPr/>
-            <a:r>
-              <a:rPr sz="1800" b="0">
-                <a:solidFill>
-                  <a:srgbClr val="FFFFFF"/>
-                </a:solidFill>
-              </a:rPr>
-              <a:t>• DPIA freshness ≤ 12mo per market — Purview report</a:t>
-            </a:r>
-          </a:p>
-          <a:p>
-            <a:pPr/>
-            <a:r>
-              <a:rPr sz="1800" b="0">
-                <a:solidFill>
-                  <a:srgbClr val="FFFFFF"/>
-                </a:solidFill>
-              </a:rPr>
-              <a:t>• Override rate, calibration error (ECE ≤ 0.05) — RAI dashboard</a:t>
+              <a:rPr sz="2200" b="0" i="1">
+                <a:solidFill>
+                  <a:srgbClr val="C8D4E6"/>
+                </a:solidFill>
+              </a:rPr>
+              <a:t>−26% gap · −45% teacher admin · 12mo → 6wk · 100% GDPR Art. 8</a:t>
             </a:r>
           </a:p>
         </p:txBody>
@@ -29520,28 +29018,43 @@
         <p:txBody>
           <a:bodyPr/>
           <a:lstStyle/>
-          <a:p>
-            <a:r>
-              <a:rPr>
-                <a:solidFill>
-                  <a:srgbClr val="FFFFFF"/>
-                </a:solidFill>
-              </a:rPr>
-              <a:t>~€55M annual value at run-rate, payback ≤ 24 months</a:t>
-            </a:r>
-          </a:p>
+          <a:p/>
         </p:txBody>
       </p:sp>
-      <p:sp>
-        <p:nvSpPr>
-          <p:cNvPr id="3" name="TextBox 2"/>
+      <p:pic>
+        <p:nvPicPr>
+          <p:cNvPr id="3" name="Picture 2" descr="stat-value.png"/>
+          <p:cNvPicPr>
+            <a:picLocks noChangeAspect="1"/>
+          </p:cNvPicPr>
+          <p:nvPr/>
+        </p:nvPicPr>
+        <p:blipFill>
+          <a:blip r:embed="rId2"/>
+          <a:stretch>
+            <a:fillRect/>
+          </a:stretch>
+        </p:blipFill>
+        <p:spPr>
+          <a:xfrm>
+            <a:off x="0" y="0"/>
+            <a:ext cx="12192000" cy="6858000"/>
+          </a:xfrm>
+          <a:prstGeom prst="rect">
+            <a:avLst/>
+          </a:prstGeom>
+        </p:spPr>
+      </p:pic>
+      <p:sp>
+        <p:nvSpPr>
+          <p:cNvPr id="4" name="TextBox 3"/>
           <p:cNvSpPr txBox="1"/>
           <p:nvPr/>
         </p:nvSpPr>
         <p:spPr>
           <a:xfrm>
-            <a:off x="640000" y="950000"/>
-            <a:ext cx="10912000" cy="360000"/>
+            <a:off x="600000" y="360000"/>
+            <a:ext cx="10992000" cy="540000"/>
           </a:xfrm>
           <a:prstGeom prst="rect">
             <a:avLst/>
@@ -29554,209 +29067,48 @@
           </a:bodyPr>
           <a:lstStyle/>
           <a:p>
-            <a:r>
-              <a:rPr sz="1800" i="1">
-                <a:solidFill>
-                  <a:srgbClr val="C8D4E6"/>
-                </a:solidFill>
-              </a:rPr>
-              <a:t>Three value pools, conservatively sized</a:t>
+            <a:pPr algn="ctr"/>
+            <a:r>
+              <a:rPr sz="3000" b="1" i="0">
+                <a:solidFill>
+                  <a:srgbClr val="FFFFFF"/>
+                </a:solidFill>
+              </a:rPr>
+              <a:t>Run-rate annual value</a:t>
             </a:r>
           </a:p>
         </p:txBody>
       </p:sp>
       <p:sp>
         <p:nvSpPr>
-          <p:cNvPr id="4" name="Rounded Rectangle 3"/>
-          <p:cNvSpPr/>
+          <p:cNvPr id="5" name="TextBox 4"/>
+          <p:cNvSpPr txBox="1"/>
           <p:nvPr/>
         </p:nvSpPr>
         <p:spPr>
           <a:xfrm>
-            <a:off x="600000" y="1400000"/>
-            <a:ext cx="5376000" cy="5098000"/>
+            <a:off x="600000" y="5900000"/>
+            <a:ext cx="10992000" cy="540000"/>
           </a:xfrm>
-          <a:prstGeom prst="roundRect">
+          <a:prstGeom prst="rect">
             <a:avLst/>
           </a:prstGeom>
-          <a:solidFill>
-            <a:srgbClr val="122A4A"/>
-          </a:solidFill>
-          <a:ln w="12700">
-            <a:solidFill>
-              <a:srgbClr val="2A4A78"/>
-            </a:solidFill>
-          </a:ln>
-          <a:effectLst/>
+          <a:noFill/>
         </p:spPr>
-        <p:style>
-          <a:lnRef idx="1">
-            <a:schemeClr val="accent1"/>
-          </a:lnRef>
-          <a:fillRef idx="3">
-            <a:schemeClr val="accent1"/>
-          </a:fillRef>
-          <a:effectRef idx="2">
-            <a:schemeClr val="accent1"/>
-          </a:effectRef>
-          <a:fontRef idx="minor">
-            <a:schemeClr val="lt1"/>
-          </a:fontRef>
-        </p:style>
         <p:txBody>
-          <a:bodyPr rtlCol="0" anchor="t" wrap="square" lIns="120000" rIns="120000" tIns="80000" bIns="80000"/>
+          <a:bodyPr wrap="square">
+            <a:spAutoFit/>
+          </a:bodyPr>
           <a:lstStyle/>
           <a:p>
             <a:pPr algn="ctr"/>
             <a:r>
-              <a:rPr sz="1600" b="1">
-                <a:solidFill>
-                  <a:srgbClr val="F28C00"/>
-                </a:solidFill>
-              </a:rPr>
-              <a:t>VALUE POOLS</a:t>
-            </a:r>
-          </a:p>
-          <a:p>
-            <a:pPr/>
-            <a:r>
-              <a:rPr sz="1800" b="0">
-                <a:solidFill>
-                  <a:srgbClr val="FFFFFF"/>
-                </a:solidFill>
-              </a:rPr>
-              <a:t>• Teacher productivity: −45% admin × ~120k teachers × €15/h saved ≈ €28M/yr</a:t>
-            </a:r>
-          </a:p>
-          <a:p>
-            <a:pPr/>
-            <a:r>
-              <a:rPr sz="1800" b="0">
-                <a:solidFill>
-                  <a:srgbClr val="FFFFFF"/>
-                </a:solidFill>
-              </a:rPr>
-              <a:t>• Market expansion: 3 new markets · 18 months earlier · ≈ €18M incremental ARR</a:t>
-            </a:r>
-          </a:p>
-          <a:p>
-            <a:pPr/>
-            <a:r>
-              <a:rPr sz="1800" b="0">
-                <a:solidFill>
-                  <a:srgbClr val="FFFFFF"/>
-                </a:solidFill>
-              </a:rPr>
-              <a:t>• Retention uplift from outcome gains: +2 pp churn reduction ≈ €9M/yr</a:t>
-            </a:r>
-          </a:p>
-          <a:p>
-            <a:pPr/>
-            <a:r>
-              <a:rPr sz="1800" b="0">
-                <a:solidFill>
-                  <a:srgbClr val="FFFFFF"/>
-                </a:solidFill>
-              </a:rPr>
-              <a:t>• Total annual run-rate value: ≈ €55M (steady-state, 5 markets)</a:t>
-            </a:r>
-          </a:p>
-        </p:txBody>
-      </p:sp>
-      <p:sp>
-        <p:nvSpPr>
-          <p:cNvPr id="5" name="Rounded Rectangle 4"/>
-          <p:cNvSpPr/>
-          <p:nvPr/>
-        </p:nvSpPr>
-        <p:spPr>
-          <a:xfrm>
-            <a:off x="6216000" y="1400000"/>
-            <a:ext cx="5376000" cy="5098000"/>
-          </a:xfrm>
-          <a:prstGeom prst="roundRect">
-            <a:avLst/>
-          </a:prstGeom>
-          <a:solidFill>
-            <a:srgbClr val="122A4A"/>
-          </a:solidFill>
-          <a:ln w="12700">
-            <a:solidFill>
-              <a:srgbClr val="2A4A78"/>
-            </a:solidFill>
-          </a:ln>
-          <a:effectLst/>
-        </p:spPr>
-        <p:style>
-          <a:lnRef idx="1">
-            <a:schemeClr val="accent1"/>
-          </a:lnRef>
-          <a:fillRef idx="3">
-            <a:schemeClr val="accent1"/>
-          </a:fillRef>
-          <a:effectRef idx="2">
-            <a:schemeClr val="accent1"/>
-          </a:effectRef>
-          <a:fontRef idx="minor">
-            <a:schemeClr val="lt1"/>
-          </a:fontRef>
-        </p:style>
-        <p:txBody>
-          <a:bodyPr rtlCol="0" anchor="t" wrap="square" lIns="120000" rIns="120000" tIns="80000" bIns="80000"/>
-          <a:lstStyle/>
-          <a:p>
-            <a:pPr algn="ctr"/>
-            <a:r>
-              <a:rPr sz="1600" b="1">
-                <a:solidFill>
-                  <a:srgbClr val="F28C00"/>
-                </a:solidFill>
-              </a:rPr>
-              <a:t>INVESTMENT &amp; PAYBACK</a:t>
-            </a:r>
-          </a:p>
-          <a:p>
-            <a:pPr/>
-            <a:r>
-              <a:rPr sz="1800" b="0">
-                <a:solidFill>
-                  <a:srgbClr val="FFFFFF"/>
-                </a:solidFill>
-              </a:rPr>
-              <a:t>• Programme cost over 12 months: €18–22M (build) + €6M/yr (run, FinOps optimised)</a:t>
-            </a:r>
-          </a:p>
-          <a:p>
-            <a:pPr/>
-            <a:r>
-              <a:rPr sz="1800" b="0">
-                <a:solidFill>
-                  <a:srgbClr val="FFFFFF"/>
-                </a:solidFill>
-              </a:rPr>
-              <a:t>• Break-even: month 22 on 3-market live, month 30 on full 5</a:t>
-            </a:r>
-          </a:p>
-          <a:p>
-            <a:pPr/>
-            <a:r>
-              <a:rPr sz="1800" b="0">
-                <a:solidFill>
-                  <a:srgbClr val="FFFFFF"/>
-                </a:solidFill>
-              </a:rPr>
-              <a:t>• Sensitivity: ±20% on adoption ramp changes payback by ±4 months</a:t>
-            </a:r>
-          </a:p>
-          <a:p>
-            <a:pPr/>
-            <a:r>
-              <a:rPr sz="1800" b="0">
-                <a:solidFill>
-                  <a:srgbClr val="FFFFFF"/>
-                </a:solidFill>
-              </a:rPr>
-              <a:t>• Compliance is sunk regardless — doing it inside the programme avoids re-work</a:t>
+              <a:rPr sz="2200" b="0" i="1">
+                <a:solidFill>
+                  <a:srgbClr val="C8D4E6"/>
+                </a:solidFill>
+              </a:rPr>
+              <a:t>Payback ≤ 24 months on three markets live</a:t>
             </a:r>
           </a:p>
         </p:txBody>
@@ -29793,28 +29145,43 @@
         <p:txBody>
           <a:bodyPr/>
           <a:lstStyle/>
-          <a:p>
-            <a:r>
-              <a:rPr>
-                <a:solidFill>
-                  <a:srgbClr val="FFFFFF"/>
-                </a:solidFill>
-              </a:rPr>
-              <a:t>Three personas, three measurable wins</a:t>
-            </a:r>
-          </a:p>
+          <a:p/>
         </p:txBody>
       </p:sp>
-      <p:sp>
-        <p:nvSpPr>
-          <p:cNvPr id="3" name="TextBox 2"/>
+      <p:pic>
+        <p:nvPicPr>
+          <p:cNvPr id="3" name="Picture 2" descr="bg-dark-grid.png"/>
+          <p:cNvPicPr>
+            <a:picLocks noChangeAspect="1"/>
+          </p:cNvPicPr>
+          <p:nvPr/>
+        </p:nvPicPr>
+        <p:blipFill>
+          <a:blip r:embed="rId2"/>
+          <a:stretch>
+            <a:fillRect/>
+          </a:stretch>
+        </p:blipFill>
+        <p:spPr>
+          <a:xfrm>
+            <a:off x="0" y="0"/>
+            <a:ext cx="12192000" cy="6858000"/>
+          </a:xfrm>
+          <a:prstGeom prst="rect">
+            <a:avLst/>
+          </a:prstGeom>
+        </p:spPr>
+      </p:pic>
+      <p:sp>
+        <p:nvSpPr>
+          <p:cNvPr id="4" name="TextBox 3"/>
           <p:cNvSpPr txBox="1"/>
           <p:nvPr/>
         </p:nvSpPr>
         <p:spPr>
           <a:xfrm>
-            <a:off x="640000" y="950000"/>
-            <a:ext cx="10912000" cy="360000"/>
+            <a:off x="600000" y="360000"/>
+            <a:ext cx="10992000" cy="540000"/>
           </a:xfrm>
           <a:prstGeom prst="rect">
             <a:avLst/>
@@ -29827,209 +29194,288 @@
           </a:bodyPr>
           <a:lstStyle/>
           <a:p>
-            <a:r>
-              <a:rPr sz="1800" i="1">
-                <a:solidFill>
-                  <a:srgbClr val="C8D4E6"/>
-                </a:solidFill>
-              </a:rPr>
-              <a:t>Learner · Teacher · Parent — each gets less of what they hate</a:t>
+            <a:pPr algn="ctr"/>
+            <a:r>
+              <a:rPr sz="3600" b="1" i="0">
+                <a:solidFill>
+                  <a:srgbClr val="FFFFFF"/>
+                </a:solidFill>
+              </a:rPr>
+              <a:t>Less of what they hate. More of what works.</a:t>
             </a:r>
           </a:p>
         </p:txBody>
       </p:sp>
       <p:sp>
         <p:nvSpPr>
-          <p:cNvPr id="4" name="Rounded Rectangle 3"/>
-          <p:cNvSpPr/>
+          <p:cNvPr id="5" name="TextBox 4"/>
+          <p:cNvSpPr txBox="1"/>
           <p:nvPr/>
         </p:nvSpPr>
         <p:spPr>
           <a:xfrm>
-            <a:off x="600000" y="1400000"/>
-            <a:ext cx="5376000" cy="5098000"/>
+            <a:off x="600000" y="920000"/>
+            <a:ext cx="10992000" cy="480000"/>
           </a:xfrm>
-          <a:prstGeom prst="roundRect">
+          <a:prstGeom prst="rect">
             <a:avLst/>
           </a:prstGeom>
-          <a:solidFill>
-            <a:srgbClr val="122A4A"/>
-          </a:solidFill>
-          <a:ln w="12700">
-            <a:solidFill>
-              <a:srgbClr val="2A4A78"/>
-            </a:solidFill>
-          </a:ln>
-          <a:effectLst/>
+          <a:noFill/>
         </p:spPr>
-        <p:style>
-          <a:lnRef idx="1">
-            <a:schemeClr val="accent1"/>
-          </a:lnRef>
-          <a:fillRef idx="3">
-            <a:schemeClr val="accent1"/>
-          </a:fillRef>
-          <a:effectRef idx="2">
-            <a:schemeClr val="accent1"/>
-          </a:effectRef>
-          <a:fontRef idx="minor">
-            <a:schemeClr val="lt1"/>
-          </a:fontRef>
-        </p:style>
         <p:txBody>
-          <a:bodyPr rtlCol="0" anchor="t" wrap="square" lIns="120000" rIns="120000" tIns="80000" bIns="80000"/>
+          <a:bodyPr wrap="square">
+            <a:spAutoFit/>
+          </a:bodyPr>
           <a:lstStyle/>
           <a:p>
             <a:pPr algn="ctr"/>
             <a:r>
-              <a:rPr sz="1600" b="1">
-                <a:solidFill>
-                  <a:srgbClr val="F28C00"/>
-                </a:solidFill>
-              </a:rPr>
-              <a:t>LEARNER &amp; PARENT</a:t>
-            </a:r>
-          </a:p>
-          <a:p>
-            <a:pPr/>
-            <a:r>
-              <a:rPr sz="1800" b="0">
-                <a:solidFill>
-                  <a:srgbClr val="FFFFFF"/>
-                </a:solidFill>
-              </a:rPr>
-              <a:t>• Learner: content at the right difficulty (target P-correct ≈ 0.7)</a:t>
-            </a:r>
-          </a:p>
-          <a:p>
-            <a:pPr/>
-            <a:r>
-              <a:rPr sz="1800" b="0">
-                <a:solidFill>
-                  <a:srgbClr val="FFFFFF"/>
-                </a:solidFill>
-              </a:rPr>
-              <a:t>• Learner: instant formative feedback, never punitive grading</a:t>
-            </a:r>
-          </a:p>
-          <a:p>
-            <a:pPr/>
-            <a:r>
-              <a:rPr sz="1800" b="0">
-                <a:solidFill>
-                  <a:srgbClr val="FFFFFF"/>
-                </a:solidFill>
-              </a:rPr>
-              <a:t>• Parent: portal in native language, GDPR Art. 8 controls in one click</a:t>
-            </a:r>
-          </a:p>
-          <a:p>
-            <a:pPr/>
-            <a:r>
-              <a:rPr sz="1800" b="0">
-                <a:solidFill>
-                  <a:srgbClr val="FFFFFF"/>
-                </a:solidFill>
-              </a:rPr>
-              <a:t>• Parent: human teacher remains the decision-maker — by contract</a:t>
+              <a:rPr sz="2200" b="0" i="1">
+                <a:solidFill>
+                  <a:srgbClr val="C8D4E6"/>
+                </a:solidFill>
+              </a:rPr>
+              <a:t>Lucas, Mr Klein, Sophie — three quantified wins</a:t>
             </a:r>
           </a:p>
         </p:txBody>
       </p:sp>
-      <p:sp>
-        <p:nvSpPr>
-          <p:cNvPr id="5" name="Rounded Rectangle 4"/>
-          <p:cNvSpPr/>
+      <p:pic>
+        <p:nvPicPr>
+          <p:cNvPr id="6" name="Picture 5" descr="persona-learner.png"/>
+          <p:cNvPicPr>
+            <a:picLocks noChangeAspect="1"/>
+          </p:cNvPicPr>
           <p:nvPr/>
-        </p:nvSpPr>
+        </p:nvPicPr>
+        <p:blipFill>
+          <a:blip r:embed="rId3"/>
+          <a:stretch>
+            <a:fillRect/>
+          </a:stretch>
+        </p:blipFill>
         <p:spPr>
           <a:xfrm>
-            <a:off x="6216000" y="1400000"/>
-            <a:ext cx="5376000" cy="5098000"/>
+            <a:off x="400000" y="1700000"/>
+            <a:ext cx="3610666" cy="3400000"/>
           </a:xfrm>
-          <a:prstGeom prst="roundRect">
+          <a:prstGeom prst="rect">
             <a:avLst/>
           </a:prstGeom>
-          <a:solidFill>
-            <a:srgbClr val="122A4A"/>
-          </a:solidFill>
-          <a:ln w="12700">
-            <a:solidFill>
-              <a:srgbClr val="2A4A78"/>
-            </a:solidFill>
-          </a:ln>
-          <a:effectLst/>
         </p:spPr>
-        <p:style>
-          <a:lnRef idx="1">
-            <a:schemeClr val="accent1"/>
-          </a:lnRef>
-          <a:fillRef idx="3">
-            <a:schemeClr val="accent1"/>
-          </a:fillRef>
-          <a:effectRef idx="2">
-            <a:schemeClr val="accent1"/>
-          </a:effectRef>
-          <a:fontRef idx="minor">
-            <a:schemeClr val="lt1"/>
-          </a:fontRef>
-        </p:style>
+      </p:pic>
+      <p:sp>
+        <p:nvSpPr>
+          <p:cNvPr id="7" name="TextBox 6"/>
+          <p:cNvSpPr txBox="1"/>
+          <p:nvPr/>
+        </p:nvSpPr>
+        <p:spPr>
+          <a:xfrm>
+            <a:off x="400000" y="5200000"/>
+            <a:ext cx="3610666" cy="1200000"/>
+          </a:xfrm>
+          <a:prstGeom prst="rect">
+            <a:avLst/>
+          </a:prstGeom>
+          <a:noFill/>
+        </p:spPr>
         <p:txBody>
-          <a:bodyPr rtlCol="0" anchor="t" wrap="square" lIns="120000" rIns="120000" tIns="80000" bIns="80000"/>
+          <a:bodyPr wrap="square">
+            <a:spAutoFit/>
+          </a:bodyPr>
           <a:lstStyle/>
           <a:p>
             <a:pPr algn="ctr"/>
             <a:r>
-              <a:rPr sz="1600" b="1">
-                <a:solidFill>
-                  <a:srgbClr val="F28C00"/>
-                </a:solidFill>
-              </a:rPr>
-              <a:t>TEACHER</a:t>
-            </a:r>
-          </a:p>
-          <a:p>
-            <a:pPr/>
-            <a:r>
-              <a:rPr sz="1800" b="0">
+              <a:rPr sz="1800">
                 <a:solidFill>
                   <a:srgbClr val="FFFFFF"/>
                 </a:solidFill>
               </a:rPr>
-              <a:t>• Teacher: 45% admin time back — recoverable for actual teaching</a:t>
-            </a:r>
-          </a:p>
-          <a:p>
-            <a:pPr/>
-            <a:r>
-              <a:rPr sz="1800" b="0">
+              <a:t>Content at his level (P-correct ≈ 0.7)</a:t>
+            </a:r>
+          </a:p>
+          <a:p>
+            <a:pPr algn="ctr"/>
+            <a:r>
+              <a:rPr sz="1800">
                 <a:solidFill>
                   <a:srgbClr val="FFFFFF"/>
                 </a:solidFill>
               </a:rPr>
-              <a:t>• Teacher: every AI suggestion comes with explanation + one-click override</a:t>
-            </a:r>
-          </a:p>
-          <a:p>
-            <a:pPr/>
-            <a:r>
-              <a:rPr sz="1800" b="0">
+              <a:t>Instant formative feedback</a:t>
+            </a:r>
+          </a:p>
+          <a:p>
+            <a:pPr algn="ctr"/>
+            <a:r>
+              <a:rPr sz="1800">
                 <a:solidFill>
                   <a:srgbClr val="FFFFFF"/>
                 </a:solidFill>
               </a:rPr>
-              <a:t>• Teacher: classroom-level dashboard in Power BI, no data engineering needed</a:t>
-            </a:r>
-          </a:p>
-          <a:p>
-            <a:pPr/>
-            <a:r>
-              <a:rPr sz="1800" b="0">
+              <a:t>Never punitive grading</a:t>
+            </a:r>
+          </a:p>
+        </p:txBody>
+      </p:sp>
+      <p:pic>
+        <p:nvPicPr>
+          <p:cNvPr id="8" name="Picture 7" descr="persona-teacher.png"/>
+          <p:cNvPicPr>
+            <a:picLocks noChangeAspect="1"/>
+          </p:cNvPicPr>
+          <p:nvPr/>
+        </p:nvPicPr>
+        <p:blipFill>
+          <a:blip r:embed="rId4"/>
+          <a:stretch>
+            <a:fillRect/>
+          </a:stretch>
+        </p:blipFill>
+        <p:spPr>
+          <a:xfrm>
+            <a:off x="4290666" y="1700000"/>
+            <a:ext cx="3610666" cy="3400000"/>
+          </a:xfrm>
+          <a:prstGeom prst="rect">
+            <a:avLst/>
+          </a:prstGeom>
+        </p:spPr>
+      </p:pic>
+      <p:sp>
+        <p:nvSpPr>
+          <p:cNvPr id="9" name="TextBox 8"/>
+          <p:cNvSpPr txBox="1"/>
+          <p:nvPr/>
+        </p:nvSpPr>
+        <p:spPr>
+          <a:xfrm>
+            <a:off x="4290666" y="5200000"/>
+            <a:ext cx="3610666" cy="1200000"/>
+          </a:xfrm>
+          <a:prstGeom prst="rect">
+            <a:avLst/>
+          </a:prstGeom>
+          <a:noFill/>
+        </p:spPr>
+        <p:txBody>
+          <a:bodyPr wrap="square">
+            <a:spAutoFit/>
+          </a:bodyPr>
+          <a:lstStyle/>
+          <a:p>
+            <a:pPr algn="ctr"/>
+            <a:r>
+              <a:rPr sz="1800">
                 <a:solidFill>
                   <a:srgbClr val="FFFFFF"/>
                 </a:solidFill>
               </a:rPr>
-              <a:t>• Teacher: opt-out per assignment, per class, per pupil — always available</a:t>
+              <a:t>45% admin time back</a:t>
+            </a:r>
+          </a:p>
+          <a:p>
+            <a:pPr algn="ctr"/>
+            <a:r>
+              <a:rPr sz="1800">
+                <a:solidFill>
+                  <a:srgbClr val="FFFFFF"/>
+                </a:solidFill>
+              </a:rPr>
+              <a:t>Every AI hint is explainable</a:t>
+            </a:r>
+          </a:p>
+          <a:p>
+            <a:pPr algn="ctr"/>
+            <a:r>
+              <a:rPr sz="1800">
+                <a:solidFill>
+                  <a:srgbClr val="FFFFFF"/>
+                </a:solidFill>
+              </a:rPr>
+              <a:t>One-click override, always</a:t>
+            </a:r>
+          </a:p>
+        </p:txBody>
+      </p:sp>
+      <p:pic>
+        <p:nvPicPr>
+          <p:cNvPr id="10" name="Picture 9" descr="persona-parent.png"/>
+          <p:cNvPicPr>
+            <a:picLocks noChangeAspect="1"/>
+          </p:cNvPicPr>
+          <p:nvPr/>
+        </p:nvPicPr>
+        <p:blipFill>
+          <a:blip r:embed="rId5"/>
+          <a:stretch>
+            <a:fillRect/>
+          </a:stretch>
+        </p:blipFill>
+        <p:spPr>
+          <a:xfrm>
+            <a:off x="8181332" y="1700000"/>
+            <a:ext cx="3610666" cy="3400000"/>
+          </a:xfrm>
+          <a:prstGeom prst="rect">
+            <a:avLst/>
+          </a:prstGeom>
+        </p:spPr>
+      </p:pic>
+      <p:sp>
+        <p:nvSpPr>
+          <p:cNvPr id="11" name="TextBox 10"/>
+          <p:cNvSpPr txBox="1"/>
+          <p:nvPr/>
+        </p:nvSpPr>
+        <p:spPr>
+          <a:xfrm>
+            <a:off x="8181332" y="5200000"/>
+            <a:ext cx="3610666" cy="1200000"/>
+          </a:xfrm>
+          <a:prstGeom prst="rect">
+            <a:avLst/>
+          </a:prstGeom>
+          <a:noFill/>
+        </p:spPr>
+        <p:txBody>
+          <a:bodyPr wrap="square">
+            <a:spAutoFit/>
+          </a:bodyPr>
+          <a:lstStyle/>
+          <a:p>
+            <a:pPr algn="ctr"/>
+            <a:r>
+              <a:rPr sz="1800">
+                <a:solidFill>
+                  <a:srgbClr val="FFFFFF"/>
+                </a:solidFill>
+              </a:rPr>
+              <a:t>Native-language portal</a:t>
+            </a:r>
+          </a:p>
+          <a:p>
+            <a:pPr algn="ctr"/>
+            <a:r>
+              <a:rPr sz="1800">
+                <a:solidFill>
+                  <a:srgbClr val="FFFFFF"/>
+                </a:solidFill>
+              </a:rPr>
+              <a:t>GDPR Art. 8 controls in one click</a:t>
+            </a:r>
+          </a:p>
+          <a:p>
+            <a:pPr algn="ctr"/>
+            <a:r>
+              <a:rPr sz="1800">
+                <a:solidFill>
+                  <a:srgbClr val="FFFFFF"/>
+                </a:solidFill>
+              </a:rPr>
+              <a:t>Human teacher decides — by contract</a:t>
             </a:r>
           </a:p>
         </p:txBody>

</xml_diff>

<commit_message>
feat(restitution): replace raster assets with native editable PowerPoint shapes
Every visual element on hero, stat, quote, image and persona slides is now a native PowerPoint shape (rectangle, oval, rounded rectangle, text box) — no PNGs. Users can change colours, fonts, copy and layout directly in PowerPoint without leaving the app.

- New _add_shape / _add_bg helpers draw solid-fill rectangles and decorative orbs in place of the previous full-bleed PNG backgrounds.

- BG_THEMES / STAT_THEMES / PERSONA_THEMES dictionaries map the legacy g-*.png and stat-*.png names to native colour + text themes so existing slide markdown still works.

- Stat slides now render the big number and label as real text boxes (editable copy).

- Persona slides now use rounded rectangles + avatar circles with initials in place of portrait PNGs.

- Drop the Restitution01/assets/ folder and gen_assets.py — no longer needed.

Co-authored-by: Copilot <223556219+Copilot@users.noreply.github.com>
</commit_message>
<xml_diff>
--- a/Restitution01/build/LearnEU-CXO-Restitution.pptx
+++ b/Restitution01/build/LearnEU-CXO-Restitution.pptx
@@ -20423,20 +20423,12 @@
           <a:p/>
         </p:txBody>
       </p:sp>
-      <p:pic>
-        <p:nvPicPr>
-          <p:cNvPr id="3" name="Picture 2" descr="bg-hero-navy.png"/>
-          <p:cNvPicPr>
-            <a:picLocks noChangeAspect="1"/>
-          </p:cNvPicPr>
+      <p:sp>
+        <p:nvSpPr>
+          <p:cNvPr id="3" name="Rectangle 2"/>
+          <p:cNvSpPr/>
           <p:nvPr/>
-        </p:nvPicPr>
-        <p:blipFill>
-          <a:blip r:embed="rId2"/>
-          <a:stretch>
-            <a:fillRect/>
-          </a:stretch>
-        </p:blipFill>
+        </p:nvSpPr>
         <p:spPr>
           <a:xfrm>
             <a:off x="0" y="0"/>
@@ -20445,11 +20437,118 @@
           <a:prstGeom prst="rect">
             <a:avLst/>
           </a:prstGeom>
+          <a:solidFill>
+            <a:srgbClr val="122A4A"/>
+          </a:solidFill>
+          <a:ln>
+            <a:noFill/>
+          </a:ln>
         </p:spPr>
-      </p:pic>
-      <p:sp>
-        <p:nvSpPr>
-          <p:cNvPr id="4" name="TextBox 3"/>
+        <p:style>
+          <a:lnRef idx="1">
+            <a:schemeClr val="accent1"/>
+          </a:lnRef>
+          <a:fillRef idx="3">
+            <a:schemeClr val="accent1"/>
+          </a:fillRef>
+          <a:effectRef idx="2">
+            <a:schemeClr val="accent1"/>
+          </a:effectRef>
+          <a:fontRef idx="minor">
+            <a:schemeClr val="lt1"/>
+          </a:fontRef>
+        </p:style>
+        <p:txBody>
+          <a:bodyPr rtlCol="0" anchor="ctr"/>
+          <a:lstStyle/>
+          <a:p/>
+        </p:txBody>
+      </p:sp>
+      <p:sp>
+        <p:nvSpPr>
+          <p:cNvPr id="4" name="Oval 3"/>
+          <p:cNvSpPr/>
+          <p:nvPr/>
+        </p:nvSpPr>
+        <p:spPr>
+          <a:xfrm>
+            <a:off x="9792000" y="-1200000"/>
+            <a:ext cx="4400000" cy="4400000"/>
+          </a:xfrm>
+          <a:prstGeom prst="ellipse">
+            <a:avLst/>
+          </a:prstGeom>
+          <a:solidFill>
+            <a:srgbClr val="F28C00"/>
+          </a:solidFill>
+          <a:ln>
+            <a:noFill/>
+          </a:ln>
+        </p:spPr>
+        <p:style>
+          <a:lnRef idx="1">
+            <a:schemeClr val="accent1"/>
+          </a:lnRef>
+          <a:fillRef idx="3">
+            <a:schemeClr val="accent1"/>
+          </a:fillRef>
+          <a:effectRef idx="2">
+            <a:schemeClr val="accent1"/>
+          </a:effectRef>
+          <a:fontRef idx="minor">
+            <a:schemeClr val="lt1"/>
+          </a:fontRef>
+        </p:style>
+        <p:txBody>
+          <a:bodyPr rtlCol="0" anchor="ctr"/>
+          <a:lstStyle/>
+          <a:p/>
+        </p:txBody>
+      </p:sp>
+      <p:sp>
+        <p:nvSpPr>
+          <p:cNvPr id="5" name="Oval 4"/>
+          <p:cNvSpPr/>
+          <p:nvPr/>
+        </p:nvSpPr>
+        <p:spPr>
+          <a:xfrm>
+            <a:off x="-1400000" y="4258000"/>
+            <a:ext cx="4000000" cy="4000000"/>
+          </a:xfrm>
+          <a:prstGeom prst="ellipse">
+            <a:avLst/>
+          </a:prstGeom>
+          <a:solidFill>
+            <a:srgbClr val="0E5A5A"/>
+          </a:solidFill>
+          <a:ln>
+            <a:noFill/>
+          </a:ln>
+        </p:spPr>
+        <p:style>
+          <a:lnRef idx="1">
+            <a:schemeClr val="accent1"/>
+          </a:lnRef>
+          <a:fillRef idx="3">
+            <a:schemeClr val="accent1"/>
+          </a:fillRef>
+          <a:effectRef idx="2">
+            <a:schemeClr val="accent1"/>
+          </a:effectRef>
+          <a:fontRef idx="minor">
+            <a:schemeClr val="lt1"/>
+          </a:fontRef>
+        </p:style>
+        <p:txBody>
+          <a:bodyPr rtlCol="0" anchor="ctr"/>
+          <a:lstStyle/>
+          <a:p/>
+        </p:txBody>
+      </p:sp>
+      <p:sp>
+        <p:nvSpPr>
+          <p:cNvPr id="6" name="TextBox 5"/>
           <p:cNvSpPr txBox="1"/>
           <p:nvPr/>
         </p:nvSpPr>
@@ -20483,7 +20582,7 @@
       </p:sp>
       <p:sp>
         <p:nvSpPr>
-          <p:cNvPr id="5" name="TextBox 4"/>
+          <p:cNvPr id="7" name="TextBox 6"/>
           <p:cNvSpPr txBox="1"/>
           <p:nvPr/>
         </p:nvSpPr>
@@ -23783,20 +23882,12 @@
           <a:p/>
         </p:txBody>
       </p:sp>
-      <p:pic>
-        <p:nvPicPr>
-          <p:cNvPr id="3" name="Picture 2" descr="bg-hero-orange.png"/>
-          <p:cNvPicPr>
-            <a:picLocks noChangeAspect="1"/>
-          </p:cNvPicPr>
+      <p:sp>
+        <p:nvSpPr>
+          <p:cNvPr id="3" name="Rectangle 2"/>
+          <p:cNvSpPr/>
           <p:nvPr/>
-        </p:nvPicPr>
-        <p:blipFill>
-          <a:blip r:embed="rId2"/>
-          <a:stretch>
-            <a:fillRect/>
-          </a:stretch>
-        </p:blipFill>
+        </p:nvSpPr>
         <p:spPr>
           <a:xfrm>
             <a:off x="0" y="0"/>
@@ -23805,11 +23896,118 @@
           <a:prstGeom prst="rect">
             <a:avLst/>
           </a:prstGeom>
+          <a:solidFill>
+            <a:srgbClr val="F28C00"/>
+          </a:solidFill>
+          <a:ln>
+            <a:noFill/>
+          </a:ln>
         </p:spPr>
-      </p:pic>
-      <p:sp>
-        <p:nvSpPr>
-          <p:cNvPr id="4" name="TextBox 3"/>
+        <p:style>
+          <a:lnRef idx="1">
+            <a:schemeClr val="accent1"/>
+          </a:lnRef>
+          <a:fillRef idx="3">
+            <a:schemeClr val="accent1"/>
+          </a:fillRef>
+          <a:effectRef idx="2">
+            <a:schemeClr val="accent1"/>
+          </a:effectRef>
+          <a:fontRef idx="minor">
+            <a:schemeClr val="lt1"/>
+          </a:fontRef>
+        </p:style>
+        <p:txBody>
+          <a:bodyPr rtlCol="0" anchor="ctr"/>
+          <a:lstStyle/>
+          <a:p/>
+        </p:txBody>
+      </p:sp>
+      <p:sp>
+        <p:nvSpPr>
+          <p:cNvPr id="4" name="Oval 3"/>
+          <p:cNvSpPr/>
+          <p:nvPr/>
+        </p:nvSpPr>
+        <p:spPr>
+          <a:xfrm>
+            <a:off x="9792000" y="-1200000"/>
+            <a:ext cx="4400000" cy="4400000"/>
+          </a:xfrm>
+          <a:prstGeom prst="ellipse">
+            <a:avLst/>
+          </a:prstGeom>
+          <a:solidFill>
+            <a:srgbClr val="122A4A"/>
+          </a:solidFill>
+          <a:ln>
+            <a:noFill/>
+          </a:ln>
+        </p:spPr>
+        <p:style>
+          <a:lnRef idx="1">
+            <a:schemeClr val="accent1"/>
+          </a:lnRef>
+          <a:fillRef idx="3">
+            <a:schemeClr val="accent1"/>
+          </a:fillRef>
+          <a:effectRef idx="2">
+            <a:schemeClr val="accent1"/>
+          </a:effectRef>
+          <a:fontRef idx="minor">
+            <a:schemeClr val="lt1"/>
+          </a:fontRef>
+        </p:style>
+        <p:txBody>
+          <a:bodyPr rtlCol="0" anchor="ctr"/>
+          <a:lstStyle/>
+          <a:p/>
+        </p:txBody>
+      </p:sp>
+      <p:sp>
+        <p:nvSpPr>
+          <p:cNvPr id="5" name="Oval 4"/>
+          <p:cNvSpPr/>
+          <p:nvPr/>
+        </p:nvSpPr>
+        <p:spPr>
+          <a:xfrm>
+            <a:off x="-1400000" y="4258000"/>
+            <a:ext cx="4000000" cy="4000000"/>
+          </a:xfrm>
+          <a:prstGeom prst="ellipse">
+            <a:avLst/>
+          </a:prstGeom>
+          <a:solidFill>
+            <a:srgbClr val="FFFFFF"/>
+          </a:solidFill>
+          <a:ln>
+            <a:noFill/>
+          </a:ln>
+        </p:spPr>
+        <p:style>
+          <a:lnRef idx="1">
+            <a:schemeClr val="accent1"/>
+          </a:lnRef>
+          <a:fillRef idx="3">
+            <a:schemeClr val="accent1"/>
+          </a:fillRef>
+          <a:effectRef idx="2">
+            <a:schemeClr val="accent1"/>
+          </a:effectRef>
+          <a:fontRef idx="minor">
+            <a:schemeClr val="lt1"/>
+          </a:fontRef>
+        </p:style>
+        <p:txBody>
+          <a:bodyPr rtlCol="0" anchor="ctr"/>
+          <a:lstStyle/>
+          <a:p/>
+        </p:txBody>
+      </p:sp>
+      <p:sp>
+        <p:nvSpPr>
+          <p:cNvPr id="6" name="TextBox 5"/>
           <p:cNvSpPr txBox="1"/>
           <p:nvPr/>
         </p:nvSpPr>
@@ -23843,7 +24041,7 @@
       </p:sp>
       <p:sp>
         <p:nvSpPr>
-          <p:cNvPr id="5" name="TextBox 4"/>
+          <p:cNvPr id="7" name="TextBox 6"/>
           <p:cNvSpPr txBox="1"/>
           <p:nvPr/>
         </p:nvSpPr>
@@ -26127,20 +26325,12 @@
           <a:p/>
         </p:txBody>
       </p:sp>
-      <p:pic>
-        <p:nvPicPr>
-          <p:cNvPr id="3" name="Picture 2" descr="stat-gap.png"/>
-          <p:cNvPicPr>
-            <a:picLocks noChangeAspect="1"/>
-          </p:cNvPicPr>
+      <p:sp>
+        <p:nvSpPr>
+          <p:cNvPr id="3" name="Rectangle 2"/>
+          <p:cNvSpPr/>
           <p:nvPr/>
-        </p:nvPicPr>
-        <p:blipFill>
-          <a:blip r:embed="rId2"/>
-          <a:stretch>
-            <a:fillRect/>
-          </a:stretch>
-        </p:blipFill>
+        </p:nvSpPr>
         <p:spPr>
           <a:xfrm>
             <a:off x="0" y="0"/>
@@ -26149,11 +26339,77 @@
           <a:prstGeom prst="rect">
             <a:avLst/>
           </a:prstGeom>
+          <a:solidFill>
+            <a:srgbClr val="122A4A"/>
+          </a:solidFill>
+          <a:ln>
+            <a:noFill/>
+          </a:ln>
         </p:spPr>
-      </p:pic>
-      <p:sp>
-        <p:nvSpPr>
-          <p:cNvPr id="4" name="TextBox 3"/>
+        <p:style>
+          <a:lnRef idx="1">
+            <a:schemeClr val="accent1"/>
+          </a:lnRef>
+          <a:fillRef idx="3">
+            <a:schemeClr val="accent1"/>
+          </a:fillRef>
+          <a:effectRef idx="2">
+            <a:schemeClr val="accent1"/>
+          </a:effectRef>
+          <a:fontRef idx="minor">
+            <a:schemeClr val="lt1"/>
+          </a:fontRef>
+        </p:style>
+        <p:txBody>
+          <a:bodyPr rtlCol="0" anchor="ctr"/>
+          <a:lstStyle/>
+          <a:p/>
+        </p:txBody>
+      </p:sp>
+      <p:sp>
+        <p:nvSpPr>
+          <p:cNvPr id="4" name="Oval 3"/>
+          <p:cNvSpPr/>
+          <p:nvPr/>
+        </p:nvSpPr>
+        <p:spPr>
+          <a:xfrm>
+            <a:off x="10792000" y="-1600000"/>
+            <a:ext cx="3600000" cy="3600000"/>
+          </a:xfrm>
+          <a:prstGeom prst="ellipse">
+            <a:avLst/>
+          </a:prstGeom>
+          <a:solidFill>
+            <a:srgbClr val="FFFFFF"/>
+          </a:solidFill>
+          <a:ln>
+            <a:noFill/>
+          </a:ln>
+        </p:spPr>
+        <p:style>
+          <a:lnRef idx="1">
+            <a:schemeClr val="accent1"/>
+          </a:lnRef>
+          <a:fillRef idx="3">
+            <a:schemeClr val="accent1"/>
+          </a:fillRef>
+          <a:effectRef idx="2">
+            <a:schemeClr val="accent1"/>
+          </a:effectRef>
+          <a:fontRef idx="minor">
+            <a:schemeClr val="lt1"/>
+          </a:fontRef>
+        </p:style>
+        <p:txBody>
+          <a:bodyPr rtlCol="0" anchor="ctr"/>
+          <a:lstStyle/>
+          <a:p/>
+        </p:txBody>
+      </p:sp>
+      <p:sp>
+        <p:nvSpPr>
+          <p:cNvPr id="5" name="TextBox 4"/>
           <p:cNvSpPr txBox="1"/>
           <p:nvPr/>
         </p:nvSpPr>
@@ -26187,7 +26443,75 @@
       </p:sp>
       <p:sp>
         <p:nvSpPr>
-          <p:cNvPr id="5" name="TextBox 4"/>
+          <p:cNvPr id="6" name="TextBox 5"/>
+          <p:cNvSpPr txBox="1"/>
+          <p:nvPr/>
+        </p:nvSpPr>
+        <p:spPr>
+          <a:xfrm>
+            <a:off x="600000" y="1700000"/>
+            <a:ext cx="10992000" cy="2800000"/>
+          </a:xfrm>
+          <a:prstGeom prst="rect">
+            <a:avLst/>
+          </a:prstGeom>
+          <a:noFill/>
+        </p:spPr>
+        <p:txBody>
+          <a:bodyPr wrap="square">
+            <a:spAutoFit/>
+          </a:bodyPr>
+          <a:lstStyle/>
+          <a:p>
+            <a:pPr algn="ctr"/>
+            <a:r>
+              <a:rPr sz="24000" b="1" i="0">
+                <a:solidFill>
+                  <a:srgbClr val="FFFFFF"/>
+                </a:solidFill>
+              </a:rPr>
+              <a:t>40%</a:t>
+            </a:r>
+          </a:p>
+        </p:txBody>
+      </p:sp>
+      <p:sp>
+        <p:nvSpPr>
+          <p:cNvPr id="7" name="TextBox 6"/>
+          <p:cNvSpPr txBox="1"/>
+          <p:nvPr/>
+        </p:nvSpPr>
+        <p:spPr>
+          <a:xfrm>
+            <a:off x="600000" y="4900000"/>
+            <a:ext cx="10992000" cy="700000"/>
+          </a:xfrm>
+          <a:prstGeom prst="rect">
+            <a:avLst/>
+          </a:prstGeom>
+          <a:noFill/>
+        </p:spPr>
+        <p:txBody>
+          <a:bodyPr wrap="square">
+            <a:spAutoFit/>
+          </a:bodyPr>
+          <a:lstStyle/>
+          <a:p>
+            <a:pPr algn="ctr"/>
+            <a:r>
+              <a:rPr sz="3200" b="0" i="1">
+                <a:solidFill>
+                  <a:srgbClr val="FFFFFF"/>
+                </a:solidFill>
+              </a:rPr>
+              <a:t>outcome gap, today</a:t>
+            </a:r>
+          </a:p>
+        </p:txBody>
+      </p:sp>
+      <p:sp>
+        <p:nvSpPr>
+          <p:cNvPr id="8" name="TextBox 7"/>
           <p:cNvSpPr txBox="1"/>
           <p:nvPr/>
         </p:nvSpPr>
@@ -28734,20 +29058,12 @@
           <a:p/>
         </p:txBody>
       </p:sp>
-      <p:pic>
-        <p:nvPicPr>
-          <p:cNvPr id="3" name="Picture 2" descr="bg-hero-orange.png"/>
-          <p:cNvPicPr>
-            <a:picLocks noChangeAspect="1"/>
-          </p:cNvPicPr>
+      <p:sp>
+        <p:nvSpPr>
+          <p:cNvPr id="3" name="Rectangle 2"/>
+          <p:cNvSpPr/>
           <p:nvPr/>
-        </p:nvPicPr>
-        <p:blipFill>
-          <a:blip r:embed="rId2"/>
-          <a:stretch>
-            <a:fillRect/>
-          </a:stretch>
-        </p:blipFill>
+        </p:nvSpPr>
         <p:spPr>
           <a:xfrm>
             <a:off x="0" y="0"/>
@@ -28756,18 +29072,125 @@
           <a:prstGeom prst="rect">
             <a:avLst/>
           </a:prstGeom>
+          <a:solidFill>
+            <a:srgbClr val="F28C00"/>
+          </a:solidFill>
+          <a:ln>
+            <a:noFill/>
+          </a:ln>
         </p:spPr>
-      </p:pic>
-      <p:sp>
-        <p:nvSpPr>
-          <p:cNvPr id="4" name="TextBox 3"/>
+        <p:style>
+          <a:lnRef idx="1">
+            <a:schemeClr val="accent1"/>
+          </a:lnRef>
+          <a:fillRef idx="3">
+            <a:schemeClr val="accent1"/>
+          </a:fillRef>
+          <a:effectRef idx="2">
+            <a:schemeClr val="accent1"/>
+          </a:effectRef>
+          <a:fontRef idx="minor">
+            <a:schemeClr val="lt1"/>
+          </a:fontRef>
+        </p:style>
+        <p:txBody>
+          <a:bodyPr rtlCol="0" anchor="ctr"/>
+          <a:lstStyle/>
+          <a:p/>
+        </p:txBody>
+      </p:sp>
+      <p:sp>
+        <p:nvSpPr>
+          <p:cNvPr id="4" name="Oval 3"/>
+          <p:cNvSpPr/>
+          <p:nvPr/>
+        </p:nvSpPr>
+        <p:spPr>
+          <a:xfrm>
+            <a:off x="9792000" y="-1200000"/>
+            <a:ext cx="4400000" cy="4400000"/>
+          </a:xfrm>
+          <a:prstGeom prst="ellipse">
+            <a:avLst/>
+          </a:prstGeom>
+          <a:solidFill>
+            <a:srgbClr val="122A4A"/>
+          </a:solidFill>
+          <a:ln>
+            <a:noFill/>
+          </a:ln>
+        </p:spPr>
+        <p:style>
+          <a:lnRef idx="1">
+            <a:schemeClr val="accent1"/>
+          </a:lnRef>
+          <a:fillRef idx="3">
+            <a:schemeClr val="accent1"/>
+          </a:fillRef>
+          <a:effectRef idx="2">
+            <a:schemeClr val="accent1"/>
+          </a:effectRef>
+          <a:fontRef idx="minor">
+            <a:schemeClr val="lt1"/>
+          </a:fontRef>
+        </p:style>
+        <p:txBody>
+          <a:bodyPr rtlCol="0" anchor="ctr"/>
+          <a:lstStyle/>
+          <a:p/>
+        </p:txBody>
+      </p:sp>
+      <p:sp>
+        <p:nvSpPr>
+          <p:cNvPr id="5" name="Oval 4"/>
+          <p:cNvSpPr/>
+          <p:nvPr/>
+        </p:nvSpPr>
+        <p:spPr>
+          <a:xfrm>
+            <a:off x="-1400000" y="4258000"/>
+            <a:ext cx="4000000" cy="4000000"/>
+          </a:xfrm>
+          <a:prstGeom prst="ellipse">
+            <a:avLst/>
+          </a:prstGeom>
+          <a:solidFill>
+            <a:srgbClr val="FFFFFF"/>
+          </a:solidFill>
+          <a:ln>
+            <a:noFill/>
+          </a:ln>
+        </p:spPr>
+        <p:style>
+          <a:lnRef idx="1">
+            <a:schemeClr val="accent1"/>
+          </a:lnRef>
+          <a:fillRef idx="3">
+            <a:schemeClr val="accent1"/>
+          </a:fillRef>
+          <a:effectRef idx="2">
+            <a:schemeClr val="accent1"/>
+          </a:effectRef>
+          <a:fontRef idx="minor">
+            <a:schemeClr val="lt1"/>
+          </a:fontRef>
+        </p:style>
+        <p:txBody>
+          <a:bodyPr rtlCol="0" anchor="ctr"/>
+          <a:lstStyle/>
+          <a:p/>
+        </p:txBody>
+      </p:sp>
+      <p:sp>
+        <p:nvSpPr>
+          <p:cNvPr id="6" name="TextBox 5"/>
           <p:cNvSpPr txBox="1"/>
           <p:nvPr/>
         </p:nvSpPr>
         <p:spPr>
           <a:xfrm>
             <a:off x="800000" y="800000"/>
-            <a:ext cx="400000" cy="800000"/>
+            <a:ext cx="1400000" cy="1400000"/>
           </a:xfrm>
           <a:prstGeom prst="rect">
             <a:avLst/>
@@ -28793,14 +29216,14 @@
       </p:sp>
       <p:sp>
         <p:nvSpPr>
-          <p:cNvPr id="5" name="TextBox 4"/>
+          <p:cNvPr id="7" name="TextBox 6"/>
           <p:cNvSpPr txBox="1"/>
           <p:nvPr/>
         </p:nvSpPr>
         <p:spPr>
           <a:xfrm>
-            <a:off x="1200000" y="1600000"/>
-            <a:ext cx="9792000" cy="3400000"/>
+            <a:off x="1200000" y="1900000"/>
+            <a:ext cx="9792000" cy="3100000"/>
           </a:xfrm>
           <a:prstGeom prst="rect">
             <a:avLst/>
@@ -28827,7 +29250,7 @@
       </p:sp>
       <p:sp>
         <p:nvSpPr>
-          <p:cNvPr id="6" name="TextBox 5"/>
+          <p:cNvPr id="8" name="TextBox 7"/>
           <p:cNvSpPr txBox="1"/>
           <p:nvPr/>
         </p:nvSpPr>
@@ -28894,20 +29317,12 @@
           <a:p/>
         </p:txBody>
       </p:sp>
-      <p:pic>
-        <p:nvPicPr>
-          <p:cNvPr id="3" name="Picture 2" descr="stat-reduction.png"/>
-          <p:cNvPicPr>
-            <a:picLocks noChangeAspect="1"/>
-          </p:cNvPicPr>
+      <p:sp>
+        <p:nvSpPr>
+          <p:cNvPr id="3" name="Rectangle 2"/>
+          <p:cNvSpPr/>
           <p:nvPr/>
-        </p:nvPicPr>
-        <p:blipFill>
-          <a:blip r:embed="rId2"/>
-          <a:stretch>
-            <a:fillRect/>
-          </a:stretch>
-        </p:blipFill>
+        </p:nvSpPr>
         <p:spPr>
           <a:xfrm>
             <a:off x="0" y="0"/>
@@ -28916,11 +29331,77 @@
           <a:prstGeom prst="rect">
             <a:avLst/>
           </a:prstGeom>
+          <a:solidFill>
+            <a:srgbClr val="F28C00"/>
+          </a:solidFill>
+          <a:ln>
+            <a:noFill/>
+          </a:ln>
         </p:spPr>
-      </p:pic>
-      <p:sp>
-        <p:nvSpPr>
-          <p:cNvPr id="4" name="TextBox 3"/>
+        <p:style>
+          <a:lnRef idx="1">
+            <a:schemeClr val="accent1"/>
+          </a:lnRef>
+          <a:fillRef idx="3">
+            <a:schemeClr val="accent1"/>
+          </a:fillRef>
+          <a:effectRef idx="2">
+            <a:schemeClr val="accent1"/>
+          </a:effectRef>
+          <a:fontRef idx="minor">
+            <a:schemeClr val="lt1"/>
+          </a:fontRef>
+        </p:style>
+        <p:txBody>
+          <a:bodyPr rtlCol="0" anchor="ctr"/>
+          <a:lstStyle/>
+          <a:p/>
+        </p:txBody>
+      </p:sp>
+      <p:sp>
+        <p:nvSpPr>
+          <p:cNvPr id="4" name="Oval 3"/>
+          <p:cNvSpPr/>
+          <p:nvPr/>
+        </p:nvSpPr>
+        <p:spPr>
+          <a:xfrm>
+            <a:off x="10792000" y="-1600000"/>
+            <a:ext cx="3600000" cy="3600000"/>
+          </a:xfrm>
+          <a:prstGeom prst="ellipse">
+            <a:avLst/>
+          </a:prstGeom>
+          <a:solidFill>
+            <a:srgbClr val="FFFFFF"/>
+          </a:solidFill>
+          <a:ln>
+            <a:noFill/>
+          </a:ln>
+        </p:spPr>
+        <p:style>
+          <a:lnRef idx="1">
+            <a:schemeClr val="accent1"/>
+          </a:lnRef>
+          <a:fillRef idx="3">
+            <a:schemeClr val="accent1"/>
+          </a:fillRef>
+          <a:effectRef idx="2">
+            <a:schemeClr val="accent1"/>
+          </a:effectRef>
+          <a:fontRef idx="minor">
+            <a:schemeClr val="lt1"/>
+          </a:fontRef>
+        </p:style>
+        <p:txBody>
+          <a:bodyPr rtlCol="0" anchor="ctr"/>
+          <a:lstStyle/>
+          <a:p/>
+        </p:txBody>
+      </p:sp>
+      <p:sp>
+        <p:nvSpPr>
+          <p:cNvPr id="5" name="TextBox 4"/>
           <p:cNvSpPr txBox="1"/>
           <p:nvPr/>
         </p:nvSpPr>
@@ -28954,7 +29435,75 @@
       </p:sp>
       <p:sp>
         <p:nvSpPr>
-          <p:cNvPr id="5" name="TextBox 4"/>
+          <p:cNvPr id="6" name="TextBox 5"/>
+          <p:cNvSpPr txBox="1"/>
+          <p:nvPr/>
+        </p:nvSpPr>
+        <p:spPr>
+          <a:xfrm>
+            <a:off x="600000" y="1700000"/>
+            <a:ext cx="10992000" cy="2800000"/>
+          </a:xfrm>
+          <a:prstGeom prst="rect">
+            <a:avLst/>
+          </a:prstGeom>
+          <a:noFill/>
+        </p:spPr>
+        <p:txBody>
+          <a:bodyPr wrap="square">
+            <a:spAutoFit/>
+          </a:bodyPr>
+          <a:lstStyle/>
+          <a:p>
+            <a:pPr algn="ctr"/>
+            <a:r>
+              <a:rPr sz="24000" b="1" i="0">
+                <a:solidFill>
+                  <a:srgbClr val="FFFFFF"/>
+                </a:solidFill>
+              </a:rPr>
+              <a:t>−26pp</a:t>
+            </a:r>
+          </a:p>
+        </p:txBody>
+      </p:sp>
+      <p:sp>
+        <p:nvSpPr>
+          <p:cNvPr id="7" name="TextBox 6"/>
+          <p:cNvSpPr txBox="1"/>
+          <p:nvPr/>
+        </p:nvSpPr>
+        <p:spPr>
+          <a:xfrm>
+            <a:off x="600000" y="4900000"/>
+            <a:ext cx="10992000" cy="700000"/>
+          </a:xfrm>
+          <a:prstGeom prst="rect">
+            <a:avLst/>
+          </a:prstGeom>
+          <a:noFill/>
+        </p:spPr>
+        <p:txBody>
+          <a:bodyPr wrap="square">
+            <a:spAutoFit/>
+          </a:bodyPr>
+          <a:lstStyle/>
+          <a:p>
+            <a:pPr algn="ctr"/>
+            <a:r>
+              <a:rPr sz="3200" b="0" i="1">
+                <a:solidFill>
+                  <a:srgbClr val="FFFFFF"/>
+                </a:solidFill>
+              </a:rPr>
+              <a:t>outcome gap closed</a:t>
+            </a:r>
+          </a:p>
+        </p:txBody>
+      </p:sp>
+      <p:sp>
+        <p:nvSpPr>
+          <p:cNvPr id="8" name="TextBox 7"/>
           <p:cNvSpPr txBox="1"/>
           <p:nvPr/>
         </p:nvSpPr>
@@ -29021,20 +29570,12 @@
           <a:p/>
         </p:txBody>
       </p:sp>
-      <p:pic>
-        <p:nvPicPr>
-          <p:cNvPr id="3" name="Picture 2" descr="stat-value.png"/>
-          <p:cNvPicPr>
-            <a:picLocks noChangeAspect="1"/>
-          </p:cNvPicPr>
+      <p:sp>
+        <p:nvSpPr>
+          <p:cNvPr id="3" name="Rectangle 2"/>
+          <p:cNvSpPr/>
           <p:nvPr/>
-        </p:nvPicPr>
-        <p:blipFill>
-          <a:blip r:embed="rId2"/>
-          <a:stretch>
-            <a:fillRect/>
-          </a:stretch>
-        </p:blipFill>
+        </p:nvSpPr>
         <p:spPr>
           <a:xfrm>
             <a:off x="0" y="0"/>
@@ -29043,11 +29584,77 @@
           <a:prstGeom prst="rect">
             <a:avLst/>
           </a:prstGeom>
+          <a:solidFill>
+            <a:srgbClr val="1F6B3A"/>
+          </a:solidFill>
+          <a:ln>
+            <a:noFill/>
+          </a:ln>
         </p:spPr>
-      </p:pic>
-      <p:sp>
-        <p:nvSpPr>
-          <p:cNvPr id="4" name="TextBox 3"/>
+        <p:style>
+          <a:lnRef idx="1">
+            <a:schemeClr val="accent1"/>
+          </a:lnRef>
+          <a:fillRef idx="3">
+            <a:schemeClr val="accent1"/>
+          </a:fillRef>
+          <a:effectRef idx="2">
+            <a:schemeClr val="accent1"/>
+          </a:effectRef>
+          <a:fontRef idx="minor">
+            <a:schemeClr val="lt1"/>
+          </a:fontRef>
+        </p:style>
+        <p:txBody>
+          <a:bodyPr rtlCol="0" anchor="ctr"/>
+          <a:lstStyle/>
+          <a:p/>
+        </p:txBody>
+      </p:sp>
+      <p:sp>
+        <p:nvSpPr>
+          <p:cNvPr id="4" name="Oval 3"/>
+          <p:cNvSpPr/>
+          <p:nvPr/>
+        </p:nvSpPr>
+        <p:spPr>
+          <a:xfrm>
+            <a:off x="10792000" y="-1600000"/>
+            <a:ext cx="3600000" cy="3600000"/>
+          </a:xfrm>
+          <a:prstGeom prst="ellipse">
+            <a:avLst/>
+          </a:prstGeom>
+          <a:solidFill>
+            <a:srgbClr val="FFFFFF"/>
+          </a:solidFill>
+          <a:ln>
+            <a:noFill/>
+          </a:ln>
+        </p:spPr>
+        <p:style>
+          <a:lnRef idx="1">
+            <a:schemeClr val="accent1"/>
+          </a:lnRef>
+          <a:fillRef idx="3">
+            <a:schemeClr val="accent1"/>
+          </a:fillRef>
+          <a:effectRef idx="2">
+            <a:schemeClr val="accent1"/>
+          </a:effectRef>
+          <a:fontRef idx="minor">
+            <a:schemeClr val="lt1"/>
+          </a:fontRef>
+        </p:style>
+        <p:txBody>
+          <a:bodyPr rtlCol="0" anchor="ctr"/>
+          <a:lstStyle/>
+          <a:p/>
+        </p:txBody>
+      </p:sp>
+      <p:sp>
+        <p:nvSpPr>
+          <p:cNvPr id="5" name="TextBox 4"/>
           <p:cNvSpPr txBox="1"/>
           <p:nvPr/>
         </p:nvSpPr>
@@ -29081,7 +29688,75 @@
       </p:sp>
       <p:sp>
         <p:nvSpPr>
-          <p:cNvPr id="5" name="TextBox 4"/>
+          <p:cNvPr id="6" name="TextBox 5"/>
+          <p:cNvSpPr txBox="1"/>
+          <p:nvPr/>
+        </p:nvSpPr>
+        <p:spPr>
+          <a:xfrm>
+            <a:off x="600000" y="1700000"/>
+            <a:ext cx="10992000" cy="2800000"/>
+          </a:xfrm>
+          <a:prstGeom prst="rect">
+            <a:avLst/>
+          </a:prstGeom>
+          <a:noFill/>
+        </p:spPr>
+        <p:txBody>
+          <a:bodyPr wrap="square">
+            <a:spAutoFit/>
+          </a:bodyPr>
+          <a:lstStyle/>
+          <a:p>
+            <a:pPr algn="ctr"/>
+            <a:r>
+              <a:rPr sz="24000" b="1" i="0">
+                <a:solidFill>
+                  <a:srgbClr val="FFFFFF"/>
+                </a:solidFill>
+              </a:rPr>
+              <a:t>€55M</a:t>
+            </a:r>
+          </a:p>
+        </p:txBody>
+      </p:sp>
+      <p:sp>
+        <p:nvSpPr>
+          <p:cNvPr id="7" name="TextBox 6"/>
+          <p:cNvSpPr txBox="1"/>
+          <p:nvPr/>
+        </p:nvSpPr>
+        <p:spPr>
+          <a:xfrm>
+            <a:off x="600000" y="4900000"/>
+            <a:ext cx="10992000" cy="700000"/>
+          </a:xfrm>
+          <a:prstGeom prst="rect">
+            <a:avLst/>
+          </a:prstGeom>
+          <a:noFill/>
+        </p:spPr>
+        <p:txBody>
+          <a:bodyPr wrap="square">
+            <a:spAutoFit/>
+          </a:bodyPr>
+          <a:lstStyle/>
+          <a:p>
+            <a:pPr algn="ctr"/>
+            <a:r>
+              <a:rPr sz="3200" b="0" i="1">
+                <a:solidFill>
+                  <a:srgbClr val="FFFFFF"/>
+                </a:solidFill>
+              </a:rPr>
+              <a:t>annual run-rate value</a:t>
+            </a:r>
+          </a:p>
+        </p:txBody>
+      </p:sp>
+      <p:sp>
+        <p:nvSpPr>
+          <p:cNvPr id="8" name="TextBox 7"/>
           <p:cNvSpPr txBox="1"/>
           <p:nvPr/>
         </p:nvSpPr>
@@ -29148,20 +29823,12 @@
           <a:p/>
         </p:txBody>
       </p:sp>
-      <p:pic>
-        <p:nvPicPr>
-          <p:cNvPr id="3" name="Picture 2" descr="bg-dark-grid.png"/>
-          <p:cNvPicPr>
-            <a:picLocks noChangeAspect="1"/>
-          </p:cNvPicPr>
+      <p:sp>
+        <p:nvSpPr>
+          <p:cNvPr id="3" name="Rectangle 2"/>
+          <p:cNvSpPr/>
           <p:nvPr/>
-        </p:nvPicPr>
-        <p:blipFill>
-          <a:blip r:embed="rId2"/>
-          <a:stretch>
-            <a:fillRect/>
-          </a:stretch>
-        </p:blipFill>
+        </p:nvSpPr>
         <p:spPr>
           <a:xfrm>
             <a:off x="0" y="0"/>
@@ -29170,11 +29837,77 @@
           <a:prstGeom prst="rect">
             <a:avLst/>
           </a:prstGeom>
+          <a:solidFill>
+            <a:srgbClr val="0F1B2D"/>
+          </a:solidFill>
+          <a:ln>
+            <a:noFill/>
+          </a:ln>
         </p:spPr>
-      </p:pic>
-      <p:sp>
-        <p:nvSpPr>
-          <p:cNvPr id="4" name="TextBox 3"/>
+        <p:style>
+          <a:lnRef idx="1">
+            <a:schemeClr val="accent1"/>
+          </a:lnRef>
+          <a:fillRef idx="3">
+            <a:schemeClr val="accent1"/>
+          </a:fillRef>
+          <a:effectRef idx="2">
+            <a:schemeClr val="accent1"/>
+          </a:effectRef>
+          <a:fontRef idx="minor">
+            <a:schemeClr val="lt1"/>
+          </a:fontRef>
+        </p:style>
+        <p:txBody>
+          <a:bodyPr rtlCol="0" anchor="ctr"/>
+          <a:lstStyle/>
+          <a:p/>
+        </p:txBody>
+      </p:sp>
+      <p:sp>
+        <p:nvSpPr>
+          <p:cNvPr id="4" name="Oval 3"/>
+          <p:cNvSpPr/>
+          <p:nvPr/>
+        </p:nvSpPr>
+        <p:spPr>
+          <a:xfrm>
+            <a:off x="9792000" y="-1200000"/>
+            <a:ext cx="4400000" cy="4400000"/>
+          </a:xfrm>
+          <a:prstGeom prst="ellipse">
+            <a:avLst/>
+          </a:prstGeom>
+          <a:solidFill>
+            <a:srgbClr val="122A4A"/>
+          </a:solidFill>
+          <a:ln>
+            <a:noFill/>
+          </a:ln>
+        </p:spPr>
+        <p:style>
+          <a:lnRef idx="1">
+            <a:schemeClr val="accent1"/>
+          </a:lnRef>
+          <a:fillRef idx="3">
+            <a:schemeClr val="accent1"/>
+          </a:fillRef>
+          <a:effectRef idx="2">
+            <a:schemeClr val="accent1"/>
+          </a:effectRef>
+          <a:fontRef idx="minor">
+            <a:schemeClr val="lt1"/>
+          </a:fontRef>
+        </p:style>
+        <p:txBody>
+          <a:bodyPr rtlCol="0" anchor="ctr"/>
+          <a:lstStyle/>
+          <a:p/>
+        </p:txBody>
+      </p:sp>
+      <p:sp>
+        <p:nvSpPr>
+          <p:cNvPr id="5" name="TextBox 4"/>
           <p:cNvSpPr txBox="1"/>
           <p:nvPr/>
         </p:nvSpPr>
@@ -29208,7 +29941,7 @@
       </p:sp>
       <p:sp>
         <p:nvSpPr>
-          <p:cNvPr id="5" name="TextBox 4"/>
+          <p:cNvPr id="6" name="TextBox 5"/>
           <p:cNvSpPr txBox="1"/>
           <p:nvPr/>
         </p:nvSpPr>
@@ -29240,40 +29973,98 @@
           </a:p>
         </p:txBody>
       </p:sp>
-      <p:pic>
-        <p:nvPicPr>
-          <p:cNvPr id="6" name="Picture 5" descr="persona-learner.png"/>
-          <p:cNvPicPr>
-            <a:picLocks noChangeAspect="1"/>
-          </p:cNvPicPr>
+      <p:sp>
+        <p:nvSpPr>
+          <p:cNvPr id="7" name="Rounded Rectangle 6"/>
+          <p:cNvSpPr/>
           <p:nvPr/>
-        </p:nvPicPr>
-        <p:blipFill>
-          <a:blip r:embed="rId3"/>
-          <a:stretch>
-            <a:fillRect/>
-          </a:stretch>
-        </p:blipFill>
+        </p:nvSpPr>
         <p:spPr>
           <a:xfrm>
             <a:off x="400000" y="1700000"/>
             <a:ext cx="3610666" cy="3400000"/>
           </a:xfrm>
-          <a:prstGeom prst="rect">
+          <a:prstGeom prst="roundRect">
             <a:avLst/>
           </a:prstGeom>
+          <a:solidFill>
+            <a:srgbClr val="1B3C70"/>
+          </a:solidFill>
+          <a:ln>
+            <a:noFill/>
+          </a:ln>
         </p:spPr>
-      </p:pic>
-      <p:sp>
-        <p:nvSpPr>
-          <p:cNvPr id="7" name="TextBox 6"/>
+        <p:style>
+          <a:lnRef idx="1">
+            <a:schemeClr val="accent1"/>
+          </a:lnRef>
+          <a:fillRef idx="3">
+            <a:schemeClr val="accent1"/>
+          </a:fillRef>
+          <a:effectRef idx="2">
+            <a:schemeClr val="accent1"/>
+          </a:effectRef>
+          <a:fontRef idx="minor">
+            <a:schemeClr val="lt1"/>
+          </a:fontRef>
+        </p:style>
+        <p:txBody>
+          <a:bodyPr rtlCol="0" anchor="ctr"/>
+          <a:lstStyle/>
+          <a:p/>
+        </p:txBody>
+      </p:sp>
+      <p:sp>
+        <p:nvSpPr>
+          <p:cNvPr id="8" name="Oval 7"/>
+          <p:cNvSpPr/>
+          <p:nvPr/>
+        </p:nvSpPr>
+        <p:spPr>
+          <a:xfrm>
+            <a:off x="1455333" y="2000000"/>
+            <a:ext cx="1500000" cy="1500000"/>
+          </a:xfrm>
+          <a:prstGeom prst="ellipse">
+            <a:avLst/>
+          </a:prstGeom>
+          <a:solidFill>
+            <a:srgbClr val="FFFFFF"/>
+          </a:solidFill>
+          <a:ln>
+            <a:noFill/>
+          </a:ln>
+        </p:spPr>
+        <p:style>
+          <a:lnRef idx="1">
+            <a:schemeClr val="accent1"/>
+          </a:lnRef>
+          <a:fillRef idx="3">
+            <a:schemeClr val="accent1"/>
+          </a:fillRef>
+          <a:effectRef idx="2">
+            <a:schemeClr val="accent1"/>
+          </a:effectRef>
+          <a:fontRef idx="minor">
+            <a:schemeClr val="lt1"/>
+          </a:fontRef>
+        </p:style>
+        <p:txBody>
+          <a:bodyPr rtlCol="0" anchor="ctr"/>
+          <a:lstStyle/>
+          <a:p/>
+        </p:txBody>
+      </p:sp>
+      <p:sp>
+        <p:nvSpPr>
+          <p:cNvPr id="9" name="TextBox 8"/>
           <p:cNvSpPr txBox="1"/>
           <p:nvPr/>
         </p:nvSpPr>
         <p:spPr>
           <a:xfrm>
-            <a:off x="400000" y="5200000"/>
-            <a:ext cx="3610666" cy="1200000"/>
+            <a:off x="1455333" y="2150000"/>
+            <a:ext cx="1500000" cy="1350000"/>
           </a:xfrm>
           <a:prstGeom prst="rect">
             <a:avLst/>
@@ -29288,72 +30079,26 @@
           <a:p>
             <a:pPr algn="ctr"/>
             <a:r>
-              <a:rPr sz="1800">
-                <a:solidFill>
-                  <a:srgbClr val="FFFFFF"/>
-                </a:solidFill>
-              </a:rPr>
-              <a:t>Content at his level (P-correct ≈ 0.7)</a:t>
-            </a:r>
-          </a:p>
-          <a:p>
-            <a:pPr algn="ctr"/>
-            <a:r>
-              <a:rPr sz="1800">
-                <a:solidFill>
-                  <a:srgbClr val="FFFFFF"/>
-                </a:solidFill>
-              </a:rPr>
-              <a:t>Instant formative feedback</a:t>
-            </a:r>
-          </a:p>
-          <a:p>
-            <a:pPr algn="ctr"/>
-            <a:r>
-              <a:rPr sz="1800">
-                <a:solidFill>
-                  <a:srgbClr val="FFFFFF"/>
-                </a:solidFill>
-              </a:rPr>
-              <a:t>Never punitive grading</a:t>
-            </a:r>
-          </a:p>
-        </p:txBody>
-      </p:sp>
-      <p:pic>
-        <p:nvPicPr>
-          <p:cNvPr id="8" name="Picture 7" descr="persona-teacher.png"/>
-          <p:cNvPicPr>
-            <a:picLocks noChangeAspect="1"/>
-          </p:cNvPicPr>
+              <a:rPr sz="9600" b="1" i="0">
+                <a:solidFill>
+                  <a:srgbClr val="1B3C70"/>
+                </a:solidFill>
+              </a:rPr>
+              <a:t>L</a:t>
+            </a:r>
+          </a:p>
+        </p:txBody>
+      </p:sp>
+      <p:sp>
+        <p:nvSpPr>
+          <p:cNvPr id="10" name="TextBox 9"/>
+          <p:cNvSpPr txBox="1"/>
           <p:nvPr/>
-        </p:nvPicPr>
-        <p:blipFill>
-          <a:blip r:embed="rId4"/>
-          <a:stretch>
-            <a:fillRect/>
-          </a:stretch>
-        </p:blipFill>
+        </p:nvSpPr>
         <p:spPr>
           <a:xfrm>
-            <a:off x="4290666" y="1700000"/>
-            <a:ext cx="3610666" cy="3400000"/>
-          </a:xfrm>
-          <a:prstGeom prst="rect">
-            <a:avLst/>
-          </a:prstGeom>
-        </p:spPr>
-      </p:pic>
-      <p:sp>
-        <p:nvSpPr>
-          <p:cNvPr id="9" name="TextBox 8"/>
-          <p:cNvSpPr txBox="1"/>
-          <p:nvPr/>
-        </p:nvSpPr>
-        <p:spPr>
-          <a:xfrm>
-            <a:off x="4290666" y="5200000"/>
-            <a:ext cx="3610666" cy="1200000"/>
+            <a:off x="400000" y="3700000"/>
+            <a:ext cx="3610666" cy="500000"/>
           </a:xfrm>
           <a:prstGeom prst="rect">
             <a:avLst/>
@@ -29368,62 +30113,16 @@
           <a:p>
             <a:pPr algn="ctr"/>
             <a:r>
-              <a:rPr sz="1800">
+              <a:rPr sz="2800" b="1" i="0">
                 <a:solidFill>
                   <a:srgbClr val="FFFFFF"/>
                 </a:solidFill>
               </a:rPr>
-              <a:t>45% admin time back</a:t>
-            </a:r>
-          </a:p>
-          <a:p>
-            <a:pPr algn="ctr"/>
-            <a:r>
-              <a:rPr sz="1800">
-                <a:solidFill>
-                  <a:srgbClr val="FFFFFF"/>
-                </a:solidFill>
-              </a:rPr>
-              <a:t>Every AI hint is explainable</a:t>
-            </a:r>
-          </a:p>
-          <a:p>
-            <a:pPr algn="ctr"/>
-            <a:r>
-              <a:rPr sz="1800">
-                <a:solidFill>
-                  <a:srgbClr val="FFFFFF"/>
-                </a:solidFill>
-              </a:rPr>
-              <a:t>One-click override, always</a:t>
-            </a:r>
-          </a:p>
-        </p:txBody>
-      </p:sp>
-      <p:pic>
-        <p:nvPicPr>
-          <p:cNvPr id="10" name="Picture 9" descr="persona-parent.png"/>
-          <p:cNvPicPr>
-            <a:picLocks noChangeAspect="1"/>
-          </p:cNvPicPr>
-          <p:nvPr/>
-        </p:nvPicPr>
-        <p:blipFill>
-          <a:blip r:embed="rId5"/>
-          <a:stretch>
-            <a:fillRect/>
-          </a:stretch>
-        </p:blipFill>
-        <p:spPr>
-          <a:xfrm>
-            <a:off x="8181332" y="1700000"/>
-            <a:ext cx="3610666" cy="3400000"/>
-          </a:xfrm>
-          <a:prstGeom prst="rect">
-            <a:avLst/>
-          </a:prstGeom>
-        </p:spPr>
-      </p:pic>
+              <a:t>Lucas</a:t>
+            </a:r>
+          </a:p>
+        </p:txBody>
+      </p:sp>
       <p:sp>
         <p:nvSpPr>
           <p:cNvPr id="11" name="TextBox 10"/>
@@ -29432,8 +30131,8 @@
         </p:nvSpPr>
         <p:spPr>
           <a:xfrm>
-            <a:off x="8181332" y="5200000"/>
-            <a:ext cx="3610666" cy="1200000"/>
+            <a:off x="400000" y="4200000"/>
+            <a:ext cx="3610666" cy="400000"/>
           </a:xfrm>
           <a:prstGeom prst="rect">
             <a:avLst/>
@@ -29448,18 +30147,532 @@
           <a:p>
             <a:pPr algn="ctr"/>
             <a:r>
-              <a:rPr sz="1800">
+              <a:rPr sz="1600" b="0" i="1">
+                <a:solidFill>
+                  <a:srgbClr val="C8D4E6"/>
+                </a:solidFill>
+              </a:rPr>
+              <a:t>12 · Berlin</a:t>
+            </a:r>
+          </a:p>
+        </p:txBody>
+      </p:sp>
+      <p:sp>
+        <p:nvSpPr>
+          <p:cNvPr id="12" name="TextBox 11"/>
+          <p:cNvSpPr txBox="1"/>
+          <p:nvPr/>
+        </p:nvSpPr>
+        <p:spPr>
+          <a:xfrm>
+            <a:off x="400000" y="5200000"/>
+            <a:ext cx="3610666" cy="1400000"/>
+          </a:xfrm>
+          <a:prstGeom prst="rect">
+            <a:avLst/>
+          </a:prstGeom>
+          <a:noFill/>
+        </p:spPr>
+        <p:txBody>
+          <a:bodyPr wrap="square">
+            <a:spAutoFit/>
+          </a:bodyPr>
+          <a:lstStyle/>
+          <a:p>
+            <a:pPr algn="ctr"/>
+            <a:r>
+              <a:rPr sz="1600">
                 <a:solidFill>
                   <a:srgbClr val="FFFFFF"/>
                 </a:solidFill>
               </a:rPr>
+              <a:t>Content at his level (P-correct ≈ 0.7)</a:t>
+            </a:r>
+          </a:p>
+          <a:p>
+            <a:pPr algn="ctr"/>
+            <a:r>
+              <a:rPr sz="1600">
+                <a:solidFill>
+                  <a:srgbClr val="FFFFFF"/>
+                </a:solidFill>
+              </a:rPr>
+              <a:t>Instant formative feedback</a:t>
+            </a:r>
+          </a:p>
+          <a:p>
+            <a:pPr algn="ctr"/>
+            <a:r>
+              <a:rPr sz="1600">
+                <a:solidFill>
+                  <a:srgbClr val="FFFFFF"/>
+                </a:solidFill>
+              </a:rPr>
+              <a:t>Never punitive grading</a:t>
+            </a:r>
+          </a:p>
+        </p:txBody>
+      </p:sp>
+      <p:sp>
+        <p:nvSpPr>
+          <p:cNvPr id="13" name="Rounded Rectangle 12"/>
+          <p:cNvSpPr/>
+          <p:nvPr/>
+        </p:nvSpPr>
+        <p:spPr>
+          <a:xfrm>
+            <a:off x="4290666" y="1700000"/>
+            <a:ext cx="3610666" cy="3400000"/>
+          </a:xfrm>
+          <a:prstGeom prst="roundRect">
+            <a:avLst/>
+          </a:prstGeom>
+          <a:solidFill>
+            <a:srgbClr val="8F5210"/>
+          </a:solidFill>
+          <a:ln>
+            <a:noFill/>
+          </a:ln>
+        </p:spPr>
+        <p:style>
+          <a:lnRef idx="1">
+            <a:schemeClr val="accent1"/>
+          </a:lnRef>
+          <a:fillRef idx="3">
+            <a:schemeClr val="accent1"/>
+          </a:fillRef>
+          <a:effectRef idx="2">
+            <a:schemeClr val="accent1"/>
+          </a:effectRef>
+          <a:fontRef idx="minor">
+            <a:schemeClr val="lt1"/>
+          </a:fontRef>
+        </p:style>
+        <p:txBody>
+          <a:bodyPr rtlCol="0" anchor="ctr"/>
+          <a:lstStyle/>
+          <a:p/>
+        </p:txBody>
+      </p:sp>
+      <p:sp>
+        <p:nvSpPr>
+          <p:cNvPr id="14" name="Oval 13"/>
+          <p:cNvSpPr/>
+          <p:nvPr/>
+        </p:nvSpPr>
+        <p:spPr>
+          <a:xfrm>
+            <a:off x="5345999" y="2000000"/>
+            <a:ext cx="1500000" cy="1500000"/>
+          </a:xfrm>
+          <a:prstGeom prst="ellipse">
+            <a:avLst/>
+          </a:prstGeom>
+          <a:solidFill>
+            <a:srgbClr val="FFFFFF"/>
+          </a:solidFill>
+          <a:ln>
+            <a:noFill/>
+          </a:ln>
+        </p:spPr>
+        <p:style>
+          <a:lnRef idx="1">
+            <a:schemeClr val="accent1"/>
+          </a:lnRef>
+          <a:fillRef idx="3">
+            <a:schemeClr val="accent1"/>
+          </a:fillRef>
+          <a:effectRef idx="2">
+            <a:schemeClr val="accent1"/>
+          </a:effectRef>
+          <a:fontRef idx="minor">
+            <a:schemeClr val="lt1"/>
+          </a:fontRef>
+        </p:style>
+        <p:txBody>
+          <a:bodyPr rtlCol="0" anchor="ctr"/>
+          <a:lstStyle/>
+          <a:p/>
+        </p:txBody>
+      </p:sp>
+      <p:sp>
+        <p:nvSpPr>
+          <p:cNvPr id="15" name="TextBox 14"/>
+          <p:cNvSpPr txBox="1"/>
+          <p:nvPr/>
+        </p:nvSpPr>
+        <p:spPr>
+          <a:xfrm>
+            <a:off x="5345999" y="2150000"/>
+            <a:ext cx="1500000" cy="1350000"/>
+          </a:xfrm>
+          <a:prstGeom prst="rect">
+            <a:avLst/>
+          </a:prstGeom>
+          <a:noFill/>
+        </p:spPr>
+        <p:txBody>
+          <a:bodyPr wrap="square">
+            <a:spAutoFit/>
+          </a:bodyPr>
+          <a:lstStyle/>
+          <a:p>
+            <a:pPr algn="ctr"/>
+            <a:r>
+              <a:rPr sz="9600" b="1" i="0">
+                <a:solidFill>
+                  <a:srgbClr val="8F5210"/>
+                </a:solidFill>
+              </a:rPr>
+              <a:t>K</a:t>
+            </a:r>
+          </a:p>
+        </p:txBody>
+      </p:sp>
+      <p:sp>
+        <p:nvSpPr>
+          <p:cNvPr id="16" name="TextBox 15"/>
+          <p:cNvSpPr txBox="1"/>
+          <p:nvPr/>
+        </p:nvSpPr>
+        <p:spPr>
+          <a:xfrm>
+            <a:off x="4290666" y="3700000"/>
+            <a:ext cx="3610666" cy="500000"/>
+          </a:xfrm>
+          <a:prstGeom prst="rect">
+            <a:avLst/>
+          </a:prstGeom>
+          <a:noFill/>
+        </p:spPr>
+        <p:txBody>
+          <a:bodyPr wrap="square">
+            <a:spAutoFit/>
+          </a:bodyPr>
+          <a:lstStyle/>
+          <a:p>
+            <a:pPr algn="ctr"/>
+            <a:r>
+              <a:rPr sz="2800" b="1" i="0">
+                <a:solidFill>
+                  <a:srgbClr val="FFFFFF"/>
+                </a:solidFill>
+              </a:rPr>
+              <a:t>Mr Klein</a:t>
+            </a:r>
+          </a:p>
+        </p:txBody>
+      </p:sp>
+      <p:sp>
+        <p:nvSpPr>
+          <p:cNvPr id="17" name="TextBox 16"/>
+          <p:cNvSpPr txBox="1"/>
+          <p:nvPr/>
+        </p:nvSpPr>
+        <p:spPr>
+          <a:xfrm>
+            <a:off x="4290666" y="4200000"/>
+            <a:ext cx="3610666" cy="400000"/>
+          </a:xfrm>
+          <a:prstGeom prst="rect">
+            <a:avLst/>
+          </a:prstGeom>
+          <a:noFill/>
+        </p:spPr>
+        <p:txBody>
+          <a:bodyPr wrap="square">
+            <a:spAutoFit/>
+          </a:bodyPr>
+          <a:lstStyle/>
+          <a:p>
+            <a:pPr algn="ctr"/>
+            <a:r>
+              <a:rPr sz="1600" b="0" i="1">
+                <a:solidFill>
+                  <a:srgbClr val="C8D4E6"/>
+                </a:solidFill>
+              </a:rPr>
+              <a:t>Year-7 maths</a:t>
+            </a:r>
+          </a:p>
+        </p:txBody>
+      </p:sp>
+      <p:sp>
+        <p:nvSpPr>
+          <p:cNvPr id="18" name="TextBox 17"/>
+          <p:cNvSpPr txBox="1"/>
+          <p:nvPr/>
+        </p:nvSpPr>
+        <p:spPr>
+          <a:xfrm>
+            <a:off x="4290666" y="5200000"/>
+            <a:ext cx="3610666" cy="1400000"/>
+          </a:xfrm>
+          <a:prstGeom prst="rect">
+            <a:avLst/>
+          </a:prstGeom>
+          <a:noFill/>
+        </p:spPr>
+        <p:txBody>
+          <a:bodyPr wrap="square">
+            <a:spAutoFit/>
+          </a:bodyPr>
+          <a:lstStyle/>
+          <a:p>
+            <a:pPr algn="ctr"/>
+            <a:r>
+              <a:rPr sz="1600">
+                <a:solidFill>
+                  <a:srgbClr val="FFFFFF"/>
+                </a:solidFill>
+              </a:rPr>
+              <a:t>45% admin time back</a:t>
+            </a:r>
+          </a:p>
+          <a:p>
+            <a:pPr algn="ctr"/>
+            <a:r>
+              <a:rPr sz="1600">
+                <a:solidFill>
+                  <a:srgbClr val="FFFFFF"/>
+                </a:solidFill>
+              </a:rPr>
+              <a:t>Every AI hint is explainable</a:t>
+            </a:r>
+          </a:p>
+          <a:p>
+            <a:pPr algn="ctr"/>
+            <a:r>
+              <a:rPr sz="1600">
+                <a:solidFill>
+                  <a:srgbClr val="FFFFFF"/>
+                </a:solidFill>
+              </a:rPr>
+              <a:t>One-click override, always</a:t>
+            </a:r>
+          </a:p>
+        </p:txBody>
+      </p:sp>
+      <p:sp>
+        <p:nvSpPr>
+          <p:cNvPr id="19" name="Rounded Rectangle 18"/>
+          <p:cNvSpPr/>
+          <p:nvPr/>
+        </p:nvSpPr>
+        <p:spPr>
+          <a:xfrm>
+            <a:off x="8181332" y="1700000"/>
+            <a:ext cx="3610666" cy="3400000"/>
+          </a:xfrm>
+          <a:prstGeom prst="roundRect">
+            <a:avLst/>
+          </a:prstGeom>
+          <a:solidFill>
+            <a:srgbClr val="1F6B3A"/>
+          </a:solidFill>
+          <a:ln>
+            <a:noFill/>
+          </a:ln>
+        </p:spPr>
+        <p:style>
+          <a:lnRef idx="1">
+            <a:schemeClr val="accent1"/>
+          </a:lnRef>
+          <a:fillRef idx="3">
+            <a:schemeClr val="accent1"/>
+          </a:fillRef>
+          <a:effectRef idx="2">
+            <a:schemeClr val="accent1"/>
+          </a:effectRef>
+          <a:fontRef idx="minor">
+            <a:schemeClr val="lt1"/>
+          </a:fontRef>
+        </p:style>
+        <p:txBody>
+          <a:bodyPr rtlCol="0" anchor="ctr"/>
+          <a:lstStyle/>
+          <a:p/>
+        </p:txBody>
+      </p:sp>
+      <p:sp>
+        <p:nvSpPr>
+          <p:cNvPr id="20" name="Oval 19"/>
+          <p:cNvSpPr/>
+          <p:nvPr/>
+        </p:nvSpPr>
+        <p:spPr>
+          <a:xfrm>
+            <a:off x="9236665" y="2000000"/>
+            <a:ext cx="1500000" cy="1500000"/>
+          </a:xfrm>
+          <a:prstGeom prst="ellipse">
+            <a:avLst/>
+          </a:prstGeom>
+          <a:solidFill>
+            <a:srgbClr val="FFFFFF"/>
+          </a:solidFill>
+          <a:ln>
+            <a:noFill/>
+          </a:ln>
+        </p:spPr>
+        <p:style>
+          <a:lnRef idx="1">
+            <a:schemeClr val="accent1"/>
+          </a:lnRef>
+          <a:fillRef idx="3">
+            <a:schemeClr val="accent1"/>
+          </a:fillRef>
+          <a:effectRef idx="2">
+            <a:schemeClr val="accent1"/>
+          </a:effectRef>
+          <a:fontRef idx="minor">
+            <a:schemeClr val="lt1"/>
+          </a:fontRef>
+        </p:style>
+        <p:txBody>
+          <a:bodyPr rtlCol="0" anchor="ctr"/>
+          <a:lstStyle/>
+          <a:p/>
+        </p:txBody>
+      </p:sp>
+      <p:sp>
+        <p:nvSpPr>
+          <p:cNvPr id="21" name="TextBox 20"/>
+          <p:cNvSpPr txBox="1"/>
+          <p:nvPr/>
+        </p:nvSpPr>
+        <p:spPr>
+          <a:xfrm>
+            <a:off x="9236665" y="2150000"/>
+            <a:ext cx="1500000" cy="1350000"/>
+          </a:xfrm>
+          <a:prstGeom prst="rect">
+            <a:avLst/>
+          </a:prstGeom>
+          <a:noFill/>
+        </p:spPr>
+        <p:txBody>
+          <a:bodyPr wrap="square">
+            <a:spAutoFit/>
+          </a:bodyPr>
+          <a:lstStyle/>
+          <a:p>
+            <a:pPr algn="ctr"/>
+            <a:r>
+              <a:rPr sz="9600" b="1" i="0">
+                <a:solidFill>
+                  <a:srgbClr val="1F6B3A"/>
+                </a:solidFill>
+              </a:rPr>
+              <a:t>S</a:t>
+            </a:r>
+          </a:p>
+        </p:txBody>
+      </p:sp>
+      <p:sp>
+        <p:nvSpPr>
+          <p:cNvPr id="22" name="TextBox 21"/>
+          <p:cNvSpPr txBox="1"/>
+          <p:nvPr/>
+        </p:nvSpPr>
+        <p:spPr>
+          <a:xfrm>
+            <a:off x="8181332" y="3700000"/>
+            <a:ext cx="3610666" cy="500000"/>
+          </a:xfrm>
+          <a:prstGeom prst="rect">
+            <a:avLst/>
+          </a:prstGeom>
+          <a:noFill/>
+        </p:spPr>
+        <p:txBody>
+          <a:bodyPr wrap="square">
+            <a:spAutoFit/>
+          </a:bodyPr>
+          <a:lstStyle/>
+          <a:p>
+            <a:pPr algn="ctr"/>
+            <a:r>
+              <a:rPr sz="2800" b="1" i="0">
+                <a:solidFill>
+                  <a:srgbClr val="FFFFFF"/>
+                </a:solidFill>
+              </a:rPr>
+              <a:t>Sophie</a:t>
+            </a:r>
+          </a:p>
+        </p:txBody>
+      </p:sp>
+      <p:sp>
+        <p:nvSpPr>
+          <p:cNvPr id="23" name="TextBox 22"/>
+          <p:cNvSpPr txBox="1"/>
+          <p:nvPr/>
+        </p:nvSpPr>
+        <p:spPr>
+          <a:xfrm>
+            <a:off x="8181332" y="4200000"/>
+            <a:ext cx="3610666" cy="400000"/>
+          </a:xfrm>
+          <a:prstGeom prst="rect">
+            <a:avLst/>
+          </a:prstGeom>
+          <a:noFill/>
+        </p:spPr>
+        <p:txBody>
+          <a:bodyPr wrap="square">
+            <a:spAutoFit/>
+          </a:bodyPr>
+          <a:lstStyle/>
+          <a:p>
+            <a:pPr algn="ctr"/>
+            <a:r>
+              <a:rPr sz="1600" b="0" i="1">
+                <a:solidFill>
+                  <a:srgbClr val="C8D4E6"/>
+                </a:solidFill>
+              </a:rPr>
+              <a:t>Lucas' mother</a:t>
+            </a:r>
+          </a:p>
+        </p:txBody>
+      </p:sp>
+      <p:sp>
+        <p:nvSpPr>
+          <p:cNvPr id="24" name="TextBox 23"/>
+          <p:cNvSpPr txBox="1"/>
+          <p:nvPr/>
+        </p:nvSpPr>
+        <p:spPr>
+          <a:xfrm>
+            <a:off x="8181332" y="5200000"/>
+            <a:ext cx="3610666" cy="1400000"/>
+          </a:xfrm>
+          <a:prstGeom prst="rect">
+            <a:avLst/>
+          </a:prstGeom>
+          <a:noFill/>
+        </p:spPr>
+        <p:txBody>
+          <a:bodyPr wrap="square">
+            <a:spAutoFit/>
+          </a:bodyPr>
+          <a:lstStyle/>
+          <a:p>
+            <a:pPr algn="ctr"/>
+            <a:r>
+              <a:rPr sz="1600">
+                <a:solidFill>
+                  <a:srgbClr val="FFFFFF"/>
+                </a:solidFill>
+              </a:rPr>
               <a:t>Native-language portal</a:t>
             </a:r>
           </a:p>
           <a:p>
             <a:pPr algn="ctr"/>
             <a:r>
-              <a:rPr sz="1800">
+              <a:rPr sz="1600">
                 <a:solidFill>
                   <a:srgbClr val="FFFFFF"/>
                 </a:solidFill>
@@ -29470,7 +30683,7 @@
           <a:p>
             <a:pPr algn="ctr"/>
             <a:r>
-              <a:rPr sz="1800">
+              <a:rPr sz="1600">
                 <a:solidFill>
                   <a:srgbClr val="FFFFFF"/>
                 </a:solidFill>

</xml_diff>

<commit_message>
feat(restitution): turn slide 2 into a 4-stat board takeaway grid
Replace the dense 2-column exec summary with a punchy 2x2 grid of huge editable stat tiles (4.1M / -26pp / -45% / 100%) using a new 'statgrid' render mode. Background and tiles are all native PowerPoint shapes.

Co-authored-by: Copilot <223556219+Copilot@users.noreply.github.com>
</commit_message>
<xml_diff>
--- a/Restitution01/build/LearnEU-CXO-Restitution.pptx
+++ b/Restitution01/build/LearnEU-CXO-Restitution.pptx
@@ -1919,7 +1919,7 @@
           <a:lstStyle/>
           <a:p>
             <a:r>
-              <a:t>Si vous ne reteniez qu'une slide, ce serait celle-ci. À gauche, le contrat de sortie : quatre chiffres tirés mot pour mot du case study, plus la résidence EU. À droite, ce que cela demande au board : douze mois, cinq phases, environ vingt millions d'euros, et trois décisions à prendre aujourd'hui — mandat DPIA, budget Phase 0, nomination du président du Conseil RAI. Le reste du deck décline chacun de ces points pour le CXO concerné, et les annexes sont là pour tenir le débat.</a:t>
+              <a:t>Si vous ne reteniez qu'une slide, ce serait celle-ci. Quatre chiffres, un contrat, zéro excuse. Quatre millions cent mille apprenants concernés. Vingt-six points d'écart de résultats fermés en douze mois. Quarante-cinq pour cent de temps administratif rendu aux enseignants. Et cent pour cent de conformité — GDPR Article 8 et AI Act marquage CE — en permanence. Le reste du deck décline chacun de ces chiffres pour le CXO concerné, et les annexes sont là pour le débat. Le board est sollicité sur trois décisions à la slide 21 : mandat DPIA, budget Phase 0, président du Conseil RAI.</a:t>
             </a:r>
           </a:p>
           <a:p/>
@@ -1935,7 +1935,7 @@
           </a:p>
           <a:p>
             <a:r>
-              <a:t>Visual: Two stacked cards. Left = 4 outcome chips in orange. Right = 4 commitment chips in teal. Big "Grade A · 57/60" badge bottom-right.</a:t>
+              <a:t>Visual: 2×2 grid of huge editable stat tiles in orange/teal/navy/green.</a:t>
             </a:r>
           </a:p>
           <a:p>
@@ -23333,28 +23333,142 @@
         <p:txBody>
           <a:bodyPr/>
           <a:lstStyle/>
-          <a:p>
-            <a:r>
-              <a:rPr>
-                <a:solidFill>
-                  <a:srgbClr val="FFFFFF"/>
-                </a:solidFill>
-              </a:rPr>
-              <a:t>One page: what we are committing to</a:t>
-            </a:r>
-          </a:p>
-        </p:txBody>
-      </p:sp>
-      <p:sp>
-        <p:nvSpPr>
-          <p:cNvPr id="3" name="TextBox 2"/>
+          <a:p/>
+        </p:txBody>
+      </p:sp>
+      <p:sp>
+        <p:nvSpPr>
+          <p:cNvPr id="3" name="Rectangle 2"/>
+          <p:cNvSpPr/>
+          <p:nvPr/>
+        </p:nvSpPr>
+        <p:spPr>
+          <a:xfrm>
+            <a:off x="0" y="0"/>
+            <a:ext cx="12192000" cy="6858000"/>
+          </a:xfrm>
+          <a:prstGeom prst="rect">
+            <a:avLst/>
+          </a:prstGeom>
+          <a:solidFill>
+            <a:srgbClr val="122A4A"/>
+          </a:solidFill>
+          <a:ln>
+            <a:noFill/>
+          </a:ln>
+        </p:spPr>
+        <p:style>
+          <a:lnRef idx="1">
+            <a:schemeClr val="accent1"/>
+          </a:lnRef>
+          <a:fillRef idx="3">
+            <a:schemeClr val="accent1"/>
+          </a:fillRef>
+          <a:effectRef idx="2">
+            <a:schemeClr val="accent1"/>
+          </a:effectRef>
+          <a:fontRef idx="minor">
+            <a:schemeClr val="lt1"/>
+          </a:fontRef>
+        </p:style>
+        <p:txBody>
+          <a:bodyPr rtlCol="0" anchor="ctr"/>
+          <a:lstStyle/>
+          <a:p/>
+        </p:txBody>
+      </p:sp>
+      <p:sp>
+        <p:nvSpPr>
+          <p:cNvPr id="4" name="Oval 3"/>
+          <p:cNvSpPr/>
+          <p:nvPr/>
+        </p:nvSpPr>
+        <p:spPr>
+          <a:xfrm>
+            <a:off x="9792000" y="-1200000"/>
+            <a:ext cx="4400000" cy="4400000"/>
+          </a:xfrm>
+          <a:prstGeom prst="ellipse">
+            <a:avLst/>
+          </a:prstGeom>
+          <a:solidFill>
+            <a:srgbClr val="F28C00"/>
+          </a:solidFill>
+          <a:ln>
+            <a:noFill/>
+          </a:ln>
+        </p:spPr>
+        <p:style>
+          <a:lnRef idx="1">
+            <a:schemeClr val="accent1"/>
+          </a:lnRef>
+          <a:fillRef idx="3">
+            <a:schemeClr val="accent1"/>
+          </a:fillRef>
+          <a:effectRef idx="2">
+            <a:schemeClr val="accent1"/>
+          </a:effectRef>
+          <a:fontRef idx="minor">
+            <a:schemeClr val="lt1"/>
+          </a:fontRef>
+        </p:style>
+        <p:txBody>
+          <a:bodyPr rtlCol="0" anchor="ctr"/>
+          <a:lstStyle/>
+          <a:p/>
+        </p:txBody>
+      </p:sp>
+      <p:sp>
+        <p:nvSpPr>
+          <p:cNvPr id="5" name="Oval 4"/>
+          <p:cNvSpPr/>
+          <p:nvPr/>
+        </p:nvSpPr>
+        <p:spPr>
+          <a:xfrm>
+            <a:off x="-1400000" y="4258000"/>
+            <a:ext cx="4000000" cy="4000000"/>
+          </a:xfrm>
+          <a:prstGeom prst="ellipse">
+            <a:avLst/>
+          </a:prstGeom>
+          <a:solidFill>
+            <a:srgbClr val="0E5A5A"/>
+          </a:solidFill>
+          <a:ln>
+            <a:noFill/>
+          </a:ln>
+        </p:spPr>
+        <p:style>
+          <a:lnRef idx="1">
+            <a:schemeClr val="accent1"/>
+          </a:lnRef>
+          <a:fillRef idx="3">
+            <a:schemeClr val="accent1"/>
+          </a:fillRef>
+          <a:effectRef idx="2">
+            <a:schemeClr val="accent1"/>
+          </a:effectRef>
+          <a:fontRef idx="minor">
+            <a:schemeClr val="lt1"/>
+          </a:fontRef>
+        </p:style>
+        <p:txBody>
+          <a:bodyPr rtlCol="0" anchor="ctr"/>
+          <a:lstStyle/>
+          <a:p/>
+        </p:txBody>
+      </p:sp>
+      <p:sp>
+        <p:nvSpPr>
+          <p:cNvPr id="6" name="TextBox 5"/>
           <p:cNvSpPr txBox="1"/>
           <p:nvPr/>
         </p:nvSpPr>
         <p:spPr>
           <a:xfrm>
-            <a:off x="640000" y="950000"/>
-            <a:ext cx="10912000" cy="360000"/>
+            <a:off x="600000" y="280000"/>
+            <a:ext cx="10992000" cy="540000"/>
           </a:xfrm>
           <a:prstGeom prst="rect">
             <a:avLst/>
@@ -23367,27 +23481,280 @@
           </a:bodyPr>
           <a:lstStyle/>
           <a:p>
-            <a:r>
-              <a:rPr sz="1800" i="1">
+            <a:pPr algn="ctr"/>
+            <a:r>
+              <a:rPr sz="3200" b="1" i="0">
+                <a:solidFill>
+                  <a:srgbClr val="FFFFFF"/>
+                </a:solidFill>
+              </a:rPr>
+              <a:t>What we sign for</a:t>
+            </a:r>
+          </a:p>
+        </p:txBody>
+      </p:sp>
+      <p:sp>
+        <p:nvSpPr>
+          <p:cNvPr id="7" name="TextBox 6"/>
+          <p:cNvSpPr txBox="1"/>
+          <p:nvPr/>
+        </p:nvSpPr>
+        <p:spPr>
+          <a:xfrm>
+            <a:off x="600000" y="820000"/>
+            <a:ext cx="10992000" cy="480000"/>
+          </a:xfrm>
+          <a:prstGeom prst="rect">
+            <a:avLst/>
+          </a:prstGeom>
+          <a:noFill/>
+        </p:spPr>
+        <p:txBody>
+          <a:bodyPr wrap="square">
+            <a:spAutoFit/>
+          </a:bodyPr>
+          <a:lstStyle/>
+          <a:p>
+            <a:pPr algn="ctr"/>
+            <a:r>
+              <a:rPr sz="2000" b="0" i="1">
                 <a:solidFill>
                   <a:srgbClr val="C8D4E6"/>
                 </a:solidFill>
               </a:rPr>
-              <a:t>Outcome, posture, ask — in 60 seconds</a:t>
-            </a:r>
-          </a:p>
-        </p:txBody>
-      </p:sp>
-      <p:sp>
-        <p:nvSpPr>
-          <p:cNvPr id="4" name="Rounded Rectangle 3"/>
+              <a:t>4 numbers · 1 contract · 0 excuses</a:t>
+            </a:r>
+          </a:p>
+        </p:txBody>
+      </p:sp>
+      <p:sp>
+        <p:nvSpPr>
+          <p:cNvPr id="8" name="Rounded Rectangle 7"/>
           <p:cNvSpPr/>
           <p:nvPr/>
         </p:nvSpPr>
         <p:spPr>
           <a:xfrm>
-            <a:off x="600000" y="1400000"/>
-            <a:ext cx="5376000" cy="5098000"/>
+            <a:off x="600000" y="1500000"/>
+            <a:ext cx="5356000" cy="2239000"/>
+          </a:xfrm>
+          <a:prstGeom prst="roundRect">
+            <a:avLst/>
+          </a:prstGeom>
+          <a:solidFill>
+            <a:srgbClr val="F28C00"/>
+          </a:solidFill>
+          <a:ln>
+            <a:noFill/>
+          </a:ln>
+        </p:spPr>
+        <p:style>
+          <a:lnRef idx="1">
+            <a:schemeClr val="accent1"/>
+          </a:lnRef>
+          <a:fillRef idx="3">
+            <a:schemeClr val="accent1"/>
+          </a:fillRef>
+          <a:effectRef idx="2">
+            <a:schemeClr val="accent1"/>
+          </a:effectRef>
+          <a:fontRef idx="minor">
+            <a:schemeClr val="lt1"/>
+          </a:fontRef>
+        </p:style>
+        <p:txBody>
+          <a:bodyPr rtlCol="0" anchor="ctr"/>
+          <a:lstStyle/>
+          <a:p/>
+        </p:txBody>
+      </p:sp>
+      <p:sp>
+        <p:nvSpPr>
+          <p:cNvPr id="9" name="TextBox 8"/>
+          <p:cNvSpPr txBox="1"/>
+          <p:nvPr/>
+        </p:nvSpPr>
+        <p:spPr>
+          <a:xfrm>
+            <a:off x="600000" y="1700000"/>
+            <a:ext cx="5356000" cy="1119500"/>
+          </a:xfrm>
+          <a:prstGeom prst="rect">
+            <a:avLst/>
+          </a:prstGeom>
+          <a:noFill/>
+        </p:spPr>
+        <p:txBody>
+          <a:bodyPr wrap="square">
+            <a:spAutoFit/>
+          </a:bodyPr>
+          <a:lstStyle/>
+          <a:p>
+            <a:pPr algn="ctr"/>
+            <a:r>
+              <a:rPr sz="9600" b="1" i="0">
+                <a:solidFill>
+                  <a:srgbClr val="FFFFFF"/>
+                </a:solidFill>
+              </a:rPr>
+              <a:t>4.1M</a:t>
+            </a:r>
+          </a:p>
+        </p:txBody>
+      </p:sp>
+      <p:sp>
+        <p:nvSpPr>
+          <p:cNvPr id="10" name="TextBox 9"/>
+          <p:cNvSpPr txBox="1"/>
+          <p:nvPr/>
+        </p:nvSpPr>
+        <p:spPr>
+          <a:xfrm>
+            <a:off x="900000" y="3019500"/>
+            <a:ext cx="4756000" cy="619500"/>
+          </a:xfrm>
+          <a:prstGeom prst="rect">
+            <a:avLst/>
+          </a:prstGeom>
+          <a:noFill/>
+        </p:spPr>
+        <p:txBody>
+          <a:bodyPr wrap="square">
+            <a:spAutoFit/>
+          </a:bodyPr>
+          <a:lstStyle/>
+          <a:p>
+            <a:pPr algn="ctr"/>
+            <a:r>
+              <a:rPr sz="2000" b="0" i="1">
+                <a:solidFill>
+                  <a:srgbClr val="FFFFFF"/>
+                </a:solidFill>
+              </a:rPr>
+              <a:t>EU learners in scope (NL · BE · DE · PL · RO)</a:t>
+            </a:r>
+          </a:p>
+        </p:txBody>
+      </p:sp>
+      <p:sp>
+        <p:nvSpPr>
+          <p:cNvPr id="11" name="Rounded Rectangle 10"/>
+          <p:cNvSpPr/>
+          <p:nvPr/>
+        </p:nvSpPr>
+        <p:spPr>
+          <a:xfrm>
+            <a:off x="6236000" y="1500000"/>
+            <a:ext cx="5356000" cy="2239000"/>
+          </a:xfrm>
+          <a:prstGeom prst="roundRect">
+            <a:avLst/>
+          </a:prstGeom>
+          <a:solidFill>
+            <a:srgbClr val="0E5A5A"/>
+          </a:solidFill>
+          <a:ln>
+            <a:noFill/>
+          </a:ln>
+        </p:spPr>
+        <p:style>
+          <a:lnRef idx="1">
+            <a:schemeClr val="accent1"/>
+          </a:lnRef>
+          <a:fillRef idx="3">
+            <a:schemeClr val="accent1"/>
+          </a:fillRef>
+          <a:effectRef idx="2">
+            <a:schemeClr val="accent1"/>
+          </a:effectRef>
+          <a:fontRef idx="minor">
+            <a:schemeClr val="lt1"/>
+          </a:fontRef>
+        </p:style>
+        <p:txBody>
+          <a:bodyPr rtlCol="0" anchor="ctr"/>
+          <a:lstStyle/>
+          <a:p/>
+        </p:txBody>
+      </p:sp>
+      <p:sp>
+        <p:nvSpPr>
+          <p:cNvPr id="12" name="TextBox 11"/>
+          <p:cNvSpPr txBox="1"/>
+          <p:nvPr/>
+        </p:nvSpPr>
+        <p:spPr>
+          <a:xfrm>
+            <a:off x="6236000" y="1700000"/>
+            <a:ext cx="5356000" cy="1119500"/>
+          </a:xfrm>
+          <a:prstGeom prst="rect">
+            <a:avLst/>
+          </a:prstGeom>
+          <a:noFill/>
+        </p:spPr>
+        <p:txBody>
+          <a:bodyPr wrap="square">
+            <a:spAutoFit/>
+          </a:bodyPr>
+          <a:lstStyle/>
+          <a:p>
+            <a:pPr algn="ctr"/>
+            <a:r>
+              <a:rPr sz="9600" b="1" i="0">
+                <a:solidFill>
+                  <a:srgbClr val="FFFFFF"/>
+                </a:solidFill>
+              </a:rPr>
+              <a:t>−26pp</a:t>
+            </a:r>
+          </a:p>
+        </p:txBody>
+      </p:sp>
+      <p:sp>
+        <p:nvSpPr>
+          <p:cNvPr id="13" name="TextBox 12"/>
+          <p:cNvSpPr txBox="1"/>
+          <p:nvPr/>
+        </p:nvSpPr>
+        <p:spPr>
+          <a:xfrm>
+            <a:off x="6536000" y="3019500"/>
+            <a:ext cx="4756000" cy="619500"/>
+          </a:xfrm>
+          <a:prstGeom prst="rect">
+            <a:avLst/>
+          </a:prstGeom>
+          <a:noFill/>
+        </p:spPr>
+        <p:txBody>
+          <a:bodyPr wrap="square">
+            <a:spAutoFit/>
+          </a:bodyPr>
+          <a:lstStyle/>
+          <a:p>
+            <a:pPr algn="ctr"/>
+            <a:r>
+              <a:rPr sz="2000" b="0" i="1">
+                <a:solidFill>
+                  <a:srgbClr val="FFFFFF"/>
+                </a:solidFill>
+              </a:rPr>
+              <a:t>outcome-gap closed in 12 months</a:t>
+            </a:r>
+          </a:p>
+        </p:txBody>
+      </p:sp>
+      <p:sp>
+        <p:nvSpPr>
+          <p:cNvPr id="14" name="Rounded Rectangle 13"/>
+          <p:cNvSpPr/>
+          <p:nvPr/>
+        </p:nvSpPr>
+        <p:spPr>
+          <a:xfrm>
+            <a:off x="600000" y="4019000"/>
+            <a:ext cx="5356000" cy="2239000"/>
           </a:xfrm>
           <a:prstGeom prst="roundRect">
             <a:avLst/>
@@ -23395,12 +23762,9 @@
           <a:solidFill>
             <a:srgbClr val="122A4A"/>
           </a:solidFill>
-          <a:ln w="12700">
-            <a:solidFill>
-              <a:srgbClr val="2A4A78"/>
-            </a:solidFill>
+          <a:ln>
+            <a:noFill/>
           </a:ln>
-          <a:effectLst/>
         </p:spPr>
         <p:style>
           <a:lnRef idx="1">
@@ -23417,88 +23781,99 @@
           </a:fontRef>
         </p:style>
         <p:txBody>
-          <a:bodyPr rtlCol="0" anchor="t" wrap="square" lIns="120000" rIns="120000" tIns="80000" bIns="80000"/>
+          <a:bodyPr rtlCol="0" anchor="ctr"/>
           <a:lstStyle/>
+          <a:p/>
+        </p:txBody>
+      </p:sp>
+      <p:sp>
+        <p:nvSpPr>
+          <p:cNvPr id="15" name="TextBox 14"/>
+          <p:cNvSpPr txBox="1"/>
+          <p:nvPr/>
+        </p:nvSpPr>
+        <p:spPr>
+          <a:xfrm>
+            <a:off x="600000" y="4219000"/>
+            <a:ext cx="5356000" cy="1119500"/>
+          </a:xfrm>
+          <a:prstGeom prst="rect">
+            <a:avLst/>
+          </a:prstGeom>
+          <a:noFill/>
+        </p:spPr>
+        <p:txBody>
+          <a:bodyPr wrap="square">
+            <a:spAutoFit/>
+          </a:bodyPr>
+          <a:lstStyle/>
           <a:p>
             <a:pPr algn="ctr"/>
             <a:r>
-              <a:rPr sz="1600" b="1">
-                <a:solidFill>
-                  <a:srgbClr val="F28C00"/>
-                </a:solidFill>
-              </a:rPr>
-              <a:t>WHAT WE DELIVER</a:t>
-            </a:r>
-          </a:p>
-          <a:p>
-            <a:pPr/>
-            <a:r>
-              <a:rPr sz="1800" b="0">
+              <a:rPr sz="9600" b="1" i="0">
                 <a:solidFill>
                   <a:srgbClr val="FFFFFF"/>
                 </a:solidFill>
               </a:rPr>
-              <a:t>• Privacy-preserving personalised learning for 4.1M minors in NL/BE/DE/PL/RO</a:t>
-            </a:r>
-          </a:p>
-          <a:p>
-            <a:pPr/>
-            <a:r>
-              <a:rPr sz="1800" b="0">
+              <a:t>−45%</a:t>
+            </a:r>
+          </a:p>
+        </p:txBody>
+      </p:sp>
+      <p:sp>
+        <p:nvSpPr>
+          <p:cNvPr id="16" name="TextBox 15"/>
+          <p:cNvSpPr txBox="1"/>
+          <p:nvPr/>
+        </p:nvSpPr>
+        <p:spPr>
+          <a:xfrm>
+            <a:off x="900000" y="5538500"/>
+            <a:ext cx="4756000" cy="619500"/>
+          </a:xfrm>
+          <a:prstGeom prst="rect">
+            <a:avLst/>
+          </a:prstGeom>
+          <a:noFill/>
+        </p:spPr>
+        <p:txBody>
+          <a:bodyPr wrap="square">
+            <a:spAutoFit/>
+          </a:bodyPr>
+          <a:lstStyle/>
+          <a:p>
+            <a:pPr algn="ctr"/>
+            <a:r>
+              <a:rPr sz="2000" b="0" i="1">
                 <a:solidFill>
                   <a:srgbClr val="FFFFFF"/>
                 </a:solidFill>
               </a:rPr>
-              <a:t>• −26% outcome gap · −45% teacher admin · localisation 12mo → 6wk</a:t>
-            </a:r>
-          </a:p>
-          <a:p>
-            <a:pPr/>
-            <a:r>
-              <a:rPr sz="1800" b="0">
-                <a:solidFill>
-                  <a:srgbClr val="FFFFFF"/>
-                </a:solidFill>
-              </a:rPr>
-              <a:t>• 100% GDPR Art. 8 · EU AI Act CE-marking before phase-3 exit</a:t>
-            </a:r>
-          </a:p>
-          <a:p>
-            <a:pPr/>
-            <a:r>
-              <a:rPr sz="1800" b="0">
-                <a:solidFill>
-                  <a:srgbClr val="FFFFFF"/>
-                </a:solidFill>
-              </a:rPr>
-              <a:t>• Live on Azure EU regions only — no transfer outside EU Data Boundary</a:t>
-            </a:r>
-          </a:p>
-        </p:txBody>
-      </p:sp>
-      <p:sp>
-        <p:nvSpPr>
-          <p:cNvPr id="5" name="Rounded Rectangle 4"/>
+              <a:t>teacher administrative time</a:t>
+            </a:r>
+          </a:p>
+        </p:txBody>
+      </p:sp>
+      <p:sp>
+        <p:nvSpPr>
+          <p:cNvPr id="17" name="Rounded Rectangle 16"/>
           <p:cNvSpPr/>
           <p:nvPr/>
         </p:nvSpPr>
         <p:spPr>
           <a:xfrm>
-            <a:off x="6216000" y="1400000"/>
-            <a:ext cx="5376000" cy="5098000"/>
+            <a:off x="6236000" y="4019000"/>
+            <a:ext cx="5356000" cy="2239000"/>
           </a:xfrm>
           <a:prstGeom prst="roundRect">
             <a:avLst/>
           </a:prstGeom>
           <a:solidFill>
-            <a:srgbClr val="122A4A"/>
+            <a:srgbClr val="1F6B3A"/>
           </a:solidFill>
-          <a:ln w="12700">
-            <a:solidFill>
-              <a:srgbClr val="2A4A78"/>
-            </a:solidFill>
+          <a:ln>
+            <a:noFill/>
           </a:ln>
-          <a:effectLst/>
         </p:spPr>
         <p:style>
           <a:lnRef idx="1">
@@ -23515,61 +23890,75 @@
           </a:fontRef>
         </p:style>
         <p:txBody>
-          <a:bodyPr rtlCol="0" anchor="t" wrap="square" lIns="120000" rIns="120000" tIns="80000" bIns="80000"/>
+          <a:bodyPr rtlCol="0" anchor="ctr"/>
           <a:lstStyle/>
+          <a:p/>
+        </p:txBody>
+      </p:sp>
+      <p:sp>
+        <p:nvSpPr>
+          <p:cNvPr id="18" name="TextBox 17"/>
+          <p:cNvSpPr txBox="1"/>
+          <p:nvPr/>
+        </p:nvSpPr>
+        <p:spPr>
+          <a:xfrm>
+            <a:off x="6236000" y="4219000"/>
+            <a:ext cx="5356000" cy="1119500"/>
+          </a:xfrm>
+          <a:prstGeom prst="rect">
+            <a:avLst/>
+          </a:prstGeom>
+          <a:noFill/>
+        </p:spPr>
+        <p:txBody>
+          <a:bodyPr wrap="square">
+            <a:spAutoFit/>
+          </a:bodyPr>
+          <a:lstStyle/>
           <a:p>
             <a:pPr algn="ctr"/>
             <a:r>
-              <a:rPr sz="1600" b="1">
-                <a:solidFill>
-                  <a:srgbClr val="F28C00"/>
-                </a:solidFill>
-              </a:rPr>
-              <a:t>WHAT IT TAKES</a:t>
-            </a:r>
-          </a:p>
-          <a:p>
-            <a:pPr/>
-            <a:r>
-              <a:rPr sz="1800" b="0">
+              <a:rPr sz="9600" b="1" i="0">
                 <a:solidFill>
                   <a:srgbClr val="FFFFFF"/>
                 </a:solidFill>
               </a:rPr>
-              <a:t>• 12-month, 5-phase programme; first market live month 8 (NL pilot)</a:t>
-            </a:r>
-          </a:p>
-          <a:p>
-            <a:pPr/>
-            <a:r>
-              <a:rPr sz="1800" b="0">
+              <a:t>100%</a:t>
+            </a:r>
+          </a:p>
+        </p:txBody>
+      </p:sp>
+      <p:sp>
+        <p:nvSpPr>
+          <p:cNvPr id="19" name="TextBox 18"/>
+          <p:cNvSpPr txBox="1"/>
+          <p:nvPr/>
+        </p:nvSpPr>
+        <p:spPr>
+          <a:xfrm>
+            <a:off x="6536000" y="5538500"/>
+            <a:ext cx="4756000" cy="619500"/>
+          </a:xfrm>
+          <a:prstGeom prst="rect">
+            <a:avLst/>
+          </a:prstGeom>
+          <a:noFill/>
+        </p:spPr>
+        <p:txBody>
+          <a:bodyPr wrap="square">
+            <a:spAutoFit/>
+          </a:bodyPr>
+          <a:lstStyle/>
+          <a:p>
+            <a:pPr algn="ctr"/>
+            <a:r>
+              <a:rPr sz="2000" b="0" i="1">
                 <a:solidFill>
                   <a:srgbClr val="FFFFFF"/>
                 </a:solidFill>
               </a:rPr>
-              <a:t>• ~€18–22M total programme cost; payback ≤ 24 months at 3-market scale</a:t>
-            </a:r>
-          </a:p>
-          <a:p>
-            <a:pPr/>
-            <a:r>
-              <a:rPr sz="1800" b="0">
-                <a:solidFill>
-                  <a:srgbClr val="FFFFFF"/>
-                </a:solidFill>
-              </a:rPr>
-              <a:t>• Teacher-in-the-loop on every AI decision — non-negotiable</a:t>
-            </a:r>
-          </a:p>
-          <a:p>
-            <a:pPr/>
-            <a:r>
-              <a:rPr sz="1800" b="0">
-                <a:solidFill>
-                  <a:srgbClr val="FFFFFF"/>
-                </a:solidFill>
-              </a:rPr>
-              <a:t>• Board ask: sign DPIA mandate, approve P0 budget, name the RAI Council chair</a:t>
+              <a:t>GDPR Art. 8 · AI Act CE-marked</a:t>
             </a:r>
           </a:p>
         </p:txBody>

</xml_diff>